<commit_message>
docs: W01 slides and EVALUATION.md sections 1-5 draft
Co-Authored-By: Claude Opus 5.5 <noreply@anthropic.com>
</commit_message>
<xml_diff>
--- a/docs/weekly/w01/w01.pptx
+++ b/docs/weekly/w01/w01.pptx
@@ -15,6 +15,23 @@
     <p:sldId id="263" r:id="rId9"/>
     <p:sldId id="264" r:id="rId10"/>
     <p:sldId id="265" r:id="rId11"/>
+    <p:sldId id="266" r:id="rId12"/>
+    <p:sldId id="267" r:id="rId13"/>
+    <p:sldId id="268" r:id="rId14"/>
+    <p:sldId id="269" r:id="rId15"/>
+    <p:sldId id="270" r:id="rId16"/>
+    <p:sldId id="271" r:id="rId17"/>
+    <p:sldId id="272" r:id="rId18"/>
+    <p:sldId id="273" r:id="rId19"/>
+    <p:sldId id="274" r:id="rId20"/>
+    <p:sldId id="275" r:id="rId21"/>
+    <p:sldId id="276" r:id="rId22"/>
+    <p:sldId id="277" r:id="rId23"/>
+    <p:sldId id="278" r:id="rId24"/>
+    <p:sldId id="279" r:id="rId25"/>
+    <p:sldId id="280" r:id="rId26"/>
+    <p:sldId id="281" r:id="rId27"/>
+    <p:sldId id="282" r:id="rId28"/>
   </p:sldIdLst>
   <p:sldSz cx="12192000" cy="6858000"/>
   <p:notesSz cx="6858000" cy="9144000"/>
@@ -3456,7 +3473,1626 @@
             </a:pPr>
             <a:r>
               <a:rPr/>
-              <a:t>Thank you!</a:t>
+              <a:t>Problem statement</a:t>
+            </a:r>
+          </a:p>
+        </p:txBody>
+      </p:sp>
+      <p:sp>
+        <p:nvSpPr>
+          <p:cNvPr id="3" name="Content Placeholder 2">
+            <a:extLst>
+              <a:ext uri="{FF2B5EF4-FFF2-40B4-BE49-F238E27FC236}">
+                <a16:creationId xmlns:a16="http://schemas.microsoft.com/office/drawing/2014/main" id="{CF466120-0A55-3491-F9FC-FA77E459C46D}"/>
+              </a:ext>
+            </a:extLst>
+          </p:cNvPr>
+          <p:cNvSpPr>
+            <a:spLocks noGrp="1"/>
+          </p:cNvSpPr>
+          <p:nvPr>
+            <p:ph idx="1"/>
+          </p:nvPr>
+        </p:nvSpPr>
+        <p:spPr/>
+        <p:txBody>
+          <a:bodyPr/>
+          <a:lstStyle/>
+          <a:p>
+            <a:pPr lvl="0" indent="0" marL="1270000">
+              <a:buNone/>
+            </a:pPr>
+            <a:r>
+              <a:rPr sz="2000"/>
+              <a:t>DTI 예측기(지도학습 모델이든 LLM 에이전트든)는 입력이 자기가 아는 범위를 벗어나도 신뢰도를 낮추지 않을 수 있다. 지금까지의 평가는 정확도를 난이도별로 나눠 보았을 뿐, 신뢰도와 기권이 그 난이도를 따라가는지는 재지 않아, 이 결함이 있는지 알 수 없었다.</a:t>
+            </a:r>
+          </a:p>
+          <a:p>
+            <a:pPr lvl="0" indent="0" marL="0">
+              <a:buNone/>
+            </a:pPr>
+            <a:r>
+              <a:rPr b="1"/>
+              <a:t>벤치마크의 질문은 하나입니다.</a:t>
+            </a:r>
+            <a:r>
+              <a:rPr/>
+              <a:t> 신뢰도, 또는 기권 결정이 사전에 정한 난이도 d(x)를 따라가는가?</a:t>
+            </a:r>
+          </a:p>
+          <a:p>
+            <a:pPr lvl="0"/>
+            <a:r>
+              <a:rPr/>
+              <a:t>“결함이 있다”가 아니라 “아무도 재지 않았다”고 씁니다. 결함의 직접 근거는 아직 없습니다.</a:t>
+            </a:r>
+          </a:p>
+          <a:p>
+            <a:pPr lvl="0"/>
+            <a:r>
+              <a:rPr/>
+              <a:t>정답을 보기 전에 정할 수 있는 난이도 좌표가 필요합니다. 다음 절에서 정의합니다.</a:t>
+            </a:r>
+          </a:p>
+        </p:txBody>
+      </p:sp>
+    </p:spTree>
+  </p:cSld>
+</p:sld>
+</file>
+
+<file path=ppt/slides/slide11.xml><?xml version="1.0" encoding="utf-8"?>
+<p:sld xmlns:a="http://schemas.openxmlformats.org/drawingml/2006/main" xmlns:r="http://schemas.openxmlformats.org/officeDocument/2006/relationships" xmlns:p="http://schemas.openxmlformats.org/presentationml/2006/main">
+  <p:cSld>
+    <p:spTree>
+      <p:nvGrpSpPr>
+        <p:cNvPr id="1" name=""/>
+        <p:cNvGrpSpPr/>
+        <p:nvPr/>
+      </p:nvGrpSpPr>
+      <p:grpSpPr>
+        <a:xfrm>
+          <a:off x="0" y="0"/>
+          <a:ext cx="0" cy="0"/>
+          <a:chOff x="0" y="0"/>
+          <a:chExt cx="0" cy="0"/>
+        </a:xfrm>
+      </p:grpSpPr>
+      <p:sp>
+        <p:nvSpPr>
+          <p:cNvPr id="2" name="Title 1">
+            <a:extLst>
+              <a:ext uri="{FF2B5EF4-FFF2-40B4-BE49-F238E27FC236}">
+                <a16:creationId xmlns:a16="http://schemas.microsoft.com/office/drawing/2014/main" id="{1A5592C5-AEA2-D627-F76B-35C7AD5ED253}"/>
+              </a:ext>
+            </a:extLst>
+          </p:cNvPr>
+          <p:cNvSpPr>
+            <a:spLocks noGrp="1"/>
+          </p:cNvSpPr>
+          <p:nvPr>
+            <p:ph type="title"/>
+          </p:nvPr>
+        </p:nvSpPr>
+        <p:spPr>
+          <a:xfrm>
+            <a:off x="839788" y="457200"/>
+            <a:ext cx="3932237" cy="1600200"/>
+          </a:xfrm>
+        </p:spPr>
+        <p:txBody>
+          <a:bodyPr/>
+          <a:lstStyle/>
+          <a:p>
+            <a:pPr lvl="0" indent="0" marL="0">
+              <a:buNone/>
+            </a:pPr>
+            <a:r>
+              <a:rPr/>
+              <a:t>근거는 어디까지 있나</a:t>
+            </a:r>
+          </a:p>
+        </p:txBody>
+      </p:sp>
+      <p:sp>
+        <p:nvSpPr>
+          <p:cNvPr id="4" name="Text Placeholder 3">
+            <a:extLst>
+              <a:ext uri="{FF2B5EF4-FFF2-40B4-BE49-F238E27FC236}">
+                <a16:creationId xmlns:a16="http://schemas.microsoft.com/office/drawing/2014/main" id="{67344C6D-89EA-24AC-1FF8-F95BD1763393}"/>
+              </a:ext>
+            </a:extLst>
+          </p:cNvPr>
+          <p:cNvSpPr>
+            <a:spLocks noGrp="1"/>
+          </p:cNvSpPr>
+          <p:nvPr>
+            <p:ph idx="2" sz="half" type="body"/>
+          </p:nvPr>
+        </p:nvSpPr>
+        <p:spPr/>
+        <p:txBody>
+          <a:bodyPr/>
+          <a:lstStyle/>
+          <a:p>
+            <a:pPr lvl="0" indent="0" marL="0">
+              <a:buNone/>
+            </a:pPr>
+            <a:r>
+              <a:rPr/>
+              <a:t>선행 문헌(Medea, Biomni, ToolUniverse, DrugAgent, LAB-Bench, BixBench) 중 AURC나 risk-coverage로 신뢰도의 순위를 잰 곳은 없습니다.</a:t>
+            </a:r>
+          </a:p>
+        </p:txBody>
+      </p:sp>
+      <p:graphicFrame>
+        <p:nvGraphicFramePr>
+          <p:cNvPr id="6" name="Content Placeholder 5"/>
+          <p:cNvGraphicFramePr>
+            <a:graphicFrameLocks noGrp="1"/>
+          </p:cNvGraphicFramePr>
+          <p:nvPr>
+            <p:ph idx="1"/>
+          </p:nvPr>
+        </p:nvGraphicFramePr>
+        <p:xfrm>
+          <a:off x="5181600" y="977900"/>
+          <a:ext cx="6172200" cy="4864100"/>
+        </p:xfrm>
+        <a:graphic>
+          <a:graphicData uri="http://schemas.openxmlformats.org/drawingml/2006/table">
+            <a:tbl>
+              <a:tblPr firstRow="1" bandRow="1">
+                <a:tableStyleId>{5C22544A-7EE6-4342-B048-85BDC9FD1C3A}</a:tableStyleId>
+              </a:tblPr>
+              <a:tblGrid>
+                <a:gridCol w="3086100"/>
+                <a:gridCol w="3086100"/>
+              </a:tblGrid>
+              <a:tr h="0">
+                <a:tc>
+                  <a:txBody>
+                    <a:bodyPr/>
+                    <a:lstStyle/>
+                    <a:p>
+                      <a:pPr lvl="0" indent="0" marL="0">
+                        <a:buNone/>
+                      </a:pPr>
+                      <a:r>
+                        <a:rPr/>
+                        <a:t>근거</a:t>
+                      </a:r>
+                    </a:p>
+                  </a:txBody>
+                  <a:tcPr/>
+                </a:tc>
+                <a:tc>
+                  <a:txBody>
+                    <a:bodyPr/>
+                    <a:lstStyle/>
+                    <a:p>
+                      <a:pPr lvl="0" indent="0" marL="0">
+                        <a:buNone/>
+                      </a:pPr>
+                      <a:r>
+                        <a:rPr/>
+                        <a:t>내용</a:t>
+                      </a:r>
+                    </a:p>
+                  </a:txBody>
+                  <a:tcPr/>
+                </a:tc>
+              </a:tr>
+              <a:tr h="0">
+                <a:tc>
+                  <a:txBody>
+                    <a:bodyPr/>
+                    <a:lstStyle/>
+                    <a:p>
+                      <a:pPr lvl="0" indent="0" marL="0">
+                        <a:buNone/>
+                      </a:pPr>
+                      <a:r>
+                        <a:rPr/>
+                        <a:t>LAB-Bench</a:t>
+                      </a:r>
+                    </a:p>
+                  </a:txBody>
+                </a:tc>
+                <a:tc>
+                  <a:txBody>
+                    <a:bodyPr/>
+                    <a:lstStyle/>
+                    <a:p>
+                      <a:pPr lvl="0" indent="0" marL="0">
+                        <a:buNone/>
+                      </a:pPr>
+                      <a:r>
+                        <a:rPr/>
+                        <a:t>Gemini 1.5 Pro와 GPT-4-turbo는 coverage가 낮아도 precision이 나아지지 않았습니다. 기권이 틀릴 문항에 몰리지 않았다는 신호로 읽지만, 이 해석은 우리 것입니다</a:t>
+                      </a:r>
+                    </a:p>
+                  </a:txBody>
+                </a:tc>
+              </a:tr>
+              <a:tr h="0">
+                <a:tc>
+                  <a:txBody>
+                    <a:bodyPr/>
+                    <a:lstStyle/>
+                    <a:p>
+                      <a:pPr lvl="0" indent="0" marL="0">
+                        <a:buNone/>
+                      </a:pPr>
+                      <a:r>
+                        <a:rPr/>
+                        <a:t>DrugAgent (kinase)</a:t>
+                      </a:r>
+                    </a:p>
+                  </a:txBody>
+                </a:tc>
+                <a:tc>
+                  <a:txBody>
+                    <a:bodyPr/>
+                    <a:lstStyle/>
+                    <a:p>
+                      <a:pPr lvl="0" indent="0" marL="0">
+                        <a:buNone/>
+                      </a:pPr>
+                      <a:r>
+                        <a:rPr/>
+                        <a:t>쌍 단위 논문이 0편인 구간에서 ML+KG 기준선 대비 우위가 사라졌습니다. 그 구간에서 신뢰도도 떨어졌는지는 보고하지 않았습니다</a:t>
+                      </a:r>
+                    </a:p>
+                  </a:txBody>
+                </a:tc>
+              </a:tr>
+              <a:tr h="0">
+                <a:tc>
+                  <a:txBody>
+                    <a:bodyPr/>
+                    <a:lstStyle/>
+                    <a:p>
+                      <a:pPr lvl="0" indent="0" marL="0">
+                        <a:buNone/>
+                      </a:pPr>
+                      <a:r>
+                        <a:rPr/>
+                        <a:t>기권 채점</a:t>
+                      </a:r>
+                    </a:p>
+                  </a:txBody>
+                </a:tc>
+                <a:tc>
+                  <a:txBody>
+                    <a:bodyPr/>
+                    <a:lstStyle/>
+                    <a:p>
+                      <a:pPr lvl="0" indent="0" marL="0">
+                        <a:buNone/>
+                      </a:pPr>
+                      <a:r>
+                        <a:rPr/>
+                        <a:t>ToolUniverse는 기권을 오답으로, Medea와 BixBench는 분모 제외로 셉니다. LAB-Bench는 둘 다 보고합니다</a:t>
+                      </a:r>
+                    </a:p>
+                  </a:txBody>
+                </a:tc>
+              </a:tr>
+              <a:tr h="0">
+                <a:tc>
+                  <a:txBody>
+                    <a:bodyPr/>
+                    <a:lstStyle/>
+                    <a:p>
+                      <a:pPr lvl="0" indent="0" marL="0">
+                        <a:buNone/>
+                      </a:pPr>
+                      <a:r>
+                        <a:rPr/>
+                        <a:t>BixBench (MCQ)</a:t>
+                      </a:r>
+                    </a:p>
+                  </a:txBody>
+                </a:tc>
+                <a:tc>
+                  <a:txBody>
+                    <a:bodyPr/>
+                    <a:lstStyle/>
+                    <a:p>
+                      <a:pPr lvl="0" indent="0" marL="0">
+                        <a:buNone/>
+                      </a:pPr>
+                      <a:r>
+                        <a:rPr/>
+                        <a:t>기권 보기를 주면 성능이 random에 가까워지고, 빼면 random보다 높아집니다</a:t>
+                      </a:r>
+                    </a:p>
+                  </a:txBody>
+                </a:tc>
+              </a:tr>
+            </a:tbl>
+          </a:graphicData>
+        </a:graphic>
+      </p:graphicFrame>
+    </p:spTree>
+  </p:cSld>
+</p:sld>
+</file>
+
+<file path=ppt/slides/slide12.xml><?xml version="1.0" encoding="utf-8"?>
+<p:sld xmlns:a="http://schemas.openxmlformats.org/drawingml/2006/main" xmlns:r="http://schemas.openxmlformats.org/officeDocument/2006/relationships" xmlns:p="http://schemas.openxmlformats.org/presentationml/2006/main">
+  <p:cSld>
+    <p:spTree>
+      <p:nvGrpSpPr>
+        <p:cNvPr id="1" name=""/>
+        <p:cNvGrpSpPr/>
+        <p:nvPr/>
+      </p:nvGrpSpPr>
+      <p:grpSpPr>
+        <a:xfrm>
+          <a:off x="0" y="0"/>
+          <a:ext cx="0" cy="0"/>
+          <a:chOff x="0" y="0"/>
+          <a:chExt cx="0" cy="0"/>
+        </a:xfrm>
+      </p:grpSpPr>
+      <p:sp>
+        <p:nvSpPr>
+          <p:cNvPr id="2" name="Title 1">
+            <a:extLst>
+              <a:ext uri="{FF2B5EF4-FFF2-40B4-BE49-F238E27FC236}">
+                <a16:creationId xmlns:a16="http://schemas.microsoft.com/office/drawing/2014/main" id="{60DC0D0C-9A5E-1DC8-B48D-462EC113779B}"/>
+              </a:ext>
+            </a:extLst>
+          </p:cNvPr>
+          <p:cNvSpPr>
+            <a:spLocks noGrp="1"/>
+          </p:cNvSpPr>
+          <p:nvPr>
+            <p:ph type="title"/>
+          </p:nvPr>
+        </p:nvSpPr>
+        <p:spPr>
+          <a:xfrm>
+            <a:off x="831850" y="1709738"/>
+            <a:ext cx="10515600" cy="2852737"/>
+          </a:xfrm>
+        </p:spPr>
+        <p:txBody>
+          <a:bodyPr/>
+          <a:lstStyle/>
+          <a:p>
+            <a:pPr lvl="0" indent="0" marL="0">
+              <a:buNone/>
+            </a:pPr>
+            <a:r>
+              <a:rPr/>
+              <a:t>난이도 정의</a:t>
+            </a:r>
+          </a:p>
+        </p:txBody>
+      </p:sp>
+    </p:spTree>
+  </p:cSld>
+</p:sld>
+</file>
+
+<file path=ppt/slides/slide13.xml><?xml version="1.0" encoding="utf-8"?>
+<p:sld xmlns:a="http://schemas.openxmlformats.org/drawingml/2006/main" xmlns:r="http://schemas.openxmlformats.org/officeDocument/2006/relationships" xmlns:p="http://schemas.openxmlformats.org/presentationml/2006/main">
+  <p:cSld>
+    <p:spTree>
+      <p:nvGrpSpPr>
+        <p:cNvPr id="1" name=""/>
+        <p:cNvGrpSpPr/>
+        <p:nvPr/>
+      </p:nvGrpSpPr>
+      <p:grpSpPr>
+        <a:xfrm>
+          <a:off x="0" y="0"/>
+          <a:ext cx="0" cy="0"/>
+          <a:chOff x="0" y="0"/>
+          <a:chExt cx="0" cy="0"/>
+        </a:xfrm>
+      </p:grpSpPr>
+      <p:sp>
+        <p:nvSpPr>
+          <p:cNvPr id="2" name="Title 1">
+            <a:extLst>
+              <a:ext uri="{FF2B5EF4-FFF2-40B4-BE49-F238E27FC236}">
+                <a16:creationId xmlns:a16="http://schemas.microsoft.com/office/drawing/2014/main" id="{C9CE818D-09AE-4CD2-3C65-237AD773CD9F}"/>
+              </a:ext>
+            </a:extLst>
+          </p:cNvPr>
+          <p:cNvSpPr>
+            <a:spLocks noGrp="1"/>
+          </p:cNvSpPr>
+          <p:nvPr>
+            <p:ph type="title"/>
+          </p:nvPr>
+        </p:nvSpPr>
+        <p:spPr/>
+        <p:txBody>
+          <a:bodyPr/>
+          <a:lstStyle/>
+          <a:p>
+            <a:pPr lvl="0" indent="0" marL="0">
+              <a:buNone/>
+            </a:pPr>
+            <a:r>
+              <a:rPr/>
+              <a:t>난이도는 무엇에 대한 난이도인가</a:t>
+            </a:r>
+          </a:p>
+        </p:txBody>
+      </p:sp>
+      <p:sp>
+        <p:nvSpPr>
+          <p:cNvPr id="3" name="Content Placeholder 2">
+            <a:extLst>
+              <a:ext uri="{FF2B5EF4-FFF2-40B4-BE49-F238E27FC236}">
+                <a16:creationId xmlns:a16="http://schemas.microsoft.com/office/drawing/2014/main" id="{CF466120-0A55-3491-F9FC-FA77E459C46D}"/>
+              </a:ext>
+            </a:extLst>
+          </p:cNvPr>
+          <p:cNvSpPr>
+            <a:spLocks noGrp="1"/>
+          </p:cNvSpPr>
+          <p:nvPr>
+            <p:ph idx="1"/>
+          </p:nvPr>
+        </p:nvSpPr>
+        <p:spPr/>
+        <p:txBody>
+          <a:bodyPr/>
+          <a:lstStyle/>
+          <a:p>
+            <a:pPr lvl="0"/>
+            <a:r>
+              <a:rPr/>
+              <a:t>난이도는 (서열, SMILES) 자체의 속성이 아닙니다. </a:t>
+            </a:r>
+            <a:r>
+              <a:rPr b="1"/>
+              <a:t>기준 코퍼스</a:t>
+            </a:r>
+            <a:r>
+              <a:rPr/>
+              <a:t>에 대한 상대적 속성입니다.</a:t>
+            </a:r>
+          </a:p>
+          <a:p>
+            <a:pPr lvl="0"/>
+            <a:r>
+              <a:rPr/>
+              <a:t>조건 A의 기준은 BindingDB 학습 split입니다. LLM 에이전트의 기준은 사전학습 데이터와 도구가 닿는 모든 DB입니다.</a:t>
+            </a:r>
+          </a:p>
+          <a:p>
+            <a:pPr lvl="0"/>
+            <a:r>
+              <a:rPr/>
+              <a:t>예를 들어 A의 학습셋에 없는 타겟도, ChEMBL을 검색하는 에이전트에게는 단순 조회일 수 있습니다.</a:t>
+            </a:r>
+          </a:p>
+          <a:p>
+            <a:pPr lvl="0"/>
+            <a:r>
+              <a:rPr/>
+              <a:t>그래서 축마다 기준 코퍼스와 유효한 조건을 함께 적습니다.</a:t>
+            </a:r>
+          </a:p>
+        </p:txBody>
+      </p:sp>
+    </p:spTree>
+  </p:cSld>
+</p:sld>
+</file>
+
+<file path=ppt/slides/slide14.xml><?xml version="1.0" encoding="utf-8"?>
+<p:sld xmlns:a="http://schemas.openxmlformats.org/drawingml/2006/main" xmlns:r="http://schemas.openxmlformats.org/officeDocument/2006/relationships" xmlns:p="http://schemas.openxmlformats.org/presentationml/2006/main">
+  <p:cSld>
+    <p:spTree>
+      <p:nvGrpSpPr>
+        <p:cNvPr id="1" name=""/>
+        <p:cNvGrpSpPr/>
+        <p:nvPr/>
+      </p:nvGrpSpPr>
+      <p:grpSpPr>
+        <a:xfrm>
+          <a:off x="0" y="0"/>
+          <a:ext cx="0" cy="0"/>
+          <a:chOff x="0" y="0"/>
+          <a:chExt cx="0" cy="0"/>
+        </a:xfrm>
+      </p:grpSpPr>
+      <p:sp>
+        <p:nvSpPr>
+          <p:cNvPr id="2" name="Title 1">
+            <a:extLst>
+              <a:ext uri="{FF2B5EF4-FFF2-40B4-BE49-F238E27FC236}">
+                <a16:creationId xmlns:a16="http://schemas.microsoft.com/office/drawing/2014/main" id="{C9CE818D-09AE-4CD2-3C65-237AD773CD9F}"/>
+              </a:ext>
+            </a:extLst>
+          </p:cNvPr>
+          <p:cNvSpPr>
+            <a:spLocks noGrp="1"/>
+          </p:cNvSpPr>
+          <p:nvPr>
+            <p:ph type="title"/>
+          </p:nvPr>
+        </p:nvSpPr>
+        <p:spPr/>
+        <p:txBody>
+          <a:bodyPr/>
+          <a:lstStyle/>
+          <a:p>
+            <a:pPr lvl="0" indent="0" marL="0">
+              <a:buNone/>
+            </a:pPr>
+            <a:r>
+              <a:rPr/>
+              <a:t>난이도 좌표: 네 묶음</a:t>
+            </a:r>
+          </a:p>
+        </p:txBody>
+      </p:sp>
+      <p:graphicFrame>
+        <p:nvGraphicFramePr>
+          <p:cNvPr id="6" name="Content Placeholder 5"/>
+          <p:cNvGraphicFramePr>
+            <a:graphicFrameLocks noGrp="1"/>
+          </p:cNvGraphicFramePr>
+          <p:nvPr>
+            <p:ph idx="1"/>
+          </p:nvPr>
+        </p:nvGraphicFramePr>
+        <p:xfrm>
+          <a:off x="838200" y="1816100"/>
+          <a:ext cx="10515600" cy="4343400"/>
+        </p:xfrm>
+        <a:graphic>
+          <a:graphicData uri="http://schemas.openxmlformats.org/drawingml/2006/table">
+            <a:tbl>
+              <a:tblPr firstRow="1" bandRow="1">
+                <a:tableStyleId>{5C22544A-7EE6-4342-B048-85BDC9FD1C3A}</a:tableStyleId>
+              </a:tblPr>
+              <a:tblGrid>
+                <a:gridCol w="3505200"/>
+                <a:gridCol w="3505200"/>
+                <a:gridCol w="3505200"/>
+              </a:tblGrid>
+              <a:tr h="0">
+                <a:tc>
+                  <a:txBody>
+                    <a:bodyPr/>
+                    <a:lstStyle/>
+                    <a:p>
+                      <a:pPr lvl="0" indent="0" marL="0">
+                        <a:buNone/>
+                      </a:pPr>
+                      <a:r>
+                        <a:rPr/>
+                        <a:t>묶음</a:t>
+                      </a:r>
+                    </a:p>
+                  </a:txBody>
+                  <a:tcPr/>
+                </a:tc>
+                <a:tc>
+                  <a:txBody>
+                    <a:bodyPr/>
+                    <a:lstStyle/>
+                    <a:p>
+                      <a:pPr lvl="0" indent="0" marL="0">
+                        <a:buNone/>
+                      </a:pPr>
+                      <a:r>
+                        <a:rPr/>
+                        <a:t>축</a:t>
+                      </a:r>
+                    </a:p>
+                  </a:txBody>
+                  <a:tcPr/>
+                </a:tc>
+                <a:tc>
+                  <a:txBody>
+                    <a:bodyPr/>
+                    <a:lstStyle/>
+                    <a:p>
+                      <a:pPr lvl="0" indent="0" marL="0">
+                        <a:buNone/>
+                      </a:pPr>
+                      <a:r>
+                        <a:rPr/>
+                        <a:t>유효한 조건</a:t>
+                      </a:r>
+                    </a:p>
+                  </a:txBody>
+                  <a:tcPr/>
+                </a:tc>
+              </a:tr>
+              <a:tr h="0">
+                <a:tc>
+                  <a:txBody>
+                    <a:bodyPr/>
+                    <a:lstStyle/>
+                    <a:p>
+                      <a:pPr lvl="0" indent="0" marL="0">
+                        <a:buNone/>
+                      </a:pPr>
+                      <a:r>
+                        <a:rPr/>
+                        <a:t>보편 난이도</a:t>
+                      </a:r>
+                    </a:p>
+                  </a:txBody>
+                </a:tc>
+                <a:tc>
+                  <a:txBody>
+                    <a:bodyPr/>
+                    <a:lstStyle/>
+                    <a:p>
+                      <a:pPr lvl="0" indent="0" marL="0">
+                        <a:buNone/>
+                      </a:pPr>
+                      <a:r>
+                        <a:rPr/>
+                        <a:t>타겟 성숙도 (Pharos TDL), 문헌 가용성 (새로 추가)</a:t>
+                      </a:r>
+                    </a:p>
+                  </a:txBody>
+                </a:tc>
+                <a:tc>
+                  <a:txBody>
+                    <a:bodyPr/>
+                    <a:lstStyle/>
+                    <a:p>
+                      <a:pPr lvl="0" indent="0" marL="0">
+                        <a:buNone/>
+                      </a:pPr>
+                      <a:r>
+                        <a:rPr/>
+                        <a:t>전 조건</a:t>
+                      </a:r>
+                    </a:p>
+                  </a:txBody>
+                </a:tc>
+              </a:tr>
+              <a:tr h="0">
+                <a:tc>
+                  <a:txBody>
+                    <a:bodyPr/>
+                    <a:lstStyle/>
+                    <a:p>
+                      <a:pPr lvl="0" indent="0" marL="0">
+                        <a:buNone/>
+                      </a:pPr>
+                      <a:r>
+                        <a:rPr/>
+                        <a:t>학습 split 기준</a:t>
+                      </a:r>
+                    </a:p>
+                  </a:txBody>
+                </a:tc>
+                <a:tc>
+                  <a:txBody>
+                    <a:bodyPr/>
+                    <a:lstStyle/>
+                    <a:p>
+                      <a:pPr lvl="0" indent="0" marL="0">
+                        <a:buNone/>
+                      </a:pPr>
+                      <a:r>
+                        <a:rPr/>
+                        <a:t>리간드 신규성 (Tanimoto, Murcko scaffold), 타겟 신규성 (서열 identity)</a:t>
+                      </a:r>
+                    </a:p>
+                  </a:txBody>
+                </a:tc>
+                <a:tc>
+                  <a:txBody>
+                    <a:bodyPr/>
+                    <a:lstStyle/>
+                    <a:p>
+                      <a:pPr lvl="0" indent="0" marL="0">
+                        <a:buNone/>
+                      </a:pPr>
+                      <a:r>
+                        <a:rPr/>
+                        <a:t>A에 직접. 나머지 조건에 통하는지는 검증 전 가정</a:t>
+                      </a:r>
+                    </a:p>
+                  </a:txBody>
+                </a:tc>
+              </a:tr>
+              <a:tr h="0">
+                <a:tc>
+                  <a:txBody>
+                    <a:bodyPr/>
+                    <a:lstStyle/>
+                    <a:p>
+                      <a:pPr lvl="0" indent="0" marL="0">
+                        <a:buNone/>
+                      </a:pPr>
+                      <a:r>
+                        <a:rPr/>
+                        <a:t>구조 (조건부)</a:t>
+                      </a:r>
+                    </a:p>
+                  </a:txBody>
+                </a:tc>
+                <a:tc>
+                  <a:txBody>
+                    <a:bodyPr/>
+                    <a:lstStyle/>
+                    <a:p>
+                      <a:pPr lvl="0" indent="0" marL="0">
+                        <a:buNone/>
+                      </a:pPr>
+                      <a:r>
+                        <a:rPr/>
+                        <a:t>pocket pLDDT/PAE, 실험 구조 유무</a:t>
+                      </a:r>
+                    </a:p>
+                  </a:txBody>
+                </a:tc>
+                <a:tc>
+                  <a:txBody>
+                    <a:bodyPr/>
+                    <a:lstStyle/>
+                    <a:p>
+                      <a:pPr lvl="0" indent="0" marL="0">
+                        <a:buNone/>
+                      </a:pPr>
+                      <a:r>
+                        <a:rPr/>
+                        <a:t>구조를 쓰는 A, F. 티켓 04 실측 후 확정</a:t>
+                      </a:r>
+                    </a:p>
+                  </a:txBody>
+                </a:tc>
+              </a:tr>
+              <a:tr h="0">
+                <a:tc>
+                  <a:txBody>
+                    <a:bodyPr/>
+                    <a:lstStyle/>
+                    <a:p>
+                      <a:pPr lvl="0" indent="0" marL="0">
+                        <a:buNone/>
+                      </a:pPr>
+                      <a:r>
+                        <a:rPr/>
+                        <a:t>Boltz-2 (조건부)</a:t>
+                      </a:r>
+                    </a:p>
+                  </a:txBody>
+                </a:tc>
+                <a:tc>
+                  <a:txBody>
+                    <a:bodyPr/>
+                    <a:lstStyle/>
+                    <a:p>
+                      <a:pPr lvl="0" indent="0" marL="0">
+                        <a:buNone/>
+                      </a:pPr>
+                      <a:r>
+                        <a:rPr/>
+                        <a:t>리간드 크기 (heavy atom 56개 초과), cofactor가 필요한 타겟</a:t>
+                      </a:r>
+                    </a:p>
+                  </a:txBody>
+                </a:tc>
+                <a:tc>
+                  <a:txBody>
+                    <a:bodyPr/>
+                    <a:lstStyle/>
+                    <a:p>
+                      <a:pPr lvl="0" indent="0" marL="0">
+                        <a:buNone/>
+                      </a:pPr>
+                      <a:r>
+                        <a:rPr/>
+                        <a:t>F</a:t>
+                      </a:r>
+                    </a:p>
+                  </a:txBody>
+                </a:tc>
+              </a:tr>
+              <a:tr h="0">
+                <a:tc>
+                  <a:txBody>
+                    <a:bodyPr/>
+                    <a:lstStyle/>
+                    <a:p>
+                      <a:pPr lvl="0" indent="0" marL="0">
+                        <a:buNone/>
+                      </a:pPr>
+                      <a:r>
+                        <a:rPr/>
+                        <a:t>유효성 플래그</a:t>
+                      </a:r>
+                    </a:p>
+                  </a:txBody>
+                </a:tc>
+                <a:tc>
+                  <a:txBody>
+                    <a:bodyPr/>
+                    <a:lstStyle/>
+                    <a:p>
+                      <a:pPr lvl="0" indent="0" marL="0">
+                        <a:buNone/>
+                      </a:pPr>
+                      <a:r>
+                        <a:rPr/>
+                        <a:t>오염 축 (원측정 발행일), 실측값 직접 조회 여부</a:t>
+                      </a:r>
+                    </a:p>
+                  </a:txBody>
+                </a:tc>
+                <a:tc>
+                  <a:txBody>
+                    <a:bodyPr/>
+                    <a:lstStyle/>
+                    <a:p>
+                      <a:pPr lvl="0" indent="0" marL="0">
+                        <a:buNone/>
+                      </a:pPr>
+                      <a:r>
+                        <a:rPr/>
+                        <a:t>난이도가 아닙니다. 쿼리가 “예측”인지를 판정합니다</a:t>
+                      </a:r>
+                    </a:p>
+                  </a:txBody>
+                </a:tc>
+              </a:tr>
+            </a:tbl>
+          </a:graphicData>
+        </a:graphic>
+      </p:graphicFrame>
+    </p:spTree>
+  </p:cSld>
+</p:sld>
+</file>
+
+<file path=ppt/slides/slide15.xml><?xml version="1.0" encoding="utf-8"?>
+<p:sld xmlns:a="http://schemas.openxmlformats.org/drawingml/2006/main" xmlns:r="http://schemas.openxmlformats.org/officeDocument/2006/relationships" xmlns:p="http://schemas.openxmlformats.org/presentationml/2006/main">
+  <p:cSld>
+    <p:spTree>
+      <p:nvGrpSpPr>
+        <p:cNvPr id="1" name=""/>
+        <p:cNvGrpSpPr/>
+        <p:nvPr/>
+      </p:nvGrpSpPr>
+      <p:grpSpPr>
+        <a:xfrm>
+          <a:off x="0" y="0"/>
+          <a:ext cx="0" cy="0"/>
+          <a:chOff x="0" y="0"/>
+          <a:chExt cx="0" cy="0"/>
+        </a:xfrm>
+      </p:grpSpPr>
+      <p:sp>
+        <p:nvSpPr>
+          <p:cNvPr id="3" name="Content Placeholder 2">
+            <a:extLst>
+              <a:ext uri="{FF2B5EF4-FFF2-40B4-BE49-F238E27FC236}">
+                <a16:creationId xmlns:a16="http://schemas.microsoft.com/office/drawing/2014/main" id="{CF466120-0A55-3491-F9FC-FA77E459C46D}"/>
+              </a:ext>
+            </a:extLst>
+          </p:cNvPr>
+          <p:cNvSpPr>
+            <a:spLocks noGrp="1"/>
+          </p:cNvSpPr>
+          <p:nvPr>
+            <p:ph idx="1"/>
+          </p:nvPr>
+        </p:nvSpPr>
+        <p:spPr/>
+        <p:txBody>
+          <a:bodyPr/>
+          <a:lstStyle/>
+          <a:p>
+            <a:pPr lvl="0" indent="0" marL="0">
+              <a:buNone/>
+            </a:pPr>
+            <a:r>
+              <a:rPr/>
+              <a:t>난이도 좌표는 모델에 입력하지 않습니다. 결과를 층화해 분석할 때만 씁니다.</a:t>
+            </a:r>
+          </a:p>
+        </p:txBody>
+      </p:sp>
+    </p:spTree>
+  </p:cSld>
+</p:sld>
+</file>
+
+<file path=ppt/slides/slide16.xml><?xml version="1.0" encoding="utf-8"?>
+<p:sld xmlns:a="http://schemas.openxmlformats.org/drawingml/2006/main" xmlns:r="http://schemas.openxmlformats.org/officeDocument/2006/relationships" xmlns:p="http://schemas.openxmlformats.org/presentationml/2006/main">
+  <p:cSld>
+    <p:spTree>
+      <p:nvGrpSpPr>
+        <p:cNvPr id="1" name=""/>
+        <p:cNvGrpSpPr/>
+        <p:nvPr/>
+      </p:nvGrpSpPr>
+      <p:grpSpPr>
+        <a:xfrm>
+          <a:off x="0" y="0"/>
+          <a:ext cx="0" cy="0"/>
+          <a:chOff x="0" y="0"/>
+          <a:chExt cx="0" cy="0"/>
+        </a:xfrm>
+      </p:grpSpPr>
+      <p:sp>
+        <p:nvSpPr>
+          <p:cNvPr id="2" name="Title 1">
+            <a:extLst>
+              <a:ext uri="{FF2B5EF4-FFF2-40B4-BE49-F238E27FC236}">
+                <a16:creationId xmlns:a16="http://schemas.microsoft.com/office/drawing/2014/main" id="{C9CE818D-09AE-4CD2-3C65-237AD773CD9F}"/>
+              </a:ext>
+            </a:extLst>
+          </p:cNvPr>
+          <p:cNvSpPr>
+            <a:spLocks noGrp="1"/>
+          </p:cNvSpPr>
+          <p:nvPr>
+            <p:ph type="title"/>
+          </p:nvPr>
+        </p:nvSpPr>
+        <p:spPr/>
+        <p:txBody>
+          <a:bodyPr/>
+          <a:lstStyle/>
+          <a:p>
+            <a:pPr lvl="0" indent="0" marL="0">
+              <a:buNone/>
+            </a:pPr>
+            <a:r>
+              <a:rPr/>
+              <a:t>난이도가 아닌 것: 라벨 노이즈</a:t>
+            </a:r>
+          </a:p>
+        </p:txBody>
+      </p:sp>
+      <p:sp>
+        <p:nvSpPr>
+          <p:cNvPr id="3" name="Content Placeholder 2">
+            <a:extLst>
+              <a:ext uri="{FF2B5EF4-FFF2-40B4-BE49-F238E27FC236}">
+                <a16:creationId xmlns:a16="http://schemas.microsoft.com/office/drawing/2014/main" id="{CF466120-0A55-3491-F9FC-FA77E459C46D}"/>
+              </a:ext>
+            </a:extLst>
+          </p:cNvPr>
+          <p:cNvSpPr>
+            <a:spLocks noGrp="1"/>
+          </p:cNvSpPr>
+          <p:nvPr>
+            <p:ph idx="1"/>
+          </p:nvPr>
+        </p:nvSpPr>
+        <p:spPr/>
+        <p:txBody>
+          <a:bodyPr/>
+          <a:lstStyle/>
+          <a:p>
+            <a:pPr lvl="0"/>
+            <a:r>
+              <a:rPr/>
+              <a:t>“이 scaffold는 처음 본다”는 예측기가 알아차릴 수 있습니다.</a:t>
+            </a:r>
+          </a:p>
+          <a:p>
+            <a:pPr lvl="0"/>
+            <a:r>
+              <a:rPr/>
+              <a:t>“이 IC50은 특이한 조건에서 쟀다”, “5.9와 6.1의 경계다”는 알아차릴 수 없습니다. 입력이 아니라 정답의 속성입니다.</a:t>
+            </a:r>
+          </a:p>
+          <a:p>
+            <a:pPr lvl="0"/>
+            <a:r>
+              <a:rPr/>
+              <a:t>그래서 난이도 축에서 빼고, 평가셋 </a:t>
+            </a:r>
+            <a:r>
+              <a:rPr b="1"/>
+              <a:t>포함 기준</a:t>
+            </a:r>
+            <a:r>
+              <a:rPr/>
+              <a:t>으로 처리합니다.</a:t>
+            </a:r>
+          </a:p>
+          <a:p>
+            <a:pPr lvl="1"/>
+            <a:r>
+              <a:rPr/>
+              <a:t>1 µM 경계를 걸치는 검열값, 반복 측정, 회색 구간(5.5-6.5 제외 권고), degrader</a:t>
+            </a:r>
+          </a:p>
+          <a:p>
+            <a:pPr lvl="0"/>
+            <a:r>
+              <a:rPr/>
+              <a:t>각 축이 실제 난이도를 대변하는지는 W06 baseline 오차가 축을 따라 커지는지로 검증합니다(티켓 05).</a:t>
+            </a:r>
+          </a:p>
+        </p:txBody>
+      </p:sp>
+    </p:spTree>
+  </p:cSld>
+</p:sld>
+</file>
+
+<file path=ppt/slides/slide17.xml><?xml version="1.0" encoding="utf-8"?>
+<p:sld xmlns:a="http://schemas.openxmlformats.org/drawingml/2006/main" xmlns:r="http://schemas.openxmlformats.org/officeDocument/2006/relationships" xmlns:p="http://schemas.openxmlformats.org/presentationml/2006/main">
+  <p:cSld>
+    <p:spTree>
+      <p:nvGrpSpPr>
+        <p:cNvPr id="1" name=""/>
+        <p:cNvGrpSpPr/>
+        <p:nvPr/>
+      </p:nvGrpSpPr>
+      <p:grpSpPr>
+        <a:xfrm>
+          <a:off x="0" y="0"/>
+          <a:ext cx="0" cy="0"/>
+          <a:chOff x="0" y="0"/>
+          <a:chExt cx="0" cy="0"/>
+        </a:xfrm>
+      </p:grpSpPr>
+      <p:sp>
+        <p:nvSpPr>
+          <p:cNvPr id="2" name="Title 1">
+            <a:extLst>
+              <a:ext uri="{FF2B5EF4-FFF2-40B4-BE49-F238E27FC236}">
+                <a16:creationId xmlns:a16="http://schemas.microsoft.com/office/drawing/2014/main" id="{60DC0D0C-9A5E-1DC8-B48D-462EC113779B}"/>
+              </a:ext>
+            </a:extLst>
+          </p:cNvPr>
+          <p:cNvSpPr>
+            <a:spLocks noGrp="1"/>
+          </p:cNvSpPr>
+          <p:nvPr>
+            <p:ph type="title"/>
+          </p:nvPr>
+        </p:nvSpPr>
+        <p:spPr>
+          <a:xfrm>
+            <a:off x="831850" y="1709738"/>
+            <a:ext cx="10515600" cy="2852737"/>
+          </a:xfrm>
+        </p:spPr>
+        <p:txBody>
+          <a:bodyPr/>
+          <a:lstStyle/>
+          <a:p>
+            <a:pPr lvl="0" indent="0" marL="0">
+              <a:buNone/>
+            </a:pPr>
+            <a:r>
+              <a:rPr/>
+              <a:t>INPUT &amp; OUTPUT</a:t>
+            </a:r>
+          </a:p>
+        </p:txBody>
+      </p:sp>
+    </p:spTree>
+  </p:cSld>
+</p:sld>
+</file>
+
+<file path=ppt/slides/slide18.xml><?xml version="1.0" encoding="utf-8"?>
+<p:sld xmlns:a="http://schemas.openxmlformats.org/drawingml/2006/main" xmlns:r="http://schemas.openxmlformats.org/officeDocument/2006/relationships" xmlns:p="http://schemas.openxmlformats.org/presentationml/2006/main">
+  <p:cSld>
+    <p:spTree>
+      <p:nvGrpSpPr>
+        <p:cNvPr id="1" name=""/>
+        <p:cNvGrpSpPr/>
+        <p:nvPr/>
+      </p:nvGrpSpPr>
+      <p:grpSpPr>
+        <a:xfrm>
+          <a:off x="0" y="0"/>
+          <a:ext cx="0" cy="0"/>
+          <a:chOff x="0" y="0"/>
+          <a:chExt cx="0" cy="0"/>
+        </a:xfrm>
+      </p:grpSpPr>
+      <p:sp>
+        <p:nvSpPr>
+          <p:cNvPr id="2" name="Title 1">
+            <a:extLst>
+              <a:ext uri="{FF2B5EF4-FFF2-40B4-BE49-F238E27FC236}">
+                <a16:creationId xmlns:a16="http://schemas.microsoft.com/office/drawing/2014/main" id="{C9CE818D-09AE-4CD2-3C65-237AD773CD9F}"/>
+              </a:ext>
+            </a:extLst>
+          </p:cNvPr>
+          <p:cNvSpPr>
+            <a:spLocks noGrp="1"/>
+          </p:cNvSpPr>
+          <p:nvPr>
+            <p:ph type="title"/>
+          </p:nvPr>
+        </p:nvSpPr>
+        <p:spPr/>
+        <p:txBody>
+          <a:bodyPr/>
+          <a:lstStyle/>
+          <a:p>
+            <a:pPr lvl="0" indent="0" marL="0">
+              <a:buNone/>
+            </a:pPr>
+            <a:r>
+              <a:rPr/>
+              <a:t>모든 조건 공통</a:t>
+            </a:r>
+          </a:p>
+        </p:txBody>
+      </p:sp>
+      <p:graphicFrame>
+        <p:nvGraphicFramePr>
+          <p:cNvPr id="6" name="Content Placeholder 5"/>
+          <p:cNvGraphicFramePr>
+            <a:graphicFrameLocks noGrp="1"/>
+          </p:cNvGraphicFramePr>
+          <p:nvPr>
+            <p:ph idx="1"/>
+          </p:nvPr>
+        </p:nvGraphicFramePr>
+        <p:xfrm>
+          <a:off x="838200" y="1816100"/>
+          <a:ext cx="10515600" cy="4343400"/>
+        </p:xfrm>
+        <a:graphic>
+          <a:graphicData uri="http://schemas.openxmlformats.org/drawingml/2006/table">
+            <a:tbl>
+              <a:tblPr firstRow="1" bandRow="1">
+                <a:tableStyleId>{5C22544A-7EE6-4342-B048-85BDC9FD1C3A}</a:tableStyleId>
+              </a:tblPr>
+              <a:tblGrid>
+                <a:gridCol w="5257800"/>
+                <a:gridCol w="5257800"/>
+              </a:tblGrid>
+              <a:tr h="0">
+                <a:tc>
+                  <a:txBody>
+                    <a:bodyPr/>
+                    <a:lstStyle/>
+                    <a:p>
+                      <a:pPr lvl="0" indent="0" marL="0">
+                        <a:buNone/>
+                      </a:pPr>
+                      <a:r>
+                        <a:rPr/>
+                        <a:t>항목</a:t>
+                      </a:r>
+                    </a:p>
+                  </a:txBody>
+                  <a:tcPr/>
+                </a:tc>
+                <a:tc>
+                  <a:txBody>
+                    <a:bodyPr/>
+                    <a:lstStyle/>
+                    <a:p>
+                      <a:pPr lvl="0" indent="0" marL="0">
+                        <a:buNone/>
+                      </a:pPr>
+                      <a:r>
+                        <a:rPr/>
+                        <a:t>정의</a:t>
+                      </a:r>
+                    </a:p>
+                  </a:txBody>
+                  <a:tcPr/>
+                </a:tc>
+              </a:tr>
+              <a:tr h="0">
+                <a:tc>
+                  <a:txBody>
+                    <a:bodyPr/>
+                    <a:lstStyle/>
+                    <a:p>
+                      <a:pPr lvl="0" indent="0" marL="0">
+                        <a:buNone/>
+                      </a:pPr>
+                      <a:r>
+                        <a:rPr/>
+                        <a:t>입력</a:t>
+                      </a:r>
+                    </a:p>
+                  </a:txBody>
+                </a:tc>
+                <a:tc>
+                  <a:txBody>
+                    <a:bodyPr/>
+                    <a:lstStyle/>
+                    <a:p>
+                      <a:pPr lvl="0" indent="0" marL="0">
+                        <a:buNone/>
+                      </a:pPr>
+                      <a:r>
+                        <a:rPr/>
+                        <a:t>단백질 서열 + 화합물 SMILES만. 타겟 식별자(UniProt ID 등)는 주지 않습니다</a:t>
+                      </a:r>
+                    </a:p>
+                  </a:txBody>
+                </a:tc>
+              </a:tr>
+              <a:tr h="0">
+                <a:tc>
+                  <a:txBody>
+                    <a:bodyPr/>
+                    <a:lstStyle/>
+                    <a:p>
+                      <a:pPr lvl="0" indent="0" marL="0">
+                        <a:buNone/>
+                      </a:pPr>
+                      <a:r>
+                        <a:rPr/>
+                        <a:t>주 결정</a:t>
+                      </a:r>
+                    </a:p>
+                  </a:txBody>
+                </a:tc>
+                <a:tc>
+                  <a:txBody>
+                    <a:bodyPr/>
+                    <a:lstStyle/>
+                    <a:p>
+                      <a:pPr lvl="0" indent="0" marL="0">
+                        <a:buNone/>
+                      </a:pPr>
+                      <a:r>
+                        <a:rPr/>
+                        <a:t>결합 여부 </a:t>
+                      </a:r>
+                      <a:r>
+                        <a:rPr>
+                          <a:latin typeface="Courier"/>
+                        </a:rPr>
+                        <a:t>binds</a:t>
+                      </a:r>
+                      <a:r>
+                        <a:rPr/>
+                        <a:t>. pAffinity ≥ 6.0 (Kd / Ki / IC50 ≤ 1 µM)이면 true</a:t>
+                      </a:r>
+                    </a:p>
+                  </a:txBody>
+                </a:tc>
+              </a:tr>
+              <a:tr h="0">
+                <a:tc>
+                  <a:txBody>
+                    <a:bodyPr/>
+                    <a:lstStyle/>
+                    <a:p>
+                      <a:pPr lvl="0" indent="0" marL="0">
+                        <a:buNone/>
+                      </a:pPr>
+                      <a:r>
+                        <a:rPr/>
+                        <a:t>출력</a:t>
+                      </a:r>
+                    </a:p>
+                  </a:txBody>
+                </a:tc>
+                <a:tc>
+                  <a:txBody>
+                    <a:bodyPr/>
+                    <a:lstStyle/>
+                    <a:p>
+                      <a:pPr lvl="0" indent="0" marL="0">
+                        <a:buNone/>
+                      </a:pPr>
+                      <a:r>
+                        <a:rPr>
+                          <a:latin typeface="Courier"/>
+                        </a:rPr>
+                        <a:t>binds</a:t>
+                      </a:r>
+                      <a:r>
+                        <a:rPr/>
+                        <a:t>와 신뢰도, 또는 기권</a:t>
+                      </a:r>
+                    </a:p>
+                  </a:txBody>
+                </a:tc>
+              </a:tr>
+              <a:tr h="0">
+                <a:tc>
+                  <a:txBody>
+                    <a:bodyPr/>
+                    <a:lstStyle/>
+                    <a:p>
+                      <a:pPr lvl="0" indent="0" marL="0">
+                        <a:buNone/>
+                      </a:pPr>
+                      <a:r>
+                        <a:rPr/>
+                        <a:t>주 지표</a:t>
+                      </a:r>
+                    </a:p>
+                  </a:txBody>
+                </a:tc>
+                <a:tc>
+                  <a:txBody>
+                    <a:bodyPr/>
+                    <a:lstStyle/>
+                    <a:p>
+                      <a:pPr lvl="0" indent="0" marL="0">
+                        <a:buNone/>
+                      </a:pPr>
+                      <a:r>
+                        <a:rPr/>
+                        <a:t>AURC, coverage 80%에서의 selective accuracy</a:t>
+                      </a:r>
+                    </a:p>
+                  </a:txBody>
+                </a:tc>
+              </a:tr>
+              <a:tr h="0">
+                <a:tc>
+                  <a:txBody>
+                    <a:bodyPr/>
+                    <a:lstStyle/>
+                    <a:p>
+                      <a:pPr lvl="0" indent="0" marL="0">
+                        <a:buNone/>
+                      </a:pPr>
+                      <a:r>
+                        <a:rPr/>
+                        <a:t>보조</a:t>
+                      </a:r>
+                    </a:p>
+                  </a:txBody>
+                </a:tc>
+                <a:tc>
+                  <a:txBody>
+                    <a:bodyPr/>
+                    <a:lstStyle/>
+                    <a:p>
+                      <a:pPr lvl="0" indent="0" marL="0">
+                        <a:buNone/>
+                      </a:pPr>
+                      <a:r>
+                        <a:rPr/>
+                        <a:t>회귀(pAffinity). Ki와 Kd 정확값 부분집합에서만 보고</a:t>
+                      </a:r>
+                    </a:p>
+                  </a:txBody>
+                </a:tc>
+              </a:tr>
+              <a:tr h="0">
+                <a:tc>
+                  <a:txBody>
+                    <a:bodyPr/>
+                    <a:lstStyle/>
+                    <a:p>
+                      <a:pPr lvl="0" indent="0" marL="0">
+                        <a:buNone/>
+                      </a:pPr>
+                      <a:r>
+                        <a:rPr/>
+                        <a:t>데이터</a:t>
+                      </a:r>
+                    </a:p>
+                  </a:txBody>
+                </a:tc>
+                <a:tc>
+                  <a:txBody>
+                    <a:bodyPr/>
+                    <a:lstStyle/>
+                    <a:p>
+                      <a:pPr lvl="0" indent="0" marL="0">
+                        <a:buNone/>
+                      </a:pPr>
+                      <a:r>
+                        <a:rPr/>
+                        <a:t>BindingDB </a:t>
+                      </a:r>
+                      <a:r>
+                        <a:rPr>
+                          <a:latin typeface="Courier"/>
+                        </a:rPr>
+                        <a:t>202610</a:t>
+                      </a:r>
+                      <a:r>
+                        <a:rPr/>
+                        <a:t> 스냅샷의 CC BY 4.0 부분 (1,436,782행)</a:t>
+                      </a:r>
+                    </a:p>
+                  </a:txBody>
+                </a:tc>
+              </a:tr>
+              <a:tr h="0">
+                <a:tc>
+                  <a:txBody>
+                    <a:bodyPr/>
+                    <a:lstStyle/>
+                    <a:p>
+                      <a:pPr lvl="0" indent="0" marL="0">
+                        <a:buNone/>
+                      </a:pPr>
+                      <a:r>
+                        <a:rPr/>
+                        <a:t>음성</a:t>
+                      </a:r>
+                    </a:p>
+                  </a:txBody>
+                </a:tc>
+                <a:tc>
+                  <a:txBody>
+                    <a:bodyPr/>
+                    <a:lstStyle/>
+                    <a:p>
+                      <a:pPr lvl="0" indent="0" marL="0">
+                        <a:buNone/>
+                      </a:pPr>
+                      <a:r>
+                        <a:rPr/>
+                        <a:t>검열값 </a:t>
+                      </a:r>
+                      <a:r>
+                        <a:rPr>
+                          <a:latin typeface="Courier"/>
+                        </a:rPr>
+                        <a:t>&gt;10 µM</a:t>
+                      </a:r>
+                      <a:r>
+                        <a:rPr/>
+                        <a:t> + 측정된 약한 결합 (pAffinity &lt; 6). decoy 합성은 쓰지 않습니다</a:t>
+                      </a:r>
+                    </a:p>
+                  </a:txBody>
+                </a:tc>
+              </a:tr>
+            </a:tbl>
+          </a:graphicData>
+        </a:graphic>
+      </p:graphicFrame>
+    </p:spTree>
+  </p:cSld>
+</p:sld>
+</file>
+
+<file path=ppt/slides/slide19.xml><?xml version="1.0" encoding="utf-8"?>
+<p:sld xmlns:a="http://schemas.openxmlformats.org/drawingml/2006/main" xmlns:r="http://schemas.openxmlformats.org/officeDocument/2006/relationships" xmlns:p="http://schemas.openxmlformats.org/presentationml/2006/main">
+  <p:cSld>
+    <p:spTree>
+      <p:nvGrpSpPr>
+        <p:cNvPr id="1" name=""/>
+        <p:cNvGrpSpPr/>
+        <p:nvPr/>
+      </p:nvGrpSpPr>
+      <p:grpSpPr>
+        <a:xfrm>
+          <a:off x="0" y="0"/>
+          <a:ext cx="0" cy="0"/>
+          <a:chOff x="0" y="0"/>
+          <a:chExt cx="0" cy="0"/>
+        </a:xfrm>
+      </p:grpSpPr>
+      <p:sp>
+        <p:nvSpPr>
+          <p:cNvPr id="2" name="Title 1">
+            <a:extLst>
+              <a:ext uri="{FF2B5EF4-FFF2-40B4-BE49-F238E27FC236}">
+                <a16:creationId xmlns:a16="http://schemas.microsoft.com/office/drawing/2014/main" id="{C9CE818D-09AE-4CD2-3C65-237AD773CD9F}"/>
+              </a:ext>
+            </a:extLst>
+          </p:cNvPr>
+          <p:cNvSpPr>
+            <a:spLocks noGrp="1"/>
+          </p:cNvSpPr>
+          <p:nvPr>
+            <p:ph type="title"/>
+          </p:nvPr>
+        </p:nvSpPr>
+        <p:spPr/>
+        <p:txBody>
+          <a:bodyPr/>
+          <a:lstStyle/>
+          <a:p>
+            <a:pPr lvl="0" indent="0" marL="0">
+              <a:buNone/>
+            </a:pPr>
+            <a:r>
+              <a:rPr/>
+              <a:t>트랙 간 흐름</a:t>
+            </a:r>
+          </a:p>
+        </p:txBody>
+      </p:sp>
+      <p:sp>
+        <p:nvSpPr>
+          <p:cNvPr id="3" name="Content Placeholder 2">
+            <a:extLst>
+              <a:ext uri="{FF2B5EF4-FFF2-40B4-BE49-F238E27FC236}">
+                <a16:creationId xmlns:a16="http://schemas.microsoft.com/office/drawing/2014/main" id="{CF466120-0A55-3491-F9FC-FA77E459C46D}"/>
+              </a:ext>
+            </a:extLst>
+          </p:cNvPr>
+          <p:cNvSpPr>
+            <a:spLocks noGrp="1"/>
+          </p:cNvSpPr>
+          <p:nvPr>
+            <p:ph idx="1"/>
+          </p:nvPr>
+        </p:nvSpPr>
+        <p:spPr/>
+        <p:txBody>
+          <a:bodyPr/>
+          <a:lstStyle/>
+          <a:p>
+            <a:pPr lvl="0" indent="-457200" marL="457200">
+              <a:buAutoNum type="arabicPeriod"/>
+            </a:pPr>
+            <a:r>
+              <a:rPr b="1"/>
+              <a:t>큐레이션 트랙</a:t>
+            </a:r>
+            <a:r>
+              <a:rPr/>
+              <a:t>이 평가 쿼리와 난이도 좌표를 만듭니다 (</a:t>
+            </a:r>
+            <a:r>
+              <a:rPr>
+                <a:latin typeface="Courier"/>
+              </a:rPr>
+              <a:t>results/benchmark/</a:t>
+            </a:r>
+            <a:r>
+              <a:rPr/>
+              <a:t>).</a:t>
+            </a:r>
+          </a:p>
+          <a:p>
+            <a:pPr lvl="0" indent="-457200" marL="457200">
+              <a:buAutoNum type="arabicPeriod"/>
+            </a:pPr>
+            <a:r>
+              <a:rPr b="1"/>
+              <a:t>ML과 보정 트랙</a:t>
+            </a:r>
+            <a:r>
+              <a:rPr/>
+              <a:t>이 같은 쿼리로 조건 A와 F를 돌리고, conformal 절차를 구현합니다.</a:t>
+            </a:r>
+          </a:p>
+          <a:p>
+            <a:pPr lvl="0" indent="-457200" marL="457200">
+              <a:buAutoNum type="arabicPeriod"/>
+            </a:pPr>
+            <a:r>
+              <a:rPr b="1"/>
+              <a:t>에이전트 트랙</a:t>
+            </a:r>
+            <a:r>
+              <a:rPr/>
+              <a:t>이 같은 쿼리로 조건 B, C, D를 돌리고 신뢰도 로그를 남깁니다.</a:t>
+            </a:r>
+          </a:p>
+          <a:p>
+            <a:pPr lvl="0" indent="-457200" marL="457200">
+              <a:buAutoNum type="arabicPeriod"/>
+            </a:pPr>
+            <a:r>
+              <a:rPr/>
+              <a:t>조건 E는 에이전트 신뢰도 로그에 ML 트랙의 conformal 절차를 씌운 것입니다.</a:t>
+            </a:r>
+          </a:p>
+          <a:p>
+            <a:pPr lvl="0" indent="-457200" marL="457200">
+              <a:buAutoNum type="arabicPeriod"/>
+            </a:pPr>
+            <a:r>
+              <a:rPr/>
+              <a:t>모든 조건의 출력을 난이도 좌표로 층화해 비교합니다.</a:t>
             </a:r>
           </a:p>
         </p:txBody>
@@ -3616,7 +5252,7 @@
 </p:sld>
 </file>
 
-<file path=ppt/slides/slide3.xml><?xml version="1.0" encoding="utf-8"?>
+<file path=ppt/slides/slide20.xml><?xml version="1.0" encoding="utf-8"?>
 <p:sld xmlns:a="http://schemas.openxmlformats.org/drawingml/2006/main" xmlns:r="http://schemas.openxmlformats.org/officeDocument/2006/relationships" xmlns:p="http://schemas.openxmlformats.org/presentationml/2006/main">
   <p:cSld>
     <p:spTree>
@@ -3659,53 +5295,314 @@
             </a:pPr>
             <a:r>
               <a:rPr/>
-              <a:t>스터디 룰 소개</a:t>
-            </a:r>
-          </a:p>
-        </p:txBody>
-      </p:sp>
-      <p:sp>
-        <p:nvSpPr>
-          <p:cNvPr id="3" name="Content Placeholder 2">
-            <a:extLst>
-              <a:ext uri="{FF2B5EF4-FFF2-40B4-BE49-F238E27FC236}">
-                <a16:creationId xmlns:a16="http://schemas.microsoft.com/office/drawing/2014/main" id="{CF466120-0A55-3491-F9FC-FA77E459C46D}"/>
-              </a:ext>
-            </a:extLst>
-          </p:cNvPr>
-          <p:cNvSpPr>
-            <a:spLocks noGrp="1"/>
-          </p:cNvSpPr>
+              <a:t>큐레이션 트랙</a:t>
+            </a:r>
+          </a:p>
+        </p:txBody>
+      </p:sp>
+      <p:graphicFrame>
+        <p:nvGraphicFramePr>
+          <p:cNvPr id="6" name="Content Placeholder 5"/>
+          <p:cNvGraphicFramePr>
+            <a:graphicFrameLocks noGrp="1"/>
+          </p:cNvGraphicFramePr>
           <p:nvPr>
             <p:ph idx="1"/>
           </p:nvPr>
-        </p:nvSpPr>
-        <p:spPr/>
-        <p:txBody>
-          <a:bodyPr/>
-          <a:lstStyle/>
-          <a:p>
-            <a:pPr lvl="0"/>
-            <a:r>
-              <a:rPr/>
-              <a:t>2회 이상 무단 불참 시 제명</a:t>
-            </a:r>
-          </a:p>
-          <a:p>
-            <a:pPr lvl="0"/>
-            <a:r>
-              <a:rPr/>
-              <a:t>카메라 on 필수 (얼굴이 보이지 않아도 돼)</a:t>
-            </a:r>
-          </a:p>
-        </p:txBody>
-      </p:sp>
+        </p:nvGraphicFramePr>
+        <p:xfrm>
+          <a:off x="838200" y="1816100"/>
+          <a:ext cx="10515600" cy="4343400"/>
+        </p:xfrm>
+        <a:graphic>
+          <a:graphicData uri="http://schemas.openxmlformats.org/drawingml/2006/table">
+            <a:tbl>
+              <a:tblPr firstRow="1" bandRow="1">
+                <a:tableStyleId>{5C22544A-7EE6-4342-B048-85BDC9FD1C3A}</a:tableStyleId>
+              </a:tblPr>
+              <a:tblGrid>
+                <a:gridCol w="3505200"/>
+                <a:gridCol w="3505200"/>
+                <a:gridCol w="3505200"/>
+              </a:tblGrid>
+              <a:tr h="0">
+                <a:tc>
+                  <a:txBody>
+                    <a:bodyPr/>
+                    <a:lstStyle/>
+                    <a:p>
+                      <a:pPr lvl="0" indent="0" marL="0">
+                        <a:buNone/>
+                      </a:pPr>
+                      <a:r>
+                        <a:rPr/>
+                        <a:t>단계</a:t>
+                      </a:r>
+                    </a:p>
+                  </a:txBody>
+                  <a:tcPr/>
+                </a:tc>
+                <a:tc>
+                  <a:txBody>
+                    <a:bodyPr/>
+                    <a:lstStyle/>
+                    <a:p>
+                      <a:pPr lvl="0" indent="0" marL="0">
+                        <a:buNone/>
+                      </a:pPr>
+                      <a:r>
+                        <a:rPr/>
+                        <a:t>입력</a:t>
+                      </a:r>
+                    </a:p>
+                  </a:txBody>
+                  <a:tcPr/>
+                </a:tc>
+                <a:tc>
+                  <a:txBody>
+                    <a:bodyPr/>
+                    <a:lstStyle/>
+                    <a:p>
+                      <a:pPr lvl="0" indent="0" marL="0">
+                        <a:buNone/>
+                      </a:pPr>
+                      <a:r>
+                        <a:rPr/>
+                        <a:t>출력</a:t>
+                      </a:r>
+                    </a:p>
+                  </a:txBody>
+                  <a:tcPr/>
+                </a:tc>
+              </a:tr>
+              <a:tr h="0">
+                <a:tc>
+                  <a:txBody>
+                    <a:bodyPr/>
+                    <a:lstStyle/>
+                    <a:p>
+                      <a:pPr lvl="0" indent="0" marL="0">
+                        <a:buNone/>
+                      </a:pPr>
+                      <a:r>
+                        <a:rPr/>
+                        <a:t>쿼리 선정</a:t>
+                      </a:r>
+                    </a:p>
+                  </a:txBody>
+                </a:tc>
+                <a:tc>
+                  <a:txBody>
+                    <a:bodyPr/>
+                    <a:lstStyle/>
+                    <a:p>
+                      <a:pPr lvl="0" indent="0" marL="0">
+                        <a:buNone/>
+                      </a:pPr>
+                      <a:r>
+                        <a:rPr/>
+                        <a:t>BindingDB </a:t>
+                      </a:r>
+                      <a:r>
+                        <a:rPr>
+                          <a:latin typeface="Courier"/>
+                        </a:rPr>
+                        <a:t>202610</a:t>
+                      </a:r>
+                      <a:r>
+                        <a:rPr/>
+                        <a:t> CC BY 부분 (Articles + Patents)</a:t>
+                      </a:r>
+                    </a:p>
+                  </a:txBody>
+                </a:tc>
+                <a:tc>
+                  <a:txBody>
+                    <a:bodyPr/>
+                    <a:lstStyle/>
+                    <a:p>
+                      <a:pPr lvl="0" indent="0" marL="0">
+                        <a:buNone/>
+                      </a:pPr>
+                      <a:r>
+                        <a:rPr/>
+                        <a:t>평가 쿼리 60-100개 (서열, SMILES, 정답 </a:t>
+                      </a:r>
+                      <a:r>
+                        <a:rPr>
+                          <a:latin typeface="Courier"/>
+                        </a:rPr>
+                        <a:t>binds</a:t>
+                      </a:r>
+                      <a:r>
+                        <a:rPr/>
+                        <a:t>, 측정 종류, 출처)</a:t>
+                      </a:r>
+                    </a:p>
+                  </a:txBody>
+                </a:tc>
+              </a:tr>
+              <a:tr h="0">
+                <a:tc>
+                  <a:txBody>
+                    <a:bodyPr/>
+                    <a:lstStyle/>
+                    <a:p>
+                      <a:pPr lvl="0" indent="0" marL="0">
+                        <a:buNone/>
+                      </a:pPr>
+                      <a:r>
+                        <a:rPr/>
+                        <a:t>포함 기준</a:t>
+                      </a:r>
+                    </a:p>
+                  </a:txBody>
+                </a:tc>
+                <a:tc>
+                  <a:txBody>
+                    <a:bodyPr/>
+                    <a:lstStyle/>
+                    <a:p>
+                      <a:pPr lvl="0" indent="0" marL="0">
+                        <a:buNone/>
+                      </a:pPr>
+                      <a:r>
+                        <a:rPr/>
+                        <a:t>측정 메타데이터 (부등호, 반복 측정, 리간드 크기 등)</a:t>
+                      </a:r>
+                    </a:p>
+                  </a:txBody>
+                </a:tc>
+                <a:tc>
+                  <a:txBody>
+                    <a:bodyPr/>
+                    <a:lstStyle/>
+                    <a:p>
+                      <a:pPr lvl="0" indent="0" marL="0">
+                        <a:buNone/>
+                      </a:pPr>
+                      <a:r>
+                        <a:rPr/>
+                        <a:t>제외 및 플래그 기록</a:t>
+                      </a:r>
+                    </a:p>
+                  </a:txBody>
+                </a:tc>
+              </a:tr>
+              <a:tr h="0">
+                <a:tc>
+                  <a:txBody>
+                    <a:bodyPr/>
+                    <a:lstStyle/>
+                    <a:p>
+                      <a:pPr lvl="0" indent="0" marL="0">
+                        <a:buNone/>
+                      </a:pPr>
+                      <a:r>
+                        <a:rPr/>
+                        <a:t>좌표 계산</a:t>
+                      </a:r>
+                    </a:p>
+                  </a:txBody>
+                </a:tc>
+                <a:tc>
+                  <a:txBody>
+                    <a:bodyPr/>
+                    <a:lstStyle/>
+                    <a:p>
+                      <a:pPr lvl="0" indent="0" marL="0">
+                        <a:buNone/>
+                      </a:pPr>
+                      <a:r>
+                        <a:rPr/>
+                        <a:t>쿼리, A의 학습 split, Pharos, AlphaFold DB, PDB/SIFTS, 발행일</a:t>
+                      </a:r>
+                    </a:p>
+                  </a:txBody>
+                </a:tc>
+                <a:tc>
+                  <a:txBody>
+                    <a:bodyPr/>
+                    <a:lstStyle/>
+                    <a:p>
+                      <a:pPr lvl="0" indent="0" marL="0">
+                        <a:buNone/>
+                      </a:pPr>
+                      <a:r>
+                        <a:rPr/>
+                        <a:t>쿼리별 난이도 좌표와 유효성 플래그</a:t>
+                      </a:r>
+                    </a:p>
+                  </a:txBody>
+                </a:tc>
+              </a:tr>
+              <a:tr h="0">
+                <a:tc>
+                  <a:txBody>
+                    <a:bodyPr/>
+                    <a:lstStyle/>
+                    <a:p>
+                      <a:pPr lvl="0" indent="0" marL="0">
+                        <a:buNone/>
+                      </a:pPr>
+                      <a:r>
+                        <a:rPr/>
+                        <a:t>교차 검증</a:t>
+                      </a:r>
+                    </a:p>
+                  </a:txBody>
+                </a:tc>
+                <a:tc>
+                  <a:txBody>
+                    <a:bodyPr/>
+                    <a:lstStyle/>
+                    <a:p>
+                      <a:pPr lvl="0" indent="0" marL="0">
+                        <a:buNone/>
+                      </a:pPr>
+                      <a:r>
+                        <a:rPr/>
+                        <a:t>쿼리 초안</a:t>
+                      </a:r>
+                    </a:p>
+                  </a:txBody>
+                </a:tc>
+                <a:tc>
+                  <a:txBody>
+                    <a:bodyPr/>
+                    <a:lstStyle/>
+                    <a:p>
+                      <a:pPr lvl="0" indent="0" marL="0">
+                        <a:buNone/>
+                      </a:pPr>
+                      <a:r>
+                        <a:rPr/>
+                        <a:t>2인 검증 기록, </a:t>
+                      </a:r>
+                      <a:r>
+                        <a:rPr>
+                          <a:latin typeface="Courier"/>
+                        </a:rPr>
+                        <a:t>results/benchmark/</a:t>
+                      </a:r>
+                      <a:r>
+                        <a:rPr/>
+                        <a:t> 확정본</a:t>
+                      </a:r>
+                    </a:p>
+                  </a:txBody>
+                </a:tc>
+              </a:tr>
+            </a:tbl>
+          </a:graphicData>
+        </a:graphic>
+      </p:graphicFrame>
     </p:spTree>
   </p:cSld>
 </p:sld>
 </file>
 
-<file path=ppt/slides/slide4.xml><?xml version="1.0" encoding="utf-8"?>
+<file path=ppt/slides/slide21.xml><?xml version="1.0" encoding="utf-8"?>
 <p:sld xmlns:a="http://schemas.openxmlformats.org/drawingml/2006/main" xmlns:r="http://schemas.openxmlformats.org/officeDocument/2006/relationships" xmlns:p="http://schemas.openxmlformats.org/presentationml/2006/main">
   <p:cSld>
     <p:spTree>
@@ -3727,7 +5624,7 @@
           <p:cNvPr id="2" name="Title 1">
             <a:extLst>
               <a:ext uri="{FF2B5EF4-FFF2-40B4-BE49-F238E27FC236}">
-                <a16:creationId xmlns:a16="http://schemas.microsoft.com/office/drawing/2014/main" id="{60DC0D0C-9A5E-1DC8-B48D-462EC113779B}"/>
+                <a16:creationId xmlns:a16="http://schemas.microsoft.com/office/drawing/2014/main" id="{C9CE818D-09AE-4CD2-3C65-237AD773CD9F}"/>
               </a:ext>
             </a:extLst>
           </p:cNvPr>
@@ -3738,12 +5635,7 @@
             <p:ph type="title"/>
           </p:nvPr>
         </p:nvSpPr>
-        <p:spPr>
-          <a:xfrm>
-            <a:off x="831850" y="1709738"/>
-            <a:ext cx="10515600" cy="2852737"/>
-          </a:xfrm>
-        </p:spPr>
+        <p:spPr/>
         <p:txBody>
           <a:bodyPr/>
           <a:lstStyle/>
@@ -3753,17 +5645,269 @@
             </a:pPr>
             <a:r>
               <a:rPr/>
-              <a:t>Ice breaking</a:t>
-            </a:r>
-          </a:p>
-        </p:txBody>
-      </p:sp>
+              <a:t>ML과 보정 트랙</a:t>
+            </a:r>
+          </a:p>
+        </p:txBody>
+      </p:sp>
+      <p:graphicFrame>
+        <p:nvGraphicFramePr>
+          <p:cNvPr id="6" name="Content Placeholder 5"/>
+          <p:cNvGraphicFramePr>
+            <a:graphicFrameLocks noGrp="1"/>
+          </p:cNvGraphicFramePr>
+          <p:nvPr>
+            <p:ph idx="1"/>
+          </p:nvPr>
+        </p:nvGraphicFramePr>
+        <p:xfrm>
+          <a:off x="838200" y="1816100"/>
+          <a:ext cx="10515600" cy="4343400"/>
+        </p:xfrm>
+        <a:graphic>
+          <a:graphicData uri="http://schemas.openxmlformats.org/drawingml/2006/table">
+            <a:tbl>
+              <a:tblPr firstRow="1" bandRow="1">
+                <a:tableStyleId>{5C22544A-7EE6-4342-B048-85BDC9FD1C3A}</a:tableStyleId>
+              </a:tblPr>
+              <a:tblGrid>
+                <a:gridCol w="3505200"/>
+                <a:gridCol w="3505200"/>
+                <a:gridCol w="3505200"/>
+              </a:tblGrid>
+              <a:tr h="0">
+                <a:tc>
+                  <a:txBody>
+                    <a:bodyPr/>
+                    <a:lstStyle/>
+                    <a:p>
+                      <a:pPr lvl="0" indent="0" marL="0">
+                        <a:buNone/>
+                      </a:pPr>
+                      <a:r>
+                        <a:rPr/>
+                        <a:t>조건</a:t>
+                      </a:r>
+                    </a:p>
+                  </a:txBody>
+                  <a:tcPr/>
+                </a:tc>
+                <a:tc>
+                  <a:txBody>
+                    <a:bodyPr/>
+                    <a:lstStyle/>
+                    <a:p>
+                      <a:pPr lvl="0" indent="0" marL="0">
+                        <a:buNone/>
+                      </a:pPr>
+                      <a:r>
+                        <a:rPr/>
+                        <a:t>입력</a:t>
+                      </a:r>
+                    </a:p>
+                  </a:txBody>
+                  <a:tcPr/>
+                </a:tc>
+                <a:tc>
+                  <a:txBody>
+                    <a:bodyPr/>
+                    <a:lstStyle/>
+                    <a:p>
+                      <a:pPr lvl="0" indent="0" marL="0">
+                        <a:buNone/>
+                      </a:pPr>
+                      <a:r>
+                        <a:rPr/>
+                        <a:t>출력</a:t>
+                      </a:r>
+                    </a:p>
+                  </a:txBody>
+                  <a:tcPr/>
+                </a:tc>
+              </a:tr>
+              <a:tr h="0">
+                <a:tc>
+                  <a:txBody>
+                    <a:bodyPr/>
+                    <a:lstStyle/>
+                    <a:p>
+                      <a:pPr lvl="0" indent="0" marL="0">
+                        <a:buNone/>
+                      </a:pPr>
+                      <a:r>
+                        <a:rPr/>
+                        <a:t>A. 보정된 baseline</a:t>
+                      </a:r>
+                    </a:p>
+                  </a:txBody>
+                </a:tc>
+                <a:tc>
+                  <a:txBody>
+                    <a:bodyPr/>
+                    <a:lstStyle/>
+                    <a:p>
+                      <a:pPr lvl="0" indent="0" marL="0">
+                        <a:buNone/>
+                      </a:pPr>
+                      <a:r>
+                        <a:rPr/>
+                        <a:t>ESM-2 단백질 임베딩, Morgan fingerprint, AlphaFold DB pocket feature, 학습 split</a:t>
+                      </a:r>
+                    </a:p>
+                  </a:txBody>
+                </a:tc>
+                <a:tc>
+                  <a:txBody>
+                    <a:bodyPr/>
+                    <a:lstStyle/>
+                    <a:p>
+                      <a:pPr lvl="0" indent="0" marL="0">
+                        <a:buNone/>
+                      </a:pPr>
+                      <a:r>
+                        <a:rPr>
+                          <a:latin typeface="Courier"/>
+                        </a:rPr>
+                        <a:t>binds</a:t>
+                      </a:r>
+                      <a:r>
+                        <a:rPr/>
+                        <a:t> 확률, conformal 예측 집합 (</a:t>
+                      </a:r>
+                      <a:r>
+                        <a:rPr>
+                          <a:latin typeface="Courier"/>
+                        </a:rPr>
+                        <a:t>{binds, not binds}</a:t>
+                      </a:r>
+                      <a:r>
+                        <a:rPr/>
+                        <a:t>이면 기권)</a:t>
+                      </a:r>
+                    </a:p>
+                  </a:txBody>
+                </a:tc>
+              </a:tr>
+              <a:tr h="0">
+                <a:tc>
+                  <a:txBody>
+                    <a:bodyPr/>
+                    <a:lstStyle/>
+                    <a:p>
+                      <a:pPr lvl="0" indent="0" marL="0">
+                        <a:buNone/>
+                      </a:pPr>
+                      <a:r>
+                        <a:rPr/>
+                        <a:t>F. Boltz-2 (GPU 조건부)</a:t>
+                      </a:r>
+                    </a:p>
+                  </a:txBody>
+                </a:tc>
+                <a:tc>
+                  <a:txBody>
+                    <a:bodyPr/>
+                    <a:lstStyle/>
+                    <a:p>
+                      <a:pPr lvl="0" indent="0" marL="0">
+                        <a:buNone/>
+                      </a:pPr>
+                      <a:r>
+                        <a:rPr/>
+                        <a:t>서열 + SMILES, 난이도 층화 200쌍</a:t>
+                      </a:r>
+                    </a:p>
+                  </a:txBody>
+                </a:tc>
+                <a:tc>
+                  <a:txBody>
+                    <a:bodyPr/>
+                    <a:lstStyle/>
+                    <a:p>
+                      <a:pPr lvl="0" indent="0" marL="0">
+                        <a:buNone/>
+                      </a:pPr>
+                      <a:r>
+                        <a:rPr>
+                          <a:latin typeface="Courier"/>
+                        </a:rPr>
+                        <a:t>affinity_probability_binary</a:t>
+                      </a:r>
+                      <a:r>
+                        <a:rPr/>
+                        <a:t>, </a:t>
+                      </a:r>
+                      <a:r>
+                        <a:rPr>
+                          <a:latin typeface="Courier"/>
+                        </a:rPr>
+                        <a:t>ligand_iptm</a:t>
+                      </a:r>
+                      <a:r>
+                        <a:rPr/>
+                        <a:t>, conformal 예측 집합</a:t>
+                      </a:r>
+                    </a:p>
+                  </a:txBody>
+                </a:tc>
+              </a:tr>
+              <a:tr h="0">
+                <a:tc>
+                  <a:txBody>
+                    <a:bodyPr/>
+                    <a:lstStyle/>
+                    <a:p>
+                      <a:pPr lvl="0" indent="0" marL="0">
+                        <a:buNone/>
+                      </a:pPr>
+                      <a:r>
+                        <a:rPr/>
+                        <a:t>E 절차</a:t>
+                      </a:r>
+                    </a:p>
+                  </a:txBody>
+                </a:tc>
+                <a:tc>
+                  <a:txBody>
+                    <a:bodyPr/>
+                    <a:lstStyle/>
+                    <a:p>
+                      <a:pPr lvl="0" indent="0" marL="0">
+                        <a:buNone/>
+                      </a:pPr>
+                      <a:r>
+                        <a:rPr/>
+                        <a:t>에이전트 트랙의 신뢰도 로그</a:t>
+                      </a:r>
+                    </a:p>
+                  </a:txBody>
+                </a:tc>
+                <a:tc>
+                  <a:txBody>
+                    <a:bodyPr/>
+                    <a:lstStyle/>
+                    <a:p>
+                      <a:pPr lvl="0" indent="0" marL="0">
+                        <a:buNone/>
+                      </a:pPr>
+                      <a:r>
+                        <a:rPr/>
+                        <a:t>A와 같은 conformal 절차를 적용한 예측 집합</a:t>
+                      </a:r>
+                    </a:p>
+                  </a:txBody>
+                </a:tc>
+              </a:tr>
+            </a:tbl>
+          </a:graphicData>
+        </a:graphic>
+      </p:graphicFrame>
     </p:spTree>
   </p:cSld>
 </p:sld>
 </file>
 
-<file path=ppt/slides/slide5.xml><?xml version="1.0" encoding="utf-8"?>
+<file path=ppt/slides/slide22.xml><?xml version="1.0" encoding="utf-8"?>
 <p:sld xmlns:a="http://schemas.openxmlformats.org/drawingml/2006/main" xmlns:r="http://schemas.openxmlformats.org/officeDocument/2006/relationships" xmlns:p="http://schemas.openxmlformats.org/presentationml/2006/main">
   <p:cSld>
     <p:spTree>
@@ -3782,18 +5926,18 @@
       </p:grpSpPr>
       <p:sp>
         <p:nvSpPr>
-          <p:cNvPr id="2" name="Title 1">
-            <a:extLst>
-              <a:ext uri="{FF2B5EF4-FFF2-40B4-BE49-F238E27FC236}">
-                <a16:creationId xmlns:a16="http://schemas.microsoft.com/office/drawing/2014/main" id="{C9CE818D-09AE-4CD2-3C65-237AD773CD9F}"/>
-              </a:ext>
-            </a:extLst>
-          </p:cNvPr>
-          <p:cNvSpPr>
-            <a:spLocks noGrp="1"/>
-          </p:cNvSpPr>
-          <p:nvPr>
-            <p:ph type="title"/>
+          <p:cNvPr id="3" name="Content Placeholder 2">
+            <a:extLst>
+              <a:ext uri="{FF2B5EF4-FFF2-40B4-BE49-F238E27FC236}">
+                <a16:creationId xmlns:a16="http://schemas.microsoft.com/office/drawing/2014/main" id="{CF466120-0A55-3491-F9FC-FA77E459C46D}"/>
+              </a:ext>
+            </a:extLst>
+          </p:cNvPr>
+          <p:cNvSpPr>
+            <a:spLocks noGrp="1"/>
+          </p:cNvSpPr>
+          <p:nvPr>
+            <p:ph idx="1"/>
           </p:nvPr>
         </p:nvSpPr>
         <p:spPr/>
@@ -3806,68 +5950,7 @@
             </a:pPr>
             <a:r>
               <a:rPr/>
-              <a:t>자기소개</a:t>
-            </a:r>
-          </a:p>
-        </p:txBody>
-      </p:sp>
-      <p:sp>
-        <p:nvSpPr>
-          <p:cNvPr id="3" name="Content Placeholder 2">
-            <a:extLst>
-              <a:ext uri="{FF2B5EF4-FFF2-40B4-BE49-F238E27FC236}">
-                <a16:creationId xmlns:a16="http://schemas.microsoft.com/office/drawing/2014/main" id="{CF466120-0A55-3491-F9FC-FA77E459C46D}"/>
-              </a:ext>
-            </a:extLst>
-          </p:cNvPr>
-          <p:cNvSpPr>
-            <a:spLocks noGrp="1"/>
-          </p:cNvSpPr>
-          <p:nvPr>
-            <p:ph idx="1"/>
-          </p:nvPr>
-        </p:nvSpPr>
-        <p:spPr/>
-        <p:txBody>
-          <a:bodyPr/>
-          <a:lstStyle/>
-          <a:p>
-            <a:pPr lvl="0" indent="0" marL="0">
-              <a:buNone/>
-            </a:pPr>
-            <a:r>
-              <a:rPr b="1"/>
-              <a:t>Yeji Bae</a:t>
-            </a:r>
-          </a:p>
-          <a:p>
-            <a:pPr lvl="0" indent="0" marL="0">
-              <a:buNone/>
-            </a:pPr>
-            <a:r>
-              <a:rPr/>
-              <a:t>Data Scientist / Computational Biologist at Seattle Children’s Hospital &amp; Research Institute</a:t>
-            </a:r>
-          </a:p>
-          <a:p>
-            <a:pPr lvl="0"/>
-            <a:r>
-              <a:rPr/>
-              <a:t>Multi-omics Analysis</a:t>
-            </a:r>
-          </a:p>
-          <a:p>
-            <a:pPr lvl="0"/>
-            <a:r>
-              <a:rPr/>
-              <a:t>DL model development (fine tuning)</a:t>
-            </a:r>
-          </a:p>
-          <a:p>
-            <a:pPr lvl="0"/>
-            <a:r>
-              <a:rPr/>
-              <a:t>Agent Engineering</a:t>
+              <a:t>OpenFold3는 F에서 빠지고 구조 품질 레퍼런스로 씁니다. 조사한 co-folding 모델 7개 중 affinity를 출력하는 것은 Boltz-2뿐입니다.</a:t>
             </a:r>
           </a:p>
         </p:txBody>
@@ -3877,7 +5960,7 @@
 </p:sld>
 </file>
 
-<file path=ppt/slides/slide6.xml><?xml version="1.0" encoding="utf-8"?>
+<file path=ppt/slides/slide23.xml><?xml version="1.0" encoding="utf-8"?>
 <p:sld xmlns:a="http://schemas.openxmlformats.org/drawingml/2006/main" xmlns:r="http://schemas.openxmlformats.org/officeDocument/2006/relationships" xmlns:p="http://schemas.openxmlformats.org/presentationml/2006/main">
   <p:cSld>
     <p:spTree>
@@ -3920,60 +6003,395 @@
             </a:pPr>
             <a:r>
               <a:rPr/>
-              <a:t>Abstain-DTI를 위한 온보딩</a:t>
-            </a:r>
-          </a:p>
-        </p:txBody>
-      </p:sp>
-      <p:sp>
-        <p:nvSpPr>
-          <p:cNvPr id="3" name="Content Placeholder 2">
-            <a:extLst>
-              <a:ext uri="{FF2B5EF4-FFF2-40B4-BE49-F238E27FC236}">
-                <a16:creationId xmlns:a16="http://schemas.microsoft.com/office/drawing/2014/main" id="{CF466120-0A55-3491-F9FC-FA77E459C46D}"/>
-              </a:ext>
-            </a:extLst>
-          </p:cNvPr>
-          <p:cNvSpPr>
-            <a:spLocks noGrp="1"/>
-          </p:cNvSpPr>
+              <a:t>에이전트 트랙</a:t>
+            </a:r>
+          </a:p>
+        </p:txBody>
+      </p:sp>
+      <p:graphicFrame>
+        <p:nvGraphicFramePr>
+          <p:cNvPr id="6" name="Content Placeholder 5"/>
+          <p:cNvGraphicFramePr>
+            <a:graphicFrameLocks noGrp="1"/>
+          </p:cNvGraphicFramePr>
           <p:nvPr>
             <p:ph idx="1"/>
           </p:nvPr>
-        </p:nvSpPr>
-        <p:spPr/>
-        <p:txBody>
-          <a:bodyPr/>
-          <a:lstStyle/>
-          <a:p>
-            <a:pPr lvl="0"/>
-            <a:r>
-              <a:rPr/>
-              <a:t>문제 정의</a:t>
-            </a:r>
-          </a:p>
-          <a:p>
-            <a:pPr lvl="0"/>
-            <a:r>
-              <a:rPr/>
-              <a:t>난이도 정의</a:t>
-            </a:r>
-          </a:p>
-          <a:p>
-            <a:pPr lvl="0"/>
-            <a:r>
-              <a:rPr/>
-              <a:t>INPUT &amp; OUTPUT</a:t>
-            </a:r>
-          </a:p>
-        </p:txBody>
-      </p:sp>
+        </p:nvGraphicFramePr>
+        <p:xfrm>
+          <a:off x="838200" y="1816100"/>
+          <a:ext cx="10515600" cy="4343400"/>
+        </p:xfrm>
+        <a:graphic>
+          <a:graphicData uri="http://schemas.openxmlformats.org/drawingml/2006/table">
+            <a:tbl>
+              <a:tblPr firstRow="1" bandRow="1">
+                <a:tableStyleId>{5C22544A-7EE6-4342-B048-85BDC9FD1C3A}</a:tableStyleId>
+              </a:tblPr>
+              <a:tblGrid>
+                <a:gridCol w="3505200"/>
+                <a:gridCol w="3505200"/>
+                <a:gridCol w="3505200"/>
+              </a:tblGrid>
+              <a:tr h="0">
+                <a:tc>
+                  <a:txBody>
+                    <a:bodyPr/>
+                    <a:lstStyle/>
+                    <a:p>
+                      <a:pPr lvl="0" indent="0" marL="0">
+                        <a:buNone/>
+                      </a:pPr>
+                      <a:r>
+                        <a:rPr/>
+                        <a:t>조건</a:t>
+                      </a:r>
+                    </a:p>
+                  </a:txBody>
+                  <a:tcPr/>
+                </a:tc>
+                <a:tc>
+                  <a:txBody>
+                    <a:bodyPr/>
+                    <a:lstStyle/>
+                    <a:p>
+                      <a:pPr lvl="0" indent="0" marL="0">
+                        <a:buNone/>
+                      </a:pPr>
+                      <a:r>
+                        <a:rPr/>
+                        <a:t>입력</a:t>
+                      </a:r>
+                    </a:p>
+                  </a:txBody>
+                  <a:tcPr/>
+                </a:tc>
+                <a:tc>
+                  <a:txBody>
+                    <a:bodyPr/>
+                    <a:lstStyle/>
+                    <a:p>
+                      <a:pPr lvl="0" indent="0" marL="0">
+                        <a:buNone/>
+                      </a:pPr>
+                      <a:r>
+                        <a:rPr/>
+                        <a:t>출력 (JSON)</a:t>
+                      </a:r>
+                    </a:p>
+                  </a:txBody>
+                  <a:tcPr/>
+                </a:tc>
+              </a:tr>
+              <a:tr h="0">
+                <a:tc>
+                  <a:txBody>
+                    <a:bodyPr/>
+                    <a:lstStyle/>
+                    <a:p>
+                      <a:pPr lvl="0" indent="0" marL="0">
+                        <a:buNone/>
+                      </a:pPr>
+                      <a:r>
+                        <a:rPr/>
+                        <a:t>B. Zero-shot LLM</a:t>
+                      </a:r>
+                    </a:p>
+                  </a:txBody>
+                </a:tc>
+                <a:tc>
+                  <a:txBody>
+                    <a:bodyPr/>
+                    <a:lstStyle/>
+                    <a:p>
+                      <a:pPr lvl="0" indent="0" marL="0">
+                        <a:buNone/>
+                      </a:pPr>
+                      <a:r>
+                        <a:rPr/>
+                        <a:t>서열 + SMILES, 도구 없음</a:t>
+                      </a:r>
+                    </a:p>
+                  </a:txBody>
+                </a:tc>
+                <a:tc>
+                  <a:txBody>
+                    <a:bodyPr/>
+                    <a:lstStyle/>
+                    <a:p>
+                      <a:pPr lvl="0" indent="0" marL="0">
+                        <a:buNone/>
+                      </a:pPr>
+                      <a:r>
+                        <a:rPr>
+                          <a:latin typeface="Courier"/>
+                        </a:rPr>
+                        <a:t>binds</a:t>
+                      </a:r>
+                      <a:r>
+                        <a:rPr/>
+                        <a:t>, </a:t>
+                      </a:r>
+                      <a:r>
+                        <a:rPr>
+                          <a:latin typeface="Courier"/>
+                        </a:rPr>
+                        <a:t>confidence</a:t>
+                      </a:r>
+                      <a:r>
+                        <a:rPr/>
+                        <a:t>, </a:t>
+                      </a:r>
+                      <a:r>
+                        <a:rPr>
+                          <a:latin typeface="Courier"/>
+                        </a:rPr>
+                        <a:t>pAffinity</a:t>
+                      </a:r>
+                      <a:r>
+                        <a:rPr/>
+                        <a:t>, </a:t>
+                      </a:r>
+                      <a:r>
+                        <a:rPr>
+                          <a:latin typeface="Courier"/>
+                        </a:rPr>
+                        <a:t>reasoning</a:t>
+                      </a:r>
+                    </a:p>
+                  </a:txBody>
+                </a:tc>
+              </a:tr>
+              <a:tr h="0">
+                <a:tc>
+                  <a:txBody>
+                    <a:bodyPr/>
+                    <a:lstStyle/>
+                    <a:p>
+                      <a:pPr lvl="0" indent="0" marL="0">
+                        <a:buNone/>
+                      </a:pPr>
+                      <a:r>
+                        <a:rPr/>
+                        <a:t>C. Agent</a:t>
+                      </a:r>
+                    </a:p>
+                  </a:txBody>
+                </a:tc>
+                <a:tc>
+                  <a:txBody>
+                    <a:bodyPr/>
+                    <a:lstStyle/>
+                    <a:p>
+                      <a:pPr lvl="0" indent="0" marL="0">
+                        <a:buNone/>
+                      </a:pPr>
+                      <a:r>
+                        <a:rPr/>
+                        <a:t>서열 + SMILES, ToolUniverse MCP 도구</a:t>
+                      </a:r>
+                    </a:p>
+                  </a:txBody>
+                </a:tc>
+                <a:tc>
+                  <a:txBody>
+                    <a:bodyPr/>
+                    <a:lstStyle/>
+                    <a:p>
+                      <a:pPr lvl="0" indent="0" marL="0">
+                        <a:buNone/>
+                      </a:pPr>
+                      <a:r>
+                        <a:rPr/>
+                        <a:t>B 필드 + </a:t>
+                      </a:r>
+                      <a:r>
+                        <a:rPr>
+                          <a:latin typeface="Courier"/>
+                        </a:rPr>
+                        <a:t>identified_target</a:t>
+                      </a:r>
+                      <a:r>
+                        <a:rPr/>
+                        <a:t>, </a:t>
+                      </a:r>
+                      <a:r>
+                        <a:rPr>
+                          <a:latin typeface="Courier"/>
+                        </a:rPr>
+                        <a:t>direct_measurement_found</a:t>
+                      </a:r>
+                      <a:r>
+                        <a:rPr/>
+                        <a:t>, </a:t>
+                      </a:r>
+                      <a:r>
+                        <a:rPr>
+                          <a:latin typeface="Courier"/>
+                        </a:rPr>
+                        <a:t>evidence</a:t>
+                      </a:r>
+                    </a:p>
+                  </a:txBody>
+                </a:tc>
+              </a:tr>
+              <a:tr h="0">
+                <a:tc>
+                  <a:txBody>
+                    <a:bodyPr/>
+                    <a:lstStyle/>
+                    <a:p>
+                      <a:pPr lvl="0" indent="0" marL="0">
+                        <a:buNone/>
+                      </a:pPr>
+                      <a:r>
+                        <a:rPr/>
+                        <a:t>D. Agent + 기권</a:t>
+                      </a:r>
+                    </a:p>
+                  </a:txBody>
+                </a:tc>
+                <a:tc>
+                  <a:txBody>
+                    <a:bodyPr/>
+                    <a:lstStyle/>
+                    <a:p>
+                      <a:pPr lvl="0" indent="0" marL="0">
+                        <a:buNone/>
+                      </a:pPr>
+                      <a:r>
+                        <a:rPr/>
+                        <a:t>C와 같음, 기권 허용</a:t>
+                      </a:r>
+                    </a:p>
+                  </a:txBody>
+                </a:tc>
+                <a:tc>
+                  <a:txBody>
+                    <a:bodyPr/>
+                    <a:lstStyle/>
+                    <a:p>
+                      <a:pPr lvl="0" indent="0" marL="0">
+                        <a:buNone/>
+                      </a:pPr>
+                      <a:r>
+                        <a:rPr/>
+                        <a:t>C 필드 + </a:t>
+                      </a:r>
+                      <a:r>
+                        <a:rPr>
+                          <a:latin typeface="Courier"/>
+                        </a:rPr>
+                        <a:t>abstain</a:t>
+                      </a:r>
+                    </a:p>
+                  </a:txBody>
+                </a:tc>
+              </a:tr>
+              <a:tr h="0">
+                <a:tc>
+                  <a:txBody>
+                    <a:bodyPr/>
+                    <a:lstStyle/>
+                    <a:p>
+                      <a:pPr lvl="0" indent="0" marL="0">
+                        <a:buNone/>
+                      </a:pPr>
+                      <a:r>
+                        <a:rPr/>
+                        <a:t>반복 실행</a:t>
+                      </a:r>
+                    </a:p>
+                  </a:txBody>
+                </a:tc>
+                <a:tc>
+                  <a:txBody>
+                    <a:bodyPr/>
+                    <a:lstStyle/>
+                    <a:p>
+                      <a:pPr lvl="0" indent="0" marL="0">
+                        <a:buNone/>
+                      </a:pPr>
+                      <a:r>
+                        <a:rPr/>
+                        <a:t>같은 쿼리 3회, temperature 0.7</a:t>
+                      </a:r>
+                    </a:p>
+                  </a:txBody>
+                </a:tc>
+                <a:tc>
+                  <a:txBody>
+                    <a:bodyPr/>
+                    <a:lstStyle/>
+                    <a:p>
+                      <a:pPr lvl="0" indent="0" marL="0">
+                        <a:buNone/>
+                      </a:pPr>
+                      <a:r>
+                        <a:rPr/>
+                        <a:t>flip rate, 조건 E용 신뢰도 로그, 토큰·지연·비용</a:t>
+                      </a:r>
+                    </a:p>
+                  </a:txBody>
+                </a:tc>
+              </a:tr>
+              <a:tr h="0">
+                <a:tc>
+                  <a:txBody>
+                    <a:bodyPr/>
+                    <a:lstStyle/>
+                    <a:p>
+                      <a:pPr lvl="0" indent="0" marL="0">
+                        <a:buNone/>
+                      </a:pPr>
+                      <a:r>
+                        <a:rPr/>
+                        <a:t>교란 감사</a:t>
+                      </a:r>
+                    </a:p>
+                  </a:txBody>
+                </a:tc>
+                <a:tc>
+                  <a:txBody>
+                    <a:bodyPr/>
+                    <a:lstStyle/>
+                    <a:p>
+                      <a:pPr lvl="0" indent="0" marL="0">
+                        <a:buNone/>
+                      </a:pPr>
+                      <a:r>
+                        <a:rPr/>
+                        <a:t>도구 출력에 오류 4종 주입 (단위, 엔트리, 동일성, 식별자)</a:t>
+                      </a:r>
+                    </a:p>
+                  </a:txBody>
+                </a:tc>
+                <a:tc>
+                  <a:txBody>
+                    <a:bodyPr/>
+                    <a:lstStyle/>
+                    <a:p>
+                      <a:pPr lvl="0" indent="0" marL="0">
+                        <a:buNone/>
+                      </a:pPr>
+                      <a:r>
+                        <a:rPr/>
+                        <a:t>교란 탐지율</a:t>
+                      </a:r>
+                    </a:p>
+                  </a:txBody>
+                </a:tc>
+              </a:tr>
+            </a:tbl>
+          </a:graphicData>
+        </a:graphic>
+      </p:graphicFrame>
     </p:spTree>
   </p:cSld>
 </p:sld>
 </file>
 
-<file path=ppt/slides/slide7.xml><?xml version="1.0" encoding="utf-8"?>
+<file path=ppt/slides/slide24.xml><?xml version="1.0" encoding="utf-8"?>
 <p:sld xmlns:a="http://schemas.openxmlformats.org/drawingml/2006/main" xmlns:r="http://schemas.openxmlformats.org/officeDocument/2006/relationships" xmlns:p="http://schemas.openxmlformats.org/presentationml/2006/main">
   <p:cSld>
     <p:spTree>
@@ -4108,6 +6526,724 @@
 </p:sld>
 </file>
 
+<file path=ppt/slides/slide25.xml><?xml version="1.0" encoding="utf-8"?>
+<p:sld xmlns:a="http://schemas.openxmlformats.org/drawingml/2006/main" xmlns:r="http://schemas.openxmlformats.org/officeDocument/2006/relationships" xmlns:p="http://schemas.openxmlformats.org/presentationml/2006/main">
+  <p:cSld>
+    <p:spTree>
+      <p:nvGrpSpPr>
+        <p:cNvPr id="1" name=""/>
+        <p:cNvGrpSpPr/>
+        <p:nvPr/>
+      </p:nvGrpSpPr>
+      <p:grpSpPr>
+        <a:xfrm>
+          <a:off x="0" y="0"/>
+          <a:ext cx="0" cy="0"/>
+          <a:chOff x="0" y="0"/>
+          <a:chExt cx="0" cy="0"/>
+        </a:xfrm>
+      </p:grpSpPr>
+      <p:sp>
+        <p:nvSpPr>
+          <p:cNvPr id="2" name="Title 1">
+            <a:extLst>
+              <a:ext uri="{FF2B5EF4-FFF2-40B4-BE49-F238E27FC236}">
+                <a16:creationId xmlns:a16="http://schemas.microsoft.com/office/drawing/2014/main" id="{C9CE818D-09AE-4CD2-3C65-237AD773CD9F}"/>
+              </a:ext>
+            </a:extLst>
+          </p:cNvPr>
+          <p:cNvSpPr>
+            <a:spLocks noGrp="1"/>
+          </p:cNvSpPr>
+          <p:nvPr>
+            <p:ph type="title"/>
+          </p:nvPr>
+        </p:nvSpPr>
+        <p:spPr/>
+        <p:txBody>
+          <a:bodyPr/>
+          <a:lstStyle/>
+          <a:p>
+            <a:pPr lvl="0" indent="0" marL="0">
+              <a:buNone/>
+            </a:pPr>
+            <a:r>
+              <a:rPr/>
+              <a:t>PR 올리기</a:t>
+            </a:r>
+          </a:p>
+        </p:txBody>
+      </p:sp>
+      <p:sp>
+        <p:nvSpPr>
+          <p:cNvPr id="3" name="Content Placeholder 2">
+            <a:extLst>
+              <a:ext uri="{FF2B5EF4-FFF2-40B4-BE49-F238E27FC236}">
+                <a16:creationId xmlns:a16="http://schemas.microsoft.com/office/drawing/2014/main" id="{CF466120-0A55-3491-F9FC-FA77E459C46D}"/>
+              </a:ext>
+            </a:extLst>
+          </p:cNvPr>
+          <p:cNvSpPr>
+            <a:spLocks noGrp="1"/>
+          </p:cNvSpPr>
+          <p:nvPr>
+            <p:ph idx="1"/>
+          </p:nvPr>
+        </p:nvSpPr>
+        <p:spPr/>
+        <p:txBody>
+          <a:bodyPr/>
+          <a:lstStyle/>
+          <a:p>
+            <a:pPr lvl="0" indent="0" marL="0">
+              <a:buNone/>
+            </a:pPr>
+            <a:r>
+              <a:rPr>
+                <a:hlinkClick r:id="rId2"/>
+              </a:rPr>
+              <a:t>https://github.com/Pseudo-Lab/abstain-dti</a:t>
+            </a:r>
+          </a:p>
+          <a:p>
+            <a:pPr lvl="0"/>
+            <a:r>
+              <a:rPr/>
+              <a:t>트랙 작업: 작업 브랜치 → 자기 트랙 브랜치 → dev 로 PR (리뷰어 1명 이상)</a:t>
+            </a:r>
+          </a:p>
+          <a:p>
+            <a:pPr lvl="0"/>
+            <a:r>
+              <a:rPr/>
+              <a:t>트랙과 무관한 작업: dev에서 브랜치 → dev 로 PR</a:t>
+            </a:r>
+          </a:p>
+          <a:p>
+            <a:pPr lvl="0"/>
+            <a:r>
+              <a:rPr/>
+              <a:t>README.md 팀 테이블 이름에 깃헙 링크 달기</a:t>
+            </a:r>
+          </a:p>
+          <a:p>
+            <a:pPr lvl="0"/>
+            <a:r>
+              <a:rPr/>
+              <a:t>다음 주 발표할 논문 올리기</a:t>
+            </a:r>
+          </a:p>
+          <a:p>
+            <a:pPr lvl="0"/>
+            <a:r>
+              <a:rPr/>
+              <a:t>논문 → 실행: </a:t>
+            </a:r>
+            <a:r>
+              <a:rPr>
+                <a:hlinkClick r:id="rId3"/>
+              </a:rPr>
+              <a:t>https://github.com/ybaeus/Paper2Agent</a:t>
+            </a:r>
+          </a:p>
+        </p:txBody>
+      </p:sp>
+    </p:spTree>
+  </p:cSld>
+</p:sld>
+</file>
+
+<file path=ppt/slides/slide26.xml><?xml version="1.0" encoding="utf-8"?>
+<p:sld xmlns:a="http://schemas.openxmlformats.org/drawingml/2006/main" xmlns:r="http://schemas.openxmlformats.org/officeDocument/2006/relationships" xmlns:p="http://schemas.openxmlformats.org/presentationml/2006/main">
+  <p:cSld>
+    <p:spTree>
+      <p:nvGrpSpPr>
+        <p:cNvPr id="1" name=""/>
+        <p:cNvGrpSpPr/>
+        <p:nvPr/>
+      </p:nvGrpSpPr>
+      <p:grpSpPr>
+        <a:xfrm>
+          <a:off x="0" y="0"/>
+          <a:ext cx="0" cy="0"/>
+          <a:chOff x="0" y="0"/>
+          <a:chExt cx="0" cy="0"/>
+        </a:xfrm>
+      </p:grpSpPr>
+      <p:sp>
+        <p:nvSpPr>
+          <p:cNvPr id="2" name="Title 1">
+            <a:extLst>
+              <a:ext uri="{FF2B5EF4-FFF2-40B4-BE49-F238E27FC236}">
+                <a16:creationId xmlns:a16="http://schemas.microsoft.com/office/drawing/2014/main" id="{C9CE818D-09AE-4CD2-3C65-237AD773CD9F}"/>
+              </a:ext>
+            </a:extLst>
+          </p:cNvPr>
+          <p:cNvSpPr>
+            <a:spLocks noGrp="1"/>
+          </p:cNvSpPr>
+          <p:nvPr>
+            <p:ph type="title"/>
+          </p:nvPr>
+        </p:nvSpPr>
+        <p:spPr/>
+        <p:txBody>
+          <a:bodyPr/>
+          <a:lstStyle/>
+          <a:p>
+            <a:pPr lvl="0" indent="0" marL="0">
+              <a:buNone/>
+            </a:pPr>
+            <a:r>
+              <a:rPr/>
+              <a:t>Feedbacks will be given by</a:t>
+            </a:r>
+          </a:p>
+        </p:txBody>
+      </p:sp>
+      <p:sp>
+        <p:nvSpPr>
+          <p:cNvPr id="3" name="Content Placeholder 2">
+            <a:extLst>
+              <a:ext uri="{FF2B5EF4-FFF2-40B4-BE49-F238E27FC236}">
+                <a16:creationId xmlns:a16="http://schemas.microsoft.com/office/drawing/2014/main" id="{CF466120-0A55-3491-F9FC-FA77E459C46D}"/>
+              </a:ext>
+            </a:extLst>
+          </p:cNvPr>
+          <p:cNvSpPr>
+            <a:spLocks noGrp="1"/>
+          </p:cNvSpPr>
+          <p:nvPr>
+            <p:ph idx="1"/>
+          </p:nvPr>
+        </p:nvSpPr>
+        <p:spPr/>
+        <p:txBody>
+          <a:bodyPr/>
+          <a:lstStyle/>
+          <a:p>
+            <a:pPr lvl="0"/>
+            <a:r>
+              <a:rPr/>
+              <a:t>UW Andre Berndt Lab postdoc 이다호 박사님 (</a:t>
+            </a:r>
+            <a:r>
+              <a:rPr>
+                <a:hlinkClick r:id="rId2"/>
+              </a:rPr>
+              <a:t>scholar</a:t>
+            </a:r>
+            <a:r>
+              <a:rPr/>
+              <a:t>)</a:t>
+            </a:r>
+          </a:p>
+          <a:p>
+            <a:pPr lvl="0"/>
+            <a:r>
+              <a:rPr/>
+              <a:t>UW David Baker Lab postdoc 신호정 박사님 (</a:t>
+            </a:r>
+            <a:r>
+              <a:rPr>
+                <a:hlinkClick r:id="rId3"/>
+              </a:rPr>
+              <a:t>scholar</a:t>
+            </a:r>
+            <a:r>
+              <a:rPr/>
+              <a:t>)</a:t>
+            </a:r>
+          </a:p>
+          <a:p>
+            <a:pPr lvl="0"/>
+            <a:r>
+              <a:rPr/>
+              <a:t>Duke PhD candidate 김종현님</a:t>
+            </a:r>
+          </a:p>
+          <a:p>
+            <a:pPr lvl="1"/>
+            <a:r>
+              <a:rPr/>
+              <a:t>Kim, J. and Romero, P.A. (2026) ‘Benchmarking and behavioral characterization of LLM agents for protein design’, bioRxiv</a:t>
+            </a:r>
+          </a:p>
+        </p:txBody>
+      </p:sp>
+    </p:spTree>
+  </p:cSld>
+</p:sld>
+</file>
+
+<file path=ppt/slides/slide27.xml><?xml version="1.0" encoding="utf-8"?>
+<p:sld xmlns:a="http://schemas.openxmlformats.org/drawingml/2006/main" xmlns:r="http://schemas.openxmlformats.org/officeDocument/2006/relationships" xmlns:p="http://schemas.openxmlformats.org/presentationml/2006/main">
+  <p:cSld>
+    <p:spTree>
+      <p:nvGrpSpPr>
+        <p:cNvPr id="1" name=""/>
+        <p:cNvGrpSpPr/>
+        <p:nvPr/>
+      </p:nvGrpSpPr>
+      <p:grpSpPr>
+        <a:xfrm>
+          <a:off x="0" y="0"/>
+          <a:ext cx="0" cy="0"/>
+          <a:chOff x="0" y="0"/>
+          <a:chExt cx="0" cy="0"/>
+        </a:xfrm>
+      </p:grpSpPr>
+      <p:sp>
+        <p:nvSpPr>
+          <p:cNvPr id="2" name="Title 1">
+            <a:extLst>
+              <a:ext uri="{FF2B5EF4-FFF2-40B4-BE49-F238E27FC236}">
+                <a16:creationId xmlns:a16="http://schemas.microsoft.com/office/drawing/2014/main" id="{C9CE818D-09AE-4CD2-3C65-237AD773CD9F}"/>
+              </a:ext>
+            </a:extLst>
+          </p:cNvPr>
+          <p:cNvSpPr>
+            <a:spLocks noGrp="1"/>
+          </p:cNvSpPr>
+          <p:nvPr>
+            <p:ph type="title"/>
+          </p:nvPr>
+        </p:nvSpPr>
+        <p:spPr/>
+        <p:txBody>
+          <a:bodyPr/>
+          <a:lstStyle/>
+          <a:p>
+            <a:pPr lvl="0" indent="0" marL="0">
+              <a:buNone/>
+            </a:pPr>
+            <a:r>
+              <a:rPr/>
+              <a:t>Thank you!</a:t>
+            </a:r>
+          </a:p>
+        </p:txBody>
+      </p:sp>
+    </p:spTree>
+  </p:cSld>
+</p:sld>
+</file>
+
+<file path=ppt/slides/slide3.xml><?xml version="1.0" encoding="utf-8"?>
+<p:sld xmlns:a="http://schemas.openxmlformats.org/drawingml/2006/main" xmlns:r="http://schemas.openxmlformats.org/officeDocument/2006/relationships" xmlns:p="http://schemas.openxmlformats.org/presentationml/2006/main">
+  <p:cSld>
+    <p:spTree>
+      <p:nvGrpSpPr>
+        <p:cNvPr id="1" name=""/>
+        <p:cNvGrpSpPr/>
+        <p:nvPr/>
+      </p:nvGrpSpPr>
+      <p:grpSpPr>
+        <a:xfrm>
+          <a:off x="0" y="0"/>
+          <a:ext cx="0" cy="0"/>
+          <a:chOff x="0" y="0"/>
+          <a:chExt cx="0" cy="0"/>
+        </a:xfrm>
+      </p:grpSpPr>
+      <p:sp>
+        <p:nvSpPr>
+          <p:cNvPr id="2" name="Title 1">
+            <a:extLst>
+              <a:ext uri="{FF2B5EF4-FFF2-40B4-BE49-F238E27FC236}">
+                <a16:creationId xmlns:a16="http://schemas.microsoft.com/office/drawing/2014/main" id="{C9CE818D-09AE-4CD2-3C65-237AD773CD9F}"/>
+              </a:ext>
+            </a:extLst>
+          </p:cNvPr>
+          <p:cNvSpPr>
+            <a:spLocks noGrp="1"/>
+          </p:cNvSpPr>
+          <p:nvPr>
+            <p:ph type="title"/>
+          </p:nvPr>
+        </p:nvSpPr>
+        <p:spPr/>
+        <p:txBody>
+          <a:bodyPr/>
+          <a:lstStyle/>
+          <a:p>
+            <a:pPr lvl="0" indent="0" marL="0">
+              <a:buNone/>
+            </a:pPr>
+            <a:r>
+              <a:rPr/>
+              <a:t>스터디 룰 소개</a:t>
+            </a:r>
+          </a:p>
+        </p:txBody>
+      </p:sp>
+      <p:sp>
+        <p:nvSpPr>
+          <p:cNvPr id="3" name="Content Placeholder 2">
+            <a:extLst>
+              <a:ext uri="{FF2B5EF4-FFF2-40B4-BE49-F238E27FC236}">
+                <a16:creationId xmlns:a16="http://schemas.microsoft.com/office/drawing/2014/main" id="{CF466120-0A55-3491-F9FC-FA77E459C46D}"/>
+              </a:ext>
+            </a:extLst>
+          </p:cNvPr>
+          <p:cNvSpPr>
+            <a:spLocks noGrp="1"/>
+          </p:cNvSpPr>
+          <p:nvPr>
+            <p:ph idx="1"/>
+          </p:nvPr>
+        </p:nvSpPr>
+        <p:spPr/>
+        <p:txBody>
+          <a:bodyPr/>
+          <a:lstStyle/>
+          <a:p>
+            <a:pPr lvl="0"/>
+            <a:r>
+              <a:rPr/>
+              <a:t>2회 이상 무단 불참 시 제명</a:t>
+            </a:r>
+          </a:p>
+          <a:p>
+            <a:pPr lvl="0"/>
+            <a:r>
+              <a:rPr/>
+              <a:t>카메라 on 필수 (얼굴이 보이지 않아도 돼)</a:t>
+            </a:r>
+          </a:p>
+        </p:txBody>
+      </p:sp>
+    </p:spTree>
+  </p:cSld>
+</p:sld>
+</file>
+
+<file path=ppt/slides/slide4.xml><?xml version="1.0" encoding="utf-8"?>
+<p:sld xmlns:a="http://schemas.openxmlformats.org/drawingml/2006/main" xmlns:r="http://schemas.openxmlformats.org/officeDocument/2006/relationships" xmlns:p="http://schemas.openxmlformats.org/presentationml/2006/main">
+  <p:cSld>
+    <p:spTree>
+      <p:nvGrpSpPr>
+        <p:cNvPr id="1" name=""/>
+        <p:cNvGrpSpPr/>
+        <p:nvPr/>
+      </p:nvGrpSpPr>
+      <p:grpSpPr>
+        <a:xfrm>
+          <a:off x="0" y="0"/>
+          <a:ext cx="0" cy="0"/>
+          <a:chOff x="0" y="0"/>
+          <a:chExt cx="0" cy="0"/>
+        </a:xfrm>
+      </p:grpSpPr>
+      <p:sp>
+        <p:nvSpPr>
+          <p:cNvPr id="2" name="Title 1">
+            <a:extLst>
+              <a:ext uri="{FF2B5EF4-FFF2-40B4-BE49-F238E27FC236}">
+                <a16:creationId xmlns:a16="http://schemas.microsoft.com/office/drawing/2014/main" id="{60DC0D0C-9A5E-1DC8-B48D-462EC113779B}"/>
+              </a:ext>
+            </a:extLst>
+          </p:cNvPr>
+          <p:cNvSpPr>
+            <a:spLocks noGrp="1"/>
+          </p:cNvSpPr>
+          <p:nvPr>
+            <p:ph type="title"/>
+          </p:nvPr>
+        </p:nvSpPr>
+        <p:spPr>
+          <a:xfrm>
+            <a:off x="831850" y="1709738"/>
+            <a:ext cx="10515600" cy="2852737"/>
+          </a:xfrm>
+        </p:spPr>
+        <p:txBody>
+          <a:bodyPr/>
+          <a:lstStyle/>
+          <a:p>
+            <a:pPr lvl="0" indent="0" marL="0">
+              <a:buNone/>
+            </a:pPr>
+            <a:r>
+              <a:rPr/>
+              <a:t>Ice breaking</a:t>
+            </a:r>
+          </a:p>
+        </p:txBody>
+      </p:sp>
+    </p:spTree>
+  </p:cSld>
+</p:sld>
+</file>
+
+<file path=ppt/slides/slide5.xml><?xml version="1.0" encoding="utf-8"?>
+<p:sld xmlns:a="http://schemas.openxmlformats.org/drawingml/2006/main" xmlns:r="http://schemas.openxmlformats.org/officeDocument/2006/relationships" xmlns:p="http://schemas.openxmlformats.org/presentationml/2006/main">
+  <p:cSld>
+    <p:spTree>
+      <p:nvGrpSpPr>
+        <p:cNvPr id="1" name=""/>
+        <p:cNvGrpSpPr/>
+        <p:nvPr/>
+      </p:nvGrpSpPr>
+      <p:grpSpPr>
+        <a:xfrm>
+          <a:off x="0" y="0"/>
+          <a:ext cx="0" cy="0"/>
+          <a:chOff x="0" y="0"/>
+          <a:chExt cx="0" cy="0"/>
+        </a:xfrm>
+      </p:grpSpPr>
+      <p:sp>
+        <p:nvSpPr>
+          <p:cNvPr id="2" name="Title 1">
+            <a:extLst>
+              <a:ext uri="{FF2B5EF4-FFF2-40B4-BE49-F238E27FC236}">
+                <a16:creationId xmlns:a16="http://schemas.microsoft.com/office/drawing/2014/main" id="{C9CE818D-09AE-4CD2-3C65-237AD773CD9F}"/>
+              </a:ext>
+            </a:extLst>
+          </p:cNvPr>
+          <p:cNvSpPr>
+            <a:spLocks noGrp="1"/>
+          </p:cNvSpPr>
+          <p:nvPr>
+            <p:ph type="title"/>
+          </p:nvPr>
+        </p:nvSpPr>
+        <p:spPr/>
+        <p:txBody>
+          <a:bodyPr/>
+          <a:lstStyle/>
+          <a:p>
+            <a:pPr lvl="0" indent="0" marL="0">
+              <a:buNone/>
+            </a:pPr>
+            <a:r>
+              <a:rPr/>
+              <a:t>자기소개</a:t>
+            </a:r>
+          </a:p>
+        </p:txBody>
+      </p:sp>
+      <p:sp>
+        <p:nvSpPr>
+          <p:cNvPr id="3" name="Content Placeholder 2">
+            <a:extLst>
+              <a:ext uri="{FF2B5EF4-FFF2-40B4-BE49-F238E27FC236}">
+                <a16:creationId xmlns:a16="http://schemas.microsoft.com/office/drawing/2014/main" id="{CF466120-0A55-3491-F9FC-FA77E459C46D}"/>
+              </a:ext>
+            </a:extLst>
+          </p:cNvPr>
+          <p:cNvSpPr>
+            <a:spLocks noGrp="1"/>
+          </p:cNvSpPr>
+          <p:nvPr>
+            <p:ph idx="1"/>
+          </p:nvPr>
+        </p:nvSpPr>
+        <p:spPr/>
+        <p:txBody>
+          <a:bodyPr/>
+          <a:lstStyle/>
+          <a:p>
+            <a:pPr lvl="0" indent="0" marL="0">
+              <a:buNone/>
+            </a:pPr>
+            <a:r>
+              <a:rPr b="1"/>
+              <a:t>Yeji Bae</a:t>
+            </a:r>
+          </a:p>
+          <a:p>
+            <a:pPr lvl="0" indent="0" marL="0">
+              <a:buNone/>
+            </a:pPr>
+            <a:r>
+              <a:rPr/>
+              <a:t>Data Scientist / Computational Biologist at Seattle Children’s Hospital &amp; Research Institute</a:t>
+            </a:r>
+          </a:p>
+          <a:p>
+            <a:pPr lvl="0"/>
+            <a:r>
+              <a:rPr/>
+              <a:t>Multi-omics Analysis</a:t>
+            </a:r>
+          </a:p>
+          <a:p>
+            <a:pPr lvl="0"/>
+            <a:r>
+              <a:rPr/>
+              <a:t>DL model development (fine tuning)</a:t>
+            </a:r>
+          </a:p>
+          <a:p>
+            <a:pPr lvl="0"/>
+            <a:r>
+              <a:rPr/>
+              <a:t>Agent Engineering</a:t>
+            </a:r>
+          </a:p>
+        </p:txBody>
+      </p:sp>
+    </p:spTree>
+  </p:cSld>
+</p:sld>
+</file>
+
+<file path=ppt/slides/slide6.xml><?xml version="1.0" encoding="utf-8"?>
+<p:sld xmlns:a="http://schemas.openxmlformats.org/drawingml/2006/main" xmlns:r="http://schemas.openxmlformats.org/officeDocument/2006/relationships" xmlns:p="http://schemas.openxmlformats.org/presentationml/2006/main">
+  <p:cSld>
+    <p:spTree>
+      <p:nvGrpSpPr>
+        <p:cNvPr id="1" name=""/>
+        <p:cNvGrpSpPr/>
+        <p:nvPr/>
+      </p:nvGrpSpPr>
+      <p:grpSpPr>
+        <a:xfrm>
+          <a:off x="0" y="0"/>
+          <a:ext cx="0" cy="0"/>
+          <a:chOff x="0" y="0"/>
+          <a:chExt cx="0" cy="0"/>
+        </a:xfrm>
+      </p:grpSpPr>
+      <p:sp>
+        <p:nvSpPr>
+          <p:cNvPr id="2" name="Title 1">
+            <a:extLst>
+              <a:ext uri="{FF2B5EF4-FFF2-40B4-BE49-F238E27FC236}">
+                <a16:creationId xmlns:a16="http://schemas.microsoft.com/office/drawing/2014/main" id="{C9CE818D-09AE-4CD2-3C65-237AD773CD9F}"/>
+              </a:ext>
+            </a:extLst>
+          </p:cNvPr>
+          <p:cNvSpPr>
+            <a:spLocks noGrp="1"/>
+          </p:cNvSpPr>
+          <p:nvPr>
+            <p:ph type="title"/>
+          </p:nvPr>
+        </p:nvSpPr>
+        <p:spPr/>
+        <p:txBody>
+          <a:bodyPr/>
+          <a:lstStyle/>
+          <a:p>
+            <a:pPr lvl="0" indent="0" marL="0">
+              <a:buNone/>
+            </a:pPr>
+            <a:r>
+              <a:rPr/>
+              <a:t>Abstain-DTI를 위한 온보딩</a:t>
+            </a:r>
+          </a:p>
+        </p:txBody>
+      </p:sp>
+      <p:sp>
+        <p:nvSpPr>
+          <p:cNvPr id="3" name="Content Placeholder 2">
+            <a:extLst>
+              <a:ext uri="{FF2B5EF4-FFF2-40B4-BE49-F238E27FC236}">
+                <a16:creationId xmlns:a16="http://schemas.microsoft.com/office/drawing/2014/main" id="{CF466120-0A55-3491-F9FC-FA77E459C46D}"/>
+              </a:ext>
+            </a:extLst>
+          </p:cNvPr>
+          <p:cNvSpPr>
+            <a:spLocks noGrp="1"/>
+          </p:cNvSpPr>
+          <p:nvPr>
+            <p:ph idx="1"/>
+          </p:nvPr>
+        </p:nvSpPr>
+        <p:spPr/>
+        <p:txBody>
+          <a:bodyPr/>
+          <a:lstStyle/>
+          <a:p>
+            <a:pPr lvl="0"/>
+            <a:r>
+              <a:rPr/>
+              <a:t>문제 정의</a:t>
+            </a:r>
+          </a:p>
+          <a:p>
+            <a:pPr lvl="0"/>
+            <a:r>
+              <a:rPr/>
+              <a:t>난이도 정의</a:t>
+            </a:r>
+          </a:p>
+          <a:p>
+            <a:pPr lvl="0"/>
+            <a:r>
+              <a:rPr/>
+              <a:t>INPUT &amp; OUTPUT</a:t>
+            </a:r>
+          </a:p>
+        </p:txBody>
+      </p:sp>
+    </p:spTree>
+  </p:cSld>
+</p:sld>
+</file>
+
+<file path=ppt/slides/slide7.xml><?xml version="1.0" encoding="utf-8"?>
+<p:sld xmlns:a="http://schemas.openxmlformats.org/drawingml/2006/main" xmlns:r="http://schemas.openxmlformats.org/officeDocument/2006/relationships" xmlns:p="http://schemas.openxmlformats.org/presentationml/2006/main">
+  <p:cSld>
+    <p:spTree>
+      <p:nvGrpSpPr>
+        <p:cNvPr id="1" name=""/>
+        <p:cNvGrpSpPr/>
+        <p:nvPr/>
+      </p:nvGrpSpPr>
+      <p:grpSpPr>
+        <a:xfrm>
+          <a:off x="0" y="0"/>
+          <a:ext cx="0" cy="0"/>
+          <a:chOff x="0" y="0"/>
+          <a:chExt cx="0" cy="0"/>
+        </a:xfrm>
+      </p:grpSpPr>
+      <p:sp>
+        <p:nvSpPr>
+          <p:cNvPr id="2" name="Title 1">
+            <a:extLst>
+              <a:ext uri="{FF2B5EF4-FFF2-40B4-BE49-F238E27FC236}">
+                <a16:creationId xmlns:a16="http://schemas.microsoft.com/office/drawing/2014/main" id="{60DC0D0C-9A5E-1DC8-B48D-462EC113779B}"/>
+              </a:ext>
+            </a:extLst>
+          </p:cNvPr>
+          <p:cNvSpPr>
+            <a:spLocks noGrp="1"/>
+          </p:cNvSpPr>
+          <p:nvPr>
+            <p:ph type="title"/>
+          </p:nvPr>
+        </p:nvSpPr>
+        <p:spPr>
+          <a:xfrm>
+            <a:off x="831850" y="1709738"/>
+            <a:ext cx="10515600" cy="2852737"/>
+          </a:xfrm>
+        </p:spPr>
+        <p:txBody>
+          <a:bodyPr/>
+          <a:lstStyle/>
+          <a:p>
+            <a:pPr lvl="0" indent="0" marL="0">
+              <a:buNone/>
+            </a:pPr>
+            <a:r>
+              <a:rPr/>
+              <a:t>문제 정의</a:t>
+            </a:r>
+          </a:p>
+        </p:txBody>
+      </p:sp>
+    </p:spTree>
+  </p:cSld>
+</p:sld>
+</file>
+
 <file path=ppt/slides/slide8.xml><?xml version="1.0" encoding="utf-8"?>
 <p:sld xmlns:a="http://schemas.openxmlformats.org/drawingml/2006/main" xmlns:r="http://schemas.openxmlformats.org/officeDocument/2006/relationships" xmlns:p="http://schemas.openxmlformats.org/presentationml/2006/main">
   <p:cSld>
@@ -4130,7 +7266,7 @@
           <p:cNvPr id="2" name="Title 1">
             <a:extLst>
               <a:ext uri="{FF2B5EF4-FFF2-40B4-BE49-F238E27FC236}">
-                <a16:creationId xmlns:a16="http://schemas.microsoft.com/office/drawing/2014/main" id="{C9CE818D-09AE-4CD2-3C65-237AD773CD9F}"/>
+                <a16:creationId xmlns:a16="http://schemas.microsoft.com/office/drawing/2014/main" id="{1A5592C5-AEA2-D627-F76B-35C7AD5ED253}"/>
               </a:ext>
             </a:extLst>
           </p:cNvPr>
@@ -4141,6 +7277,42 @@
             <p:ph type="title"/>
           </p:nvPr>
         </p:nvSpPr>
+        <p:spPr>
+          <a:xfrm>
+            <a:off x="839788" y="457200"/>
+            <a:ext cx="3932237" cy="1600200"/>
+          </a:xfrm>
+        </p:spPr>
+        <p:txBody>
+          <a:bodyPr/>
+          <a:lstStyle/>
+          <a:p>
+            <a:pPr lvl="0" indent="0" marL="0">
+              <a:buNone/>
+            </a:pPr>
+            <a:r>
+              <a:rPr/>
+              <a:t>무엇이 문제인가</a:t>
+            </a:r>
+          </a:p>
+        </p:txBody>
+      </p:sp>
+      <p:sp>
+        <p:nvSpPr>
+          <p:cNvPr id="4" name="Text Placeholder 3">
+            <a:extLst>
+              <a:ext uri="{FF2B5EF4-FFF2-40B4-BE49-F238E27FC236}">
+                <a16:creationId xmlns:a16="http://schemas.microsoft.com/office/drawing/2014/main" id="{67344C6D-89EA-24AC-1FF8-F95BD1763393}"/>
+              </a:ext>
+            </a:extLst>
+          </p:cNvPr>
+          <p:cNvSpPr>
+            <a:spLocks noGrp="1"/>
+          </p:cNvSpPr>
+          <p:nvPr>
+            <p:ph idx="2" sz="half" type="body"/>
+          </p:nvPr>
+        </p:nvSpPr>
         <p:spPr/>
         <p:txBody>
           <a:bodyPr/>
@@ -4151,85 +7323,147 @@
             </a:pPr>
             <a:r>
               <a:rPr/>
-              <a:t>PR 올리기</a:t>
-            </a:r>
-          </a:p>
-        </p:txBody>
-      </p:sp>
-      <p:sp>
-        <p:nvSpPr>
-          <p:cNvPr id="3" name="Content Placeholder 2">
-            <a:extLst>
-              <a:ext uri="{FF2B5EF4-FFF2-40B4-BE49-F238E27FC236}">
-                <a16:creationId xmlns:a16="http://schemas.microsoft.com/office/drawing/2014/main" id="{CF466120-0A55-3491-F9FC-FA77E459C46D}"/>
-              </a:ext>
-            </a:extLst>
-          </p:cNvPr>
-          <p:cNvSpPr>
-            <a:spLocks noGrp="1"/>
-          </p:cNvSpPr>
+              <a:t>“LLM이 DTI 예측을 못 하는데도 그냥 답한다”에는 두 상황이 섞여 있습니다.</a:t>
+            </a:r>
+          </a:p>
+        </p:txBody>
+      </p:sp>
+      <p:graphicFrame>
+        <p:nvGraphicFramePr>
+          <p:cNvPr id="6" name="Content Placeholder 5"/>
+          <p:cNvGraphicFramePr>
+            <a:graphicFrameLocks noGrp="1"/>
+          </p:cNvGraphicFramePr>
           <p:nvPr>
             <p:ph idx="1"/>
           </p:nvPr>
-        </p:nvSpPr>
-        <p:spPr/>
-        <p:txBody>
-          <a:bodyPr/>
-          <a:lstStyle/>
-          <a:p>
-            <a:pPr lvl="0" indent="0" marL="0">
-              <a:buNone/>
-            </a:pPr>
-            <a:r>
-              <a:rPr>
-                <a:hlinkClick r:id="rId2"/>
-              </a:rPr>
-              <a:t>https://github.com/Pseudo-Lab/abstain-dti</a:t>
-            </a:r>
-          </a:p>
-          <a:p>
-            <a:pPr lvl="0"/>
-            <a:r>
-              <a:rPr/>
-              <a:t>트랙 작업: 작업 브랜치 → 자기 트랙 브랜치 → dev 로 PR (리뷰어 1명 이상)</a:t>
-            </a:r>
-          </a:p>
-          <a:p>
-            <a:pPr lvl="0"/>
-            <a:r>
-              <a:rPr/>
-              <a:t>트랙과 무관한 작업: dev에서 브랜치 → dev 로 PR</a:t>
-            </a:r>
-          </a:p>
-          <a:p>
-            <a:pPr lvl="0"/>
-            <a:r>
-              <a:rPr/>
-              <a:t>README.md 팀 테이블 이름에 깃헙 링크 달기</a:t>
-            </a:r>
-          </a:p>
-          <a:p>
-            <a:pPr lvl="0"/>
-            <a:r>
-              <a:rPr/>
-              <a:t>다음 주 발표할 논문 올리기</a:t>
-            </a:r>
-          </a:p>
-          <a:p>
-            <a:pPr lvl="0"/>
-            <a:r>
-              <a:rPr/>
-              <a:t>논문 → 실행: </a:t>
-            </a:r>
-            <a:r>
-              <a:rPr>
-                <a:hlinkClick r:id="rId3"/>
-              </a:rPr>
-              <a:t>https://github.com/ybaeus/Paper2Agent</a:t>
-            </a:r>
-          </a:p>
-        </p:txBody>
-      </p:sp>
+        </p:nvGraphicFramePr>
+        <p:xfrm>
+          <a:off x="5181600" y="977900"/>
+          <a:ext cx="6172200" cy="4864100"/>
+        </p:xfrm>
+        <a:graphic>
+          <a:graphicData uri="http://schemas.openxmlformats.org/drawingml/2006/table">
+            <a:tbl>
+              <a:tblPr firstRow="1" bandRow="1">
+                <a:tableStyleId>{5C22544A-7EE6-4342-B048-85BDC9FD1C3A}</a:tableStyleId>
+              </a:tblPr>
+              <a:tblGrid>
+                <a:gridCol w="3086100"/>
+                <a:gridCol w="3086100"/>
+              </a:tblGrid>
+              <a:tr h="0">
+                <a:tc>
+                  <a:txBody>
+                    <a:bodyPr/>
+                    <a:lstStyle/>
+                    <a:p>
+                      <a:pPr lvl="0" indent="0" marL="0">
+                        <a:buNone/>
+                      </a:pPr>
+                      <a:r>
+                        <a:rPr/>
+                        <a:t>상황</a:t>
+                      </a:r>
+                    </a:p>
+                  </a:txBody>
+                  <a:tcPr/>
+                </a:tc>
+                <a:tc>
+                  <a:txBody>
+                    <a:bodyPr/>
+                    <a:lstStyle/>
+                    <a:p>
+                      <a:pPr lvl="0" indent="0" marL="0">
+                        <a:buNone/>
+                      </a:pPr>
+                      <a:r>
+                        <a:rPr/>
+                        <a:t>문제인가</a:t>
+                      </a:r>
+                    </a:p>
+                  </a:txBody>
+                  <a:tcPr/>
+                </a:tc>
+              </a:tr>
+              <a:tr h="0">
+                <a:tc>
+                  <a:txBody>
+                    <a:bodyPr/>
+                    <a:lstStyle/>
+                    <a:p>
+                      <a:pPr lvl="0" indent="0" marL="0">
+                        <a:buNone/>
+                      </a:pPr>
+                      <a:r>
+                        <a:rPr/>
+                        <a:t>약이 타겟에 붙지 않는다</a:t>
+                      </a:r>
+                    </a:p>
+                  </a:txBody>
+                </a:tc>
+                <a:tc>
+                  <a:txBody>
+                    <a:bodyPr/>
+                    <a:lstStyle/>
+                    <a:p>
+                      <a:pPr lvl="0" indent="0" marL="0">
+                        <a:buNone/>
+                      </a:pPr>
+                      <a:r>
+                        <a:rPr/>
+                        <a:t>아닙니다. 정답이 </a:t>
+                      </a:r>
+                      <a:r>
+                        <a:rPr>
+                          <a:latin typeface="Courier"/>
+                        </a:rPr>
+                        <a:t>binds = false</a:t>
+                      </a:r>
+                      <a:r>
+                        <a:rPr/>
+                        <a:t>일 뿐입니다</a:t>
+                      </a:r>
+                    </a:p>
+                  </a:txBody>
+                </a:tc>
+              </a:tr>
+              <a:tr h="0">
+                <a:tc>
+                  <a:txBody>
+                    <a:bodyPr/>
+                    <a:lstStyle/>
+                    <a:p>
+                      <a:pPr lvl="0" indent="0" marL="0">
+                        <a:buNone/>
+                      </a:pPr>
+                      <a:r>
+                        <a:rPr/>
+                        <a:t>답할 근거가 없는 입력에 쉬운 입력과 같은 신뢰도로 답한다</a:t>
+                      </a:r>
+                    </a:p>
+                  </a:txBody>
+                </a:tc>
+                <a:tc>
+                  <a:txBody>
+                    <a:bodyPr/>
+                    <a:lstStyle/>
+                    <a:p>
+                      <a:pPr lvl="0" indent="0" marL="0">
+                        <a:buNone/>
+                      </a:pPr>
+                      <a:r>
+                        <a:rPr/>
+                        <a:t>문제입니다</a:t>
+                      </a:r>
+                    </a:p>
+                  </a:txBody>
+                </a:tc>
+              </a:tr>
+            </a:tbl>
+          </a:graphicData>
+        </a:graphic>
+      </p:graphicFrame>
     </p:spTree>
   </p:cSld>
 </p:sld>
@@ -4254,18 +7488,18 @@
       </p:grpSpPr>
       <p:sp>
         <p:nvSpPr>
-          <p:cNvPr id="2" name="Title 1">
-            <a:extLst>
-              <a:ext uri="{FF2B5EF4-FFF2-40B4-BE49-F238E27FC236}">
-                <a16:creationId xmlns:a16="http://schemas.microsoft.com/office/drawing/2014/main" id="{C9CE818D-09AE-4CD2-3C65-237AD773CD9F}"/>
-              </a:ext>
-            </a:extLst>
-          </p:cNvPr>
-          <p:cNvSpPr>
-            <a:spLocks noGrp="1"/>
-          </p:cNvSpPr>
-          <p:nvPr>
-            <p:ph type="title"/>
+          <p:cNvPr id="3" name="Content Placeholder 2">
+            <a:extLst>
+              <a:ext uri="{FF2B5EF4-FFF2-40B4-BE49-F238E27FC236}">
+                <a16:creationId xmlns:a16="http://schemas.microsoft.com/office/drawing/2014/main" id="{CF466120-0A55-3491-F9FC-FA77E459C46D}"/>
+              </a:ext>
+            </a:extLst>
+          </p:cNvPr>
+          <p:cNvSpPr>
+            <a:spLocks noGrp="1"/>
+          </p:cNvSpPr>
+          <p:nvPr>
+            <p:ph idx="1"/>
           </p:nvPr>
         </p:nvSpPr>
         <p:spPr/>
@@ -4273,82 +7507,17 @@
           <a:bodyPr/>
           <a:lstStyle/>
           <a:p>
-            <a:pPr lvl="0" indent="0" marL="0">
-              <a:buNone/>
-            </a:pPr>
-            <a:r>
-              <a:rPr/>
-              <a:t>Feedbacks will be given by</a:t>
-            </a:r>
-          </a:p>
-        </p:txBody>
-      </p:sp>
-      <p:sp>
-        <p:nvSpPr>
-          <p:cNvPr id="3" name="Content Placeholder 2">
-            <a:extLst>
-              <a:ext uri="{FF2B5EF4-FFF2-40B4-BE49-F238E27FC236}">
-                <a16:creationId xmlns:a16="http://schemas.microsoft.com/office/drawing/2014/main" id="{CF466120-0A55-3491-F9FC-FA77E459C46D}"/>
-              </a:ext>
-            </a:extLst>
-          </p:cNvPr>
-          <p:cNvSpPr>
-            <a:spLocks noGrp="1"/>
-          </p:cNvSpPr>
-          <p:nvPr>
-            <p:ph idx="1"/>
-          </p:nvPr>
-        </p:nvSpPr>
-        <p:spPr/>
-        <p:txBody>
-          <a:bodyPr/>
-          <a:lstStyle/>
-          <a:p>
             <a:pPr lvl="0"/>
             <a:r>
               <a:rPr/>
-              <a:t>UW Andre Berndt Lab postdoc 이다호 박사님 (</a:t>
-            </a:r>
-            <a:r>
-              <a:rPr>
-                <a:hlinkClick r:id="rId2"/>
-              </a:rPr>
-              <a:t>scholar</a:t>
-            </a:r>
-            <a:r>
-              <a:rPr/>
-              <a:t>)</a:t>
+              <a:t>LLM만의 문제가 아닙니다. 지도학습 모델(A)과 Boltz-2(F)에도 같은 질문을 합니다.</a:t>
             </a:r>
           </a:p>
           <a:p>
             <a:pPr lvl="0"/>
             <a:r>
               <a:rPr/>
-              <a:t>UW David Baker Lab postdoc 신호정 박사님 (</a:t>
-            </a:r>
-            <a:r>
-              <a:rPr>
-                <a:hlinkClick r:id="rId3"/>
-              </a:rPr>
-              <a:t>scholar</a:t>
-            </a:r>
-            <a:r>
-              <a:rPr/>
-              <a:t>)</a:t>
-            </a:r>
-          </a:p>
-          <a:p>
-            <a:pPr lvl="0"/>
-            <a:r>
-              <a:rPr/>
-              <a:t>Duke PhD candidate 김종현님</a:t>
-            </a:r>
-          </a:p>
-          <a:p>
-            <a:pPr lvl="1"/>
-            <a:r>
-              <a:rPr/>
-              <a:t>Kim, J. and Romero, P.A. (2026) ‘Benchmarking and behavioral characterization of LLM agents for protein design’, bioRxiv</a:t>
+              <a:t>기권 기능이 없어서 생기는 문제도 아닙니다. 신뢰도 점수가 난이도를 담고 있지 않으면, 기권 기능이 있어도 엉뚱한 문항에서 기권합니다.</a:t>
             </a:r>
           </a:p>
         </p:txBody>

</xml_diff>

<commit_message>
docs: narrow problem statement and add recent evidence
Add research/10 with 2025-2026 sources on confidence and abstention
under novelty (DTI conformal, EviDTI, co-folding memorisation,
ChemBench). Narrow the problem statement to graded difficulty, rewrite
the W01 evidence slides in plain form, and re-render w01.pptx after
merging 884cd3f.

Co-Authored-By: Claude Opus 5.5 <noreply@anthropic.com>
</commit_message>
<xml_diff>
--- a/docs/weekly/w01/w01.pptx
+++ b/docs/weekly/w01/w01.pptx
@@ -32,6 +32,8 @@
     <p:sldId id="280" r:id="rId26"/>
     <p:sldId id="281" r:id="rId27"/>
     <p:sldId id="282" r:id="rId28"/>
+    <p:sldId id="283" r:id="rId29"/>
+    <p:sldId id="284" r:id="rId30"/>
   </p:sldIdLst>
   <p:sldSz cx="12192000" cy="6858000"/>
   <p:notesSz cx="6858000" cy="9144000"/>
@@ -3473,7 +3475,7 @@
             </a:pPr>
             <a:r>
               <a:rPr/>
-              <a:t>Problem statement</a:t>
+              <a:t>근거는 어디까지 있나</a:t>
             </a:r>
           </a:p>
         </p:txBody>
@@ -3499,12 +3501,12 @@
           <a:bodyPr/>
           <a:lstStyle/>
           <a:p>
-            <a:pPr lvl="0" indent="0" marL="1270000">
+            <a:pPr lvl="0" indent="0" marL="0">
               <a:buNone/>
             </a:pPr>
             <a:r>
-              <a:rPr sz="2000"/>
-              <a:t>DTI 예측기(지도학습 모델이든 LLM 에이전트든)는 입력이 자기가 아는 범위를 벗어나도 신뢰도를 낮추지 않을 수 있다. 지금까지의 평가는 정확도를 난이도별로 나눠 보았을 뿐, 신뢰도와 기권이 그 난이도를 따라가는지는 재지 않아, 이 결함이 있는지 알 수 없었다.</a:t>
+              <a:rPr/>
+              <a:t>선행 문헌(Medea, Biomni, ToolUniverse, DrugAgent, LAB-Bench, BixBench) 중 AURC나 risk-coverage로 신뢰도의 순위를 잰 곳은 없습니다.</a:t>
             </a:r>
           </a:p>
           <a:p>
@@ -3513,25 +3515,71 @@
             </a:pPr>
             <a:r>
               <a:rPr b="1"/>
-              <a:t>벤치마크의 질문은 하나입니다.</a:t>
-            </a:r>
-            <a:r>
-              <a:rPr/>
-              <a:t> 신뢰도, 또는 기권 결정이 사전에 정한 난이도 d(x)를 따라가는가?</a:t>
+              <a:t>LAB-Bench</a:t>
+            </a:r>
+          </a:p>
+          <a:p>
+            <a:pPr lvl="0" indent="0" marL="0">
+              <a:buNone/>
+            </a:pPr>
+            <a:r>
+              <a:rPr/>
+              <a:t>LAB-Bench는 생물학 연구 과제로 LLM을 시험하는 벤치마크입니다. 모든 문항에 “정보가 부족해 답할 수 없다” 보기를 주고, 답한 문항 비율(coverage)과 답한 문항 중 정답 비율(precision)을 따로 봅니다.</a:t>
             </a:r>
           </a:p>
           <a:p>
             <a:pPr lvl="0"/>
             <a:r>
               <a:rPr/>
-              <a:t>“결함이 있다”가 아니라 “아무도 재지 않았다”고 씁니다. 결함의 직접 근거는 아직 없습니다.</a:t>
+              <a:t>Cloning Scenarios 과제에서 Gemini 1.5 Pro와 GPT-4-turbo는 다른 모델보다 기권을 많이 했습니다.</a:t>
             </a:r>
           </a:p>
           <a:p>
             <a:pPr lvl="0"/>
             <a:r>
               <a:rPr/>
-              <a:t>정답을 보기 전에 정할 수 있는 난이도 좌표가 필요합니다. 다음 절에서 정의합니다.</a:t>
+              <a:t>그런데 답한 문항만 놓고 봐도 정답률이 가장 낮았습니다. 기권을 많이 해도 정답률은 오르지 않았습니다.</a:t>
+            </a:r>
+          </a:p>
+          <a:p>
+            <a:pPr lvl="0" indent="0" marL="0">
+              <a:buNone/>
+            </a:pPr>
+            <a:r>
+              <a:rPr b="1"/>
+              <a:t>DrugAgent (kinase)</a:t>
+            </a:r>
+          </a:p>
+          <a:p>
+            <a:pPr lvl="0" indent="0" marL="0">
+              <a:buNone/>
+            </a:pPr>
+            <a:r>
+              <a:rPr/>
+              <a:t>DrugAgent는 LLM 여러 개가 문헌과 DB를 찾아보고 약이 타겟에 붙는지 판단하는 에이전트입니다. 저자들은 kinase 평가 문제를 “그 약-타겟 쌍을 직접 다룬 논문이 몇 편 있는가”로 나눠서 정확도를 봤습니다.</a:t>
+            </a:r>
+          </a:p>
+          <a:p>
+            <a:pPr lvl="0"/>
+            <a:r>
+              <a:rPr/>
+              <a:t>논문이 1편 이상 있으면 DrugAgent가 일반 ML 모델(ML+KG)보다 잘 맞혔습니다.</a:t>
+            </a:r>
+          </a:p>
+          <a:p>
+            <a:pPr lvl="0"/>
+            <a:r>
+              <a:rPr/>
+              <a:t>논문이 0편이면 일반 ML 모델과 비슷하거나 더 못했습니다.</a:t>
+            </a:r>
+          </a:p>
+          <a:p>
+            <a:pPr lvl="0" indent="0" marL="0">
+              <a:buNone/>
+            </a:pPr>
+            <a:r>
+              <a:rPr/>
+              <a:t>출처: LAB-Bench arXiv:2407.10362 · DrugAgent arXiv:2408.13378</a:t>
             </a:r>
           </a:p>
         </p:txBody>
@@ -3563,7 +3611,7 @@
           <p:cNvPr id="2" name="Title 1">
             <a:extLst>
               <a:ext uri="{FF2B5EF4-FFF2-40B4-BE49-F238E27FC236}">
-                <a16:creationId xmlns:a16="http://schemas.microsoft.com/office/drawing/2014/main" id="{1A5592C5-AEA2-D627-F76B-35C7AD5ED253}"/>
+                <a16:creationId xmlns:a16="http://schemas.microsoft.com/office/drawing/2014/main" id="{C9CE818D-09AE-4CD2-3C65-237AD773CD9F}"/>
               </a:ext>
             </a:extLst>
           </p:cNvPr>
@@ -3574,12 +3622,7 @@
             <p:ph type="title"/>
           </p:nvPr>
         </p:nvSpPr>
-        <p:spPr>
-          <a:xfrm>
-            <a:off x="839788" y="457200"/>
-            <a:ext cx="3932237" cy="1600200"/>
-          </a:xfrm>
-        </p:spPr>
+        <p:spPr/>
         <p:txBody>
           <a:bodyPr/>
           <a:lstStyle/>
@@ -3589,25 +3632,25 @@
             </a:pPr>
             <a:r>
               <a:rPr/>
-              <a:t>근거는 어디까지 있나</a:t>
-            </a:r>
-          </a:p>
-        </p:txBody>
-      </p:sp>
-      <p:sp>
-        <p:nvSpPr>
-          <p:cNvPr id="4" name="Text Placeholder 3">
-            <a:extLst>
-              <a:ext uri="{FF2B5EF4-FFF2-40B4-BE49-F238E27FC236}">
-                <a16:creationId xmlns:a16="http://schemas.microsoft.com/office/drawing/2014/main" id="{67344C6D-89EA-24AC-1FF8-F95BD1763393}"/>
-              </a:ext>
-            </a:extLst>
-          </p:cNvPr>
-          <p:cNvSpPr>
-            <a:spLocks noGrp="1"/>
-          </p:cNvSpPr>
-          <p:nvPr>
-            <p:ph idx="2" sz="half" type="body"/>
+              <a:t>근거는 어디까지 있나 (계속)</a:t>
+            </a:r>
+          </a:p>
+        </p:txBody>
+      </p:sp>
+      <p:sp>
+        <p:nvSpPr>
+          <p:cNvPr id="3" name="Content Placeholder 2">
+            <a:extLst>
+              <a:ext uri="{FF2B5EF4-FFF2-40B4-BE49-F238E27FC236}">
+                <a16:creationId xmlns:a16="http://schemas.microsoft.com/office/drawing/2014/main" id="{CF466120-0A55-3491-F9FC-FA77E459C46D}"/>
+              </a:ext>
+            </a:extLst>
+          </p:cNvPr>
+          <p:cNvSpPr>
+            <a:spLocks noGrp="1"/>
+          </p:cNvSpPr>
+          <p:nvPr>
+            <p:ph idx="1"/>
           </p:nvPr>
         </p:nvSpPr>
         <p:spPr/>
@@ -3619,202 +3662,83 @@
               <a:buNone/>
             </a:pPr>
             <a:r>
-              <a:rPr/>
-              <a:t>선행 문헌(Medea, Biomni, ToolUniverse, DrugAgent, LAB-Bench, BixBench) 중 AURC나 risk-coverage로 신뢰도의 순위를 잰 곳은 없습니다.</a:t>
-            </a:r>
-          </a:p>
-        </p:txBody>
-      </p:sp>
-      <p:graphicFrame>
-        <p:nvGraphicFramePr>
-          <p:cNvPr id="6" name="Content Placeholder 5"/>
-          <p:cNvGraphicFramePr>
-            <a:graphicFrameLocks noGrp="1"/>
-          </p:cNvGraphicFramePr>
-          <p:nvPr>
-            <p:ph idx="1"/>
-          </p:nvPr>
-        </p:nvGraphicFramePr>
-        <p:xfrm>
-          <a:off x="5181600" y="977900"/>
-          <a:ext cx="6172200" cy="4864100"/>
-        </p:xfrm>
-        <a:graphic>
-          <a:graphicData uri="http://schemas.openxmlformats.org/drawingml/2006/table">
-            <a:tbl>
-              <a:tblPr firstRow="1" bandRow="1">
-                <a:tableStyleId>{5C22544A-7EE6-4342-B048-85BDC9FD1C3A}</a:tableStyleId>
-              </a:tblPr>
-              <a:tblGrid>
-                <a:gridCol w="3086100"/>
-                <a:gridCol w="3086100"/>
-              </a:tblGrid>
-              <a:tr h="0">
-                <a:tc>
-                  <a:txBody>
-                    <a:bodyPr/>
-                    <a:lstStyle/>
-                    <a:p>
-                      <a:pPr lvl="0" indent="0" marL="0">
-                        <a:buNone/>
-                      </a:pPr>
-                      <a:r>
-                        <a:rPr/>
-                        <a:t>근거</a:t>
-                      </a:r>
-                    </a:p>
-                  </a:txBody>
-                  <a:tcPr/>
-                </a:tc>
-                <a:tc>
-                  <a:txBody>
-                    <a:bodyPr/>
-                    <a:lstStyle/>
-                    <a:p>
-                      <a:pPr lvl="0" indent="0" marL="0">
-                        <a:buNone/>
-                      </a:pPr>
-                      <a:r>
-                        <a:rPr/>
-                        <a:t>내용</a:t>
-                      </a:r>
-                    </a:p>
-                  </a:txBody>
-                  <a:tcPr/>
-                </a:tc>
-              </a:tr>
-              <a:tr h="0">
-                <a:tc>
-                  <a:txBody>
-                    <a:bodyPr/>
-                    <a:lstStyle/>
-                    <a:p>
-                      <a:pPr lvl="0" indent="0" marL="0">
-                        <a:buNone/>
-                      </a:pPr>
-                      <a:r>
-                        <a:rPr/>
-                        <a:t>LAB-Bench</a:t>
-                      </a:r>
-                    </a:p>
-                  </a:txBody>
-                </a:tc>
-                <a:tc>
-                  <a:txBody>
-                    <a:bodyPr/>
-                    <a:lstStyle/>
-                    <a:p>
-                      <a:pPr lvl="0" indent="0" marL="0">
-                        <a:buNone/>
-                      </a:pPr>
-                      <a:r>
-                        <a:rPr/>
-                        <a:t>Gemini 1.5 Pro와 GPT-4-turbo는 coverage가 낮아도 precision이 나아지지 않았습니다. 기권이 틀릴 문항에 몰리지 않았다는 신호로 읽지만, 이 해석은 우리 것입니다</a:t>
-                      </a:r>
-                    </a:p>
-                  </a:txBody>
-                </a:tc>
-              </a:tr>
-              <a:tr h="0">
-                <a:tc>
-                  <a:txBody>
-                    <a:bodyPr/>
-                    <a:lstStyle/>
-                    <a:p>
-                      <a:pPr lvl="0" indent="0" marL="0">
-                        <a:buNone/>
-                      </a:pPr>
-                      <a:r>
-                        <a:rPr/>
-                        <a:t>DrugAgent (kinase)</a:t>
-                      </a:r>
-                    </a:p>
-                  </a:txBody>
-                </a:tc>
-                <a:tc>
-                  <a:txBody>
-                    <a:bodyPr/>
-                    <a:lstStyle/>
-                    <a:p>
-                      <a:pPr lvl="0" indent="0" marL="0">
-                        <a:buNone/>
-                      </a:pPr>
-                      <a:r>
-                        <a:rPr/>
-                        <a:t>쌍 단위 논문이 0편인 구간에서 ML+KG 기준선 대비 우위가 사라졌습니다. 그 구간에서 신뢰도도 떨어졌는지는 보고하지 않았습니다</a:t>
-                      </a:r>
-                    </a:p>
-                  </a:txBody>
-                </a:tc>
-              </a:tr>
-              <a:tr h="0">
-                <a:tc>
-                  <a:txBody>
-                    <a:bodyPr/>
-                    <a:lstStyle/>
-                    <a:p>
-                      <a:pPr lvl="0" indent="0" marL="0">
-                        <a:buNone/>
-                      </a:pPr>
-                      <a:r>
-                        <a:rPr/>
-                        <a:t>기권 채점</a:t>
-                      </a:r>
-                    </a:p>
-                  </a:txBody>
-                </a:tc>
-                <a:tc>
-                  <a:txBody>
-                    <a:bodyPr/>
-                    <a:lstStyle/>
-                    <a:p>
-                      <a:pPr lvl="0" indent="0" marL="0">
-                        <a:buNone/>
-                      </a:pPr>
-                      <a:r>
-                        <a:rPr/>
-                        <a:t>ToolUniverse는 기권을 오답으로, Medea와 BixBench는 분모 제외로 셉니다. LAB-Bench는 둘 다 보고합니다</a:t>
-                      </a:r>
-                    </a:p>
-                  </a:txBody>
-                </a:tc>
-              </a:tr>
-              <a:tr h="0">
-                <a:tc>
-                  <a:txBody>
-                    <a:bodyPr/>
-                    <a:lstStyle/>
-                    <a:p>
-                      <a:pPr lvl="0" indent="0" marL="0">
-                        <a:buNone/>
-                      </a:pPr>
-                      <a:r>
-                        <a:rPr/>
-                        <a:t>BixBench (MCQ)</a:t>
-                      </a:r>
-                    </a:p>
-                  </a:txBody>
-                </a:tc>
-                <a:tc>
-                  <a:txBody>
-                    <a:bodyPr/>
-                    <a:lstStyle/>
-                    <a:p>
-                      <a:pPr lvl="0" indent="0" marL="0">
-                        <a:buNone/>
-                      </a:pPr>
-                      <a:r>
-                        <a:rPr/>
-                        <a:t>기권 보기를 주면 성능이 random에 가까워지고, 빼면 random보다 높아집니다</a:t>
-                      </a:r>
-                    </a:p>
-                  </a:txBody>
-                </a:tc>
-              </a:tr>
-            </a:tbl>
-          </a:graphicData>
-        </a:graphic>
-      </p:graphicFrame>
+              <a:rPr b="1"/>
+              <a:t>기권 채점</a:t>
+            </a:r>
+          </a:p>
+          <a:p>
+            <a:pPr lvl="0" indent="0" marL="0">
+              <a:buNone/>
+            </a:pPr>
+            <a:r>
+              <a:rPr/>
+              <a:t>기권을 점수에 어떻게 넣을지는 논문마다 다릅니다. 같은 기권이라도 채점 방식에 따라 점수가 달라집니다.</a:t>
+            </a:r>
+          </a:p>
+          <a:p>
+            <a:pPr lvl="0"/>
+            <a:r>
+              <a:rPr/>
+              <a:t>ToolUniverse는 기권을 오답으로 셉니다.</a:t>
+            </a:r>
+          </a:p>
+          <a:p>
+            <a:pPr lvl="0"/>
+            <a:r>
+              <a:rPr/>
+              <a:t>Medea와 BixBench는 기권한 문항을 빼고 나머지로 정답률을 계산합니다.</a:t>
+            </a:r>
+          </a:p>
+          <a:p>
+            <a:pPr lvl="0"/>
+            <a:r>
+              <a:rPr/>
+              <a:t>LAB-Bench는 두 방식을 모두 보고합니다.</a:t>
+            </a:r>
+          </a:p>
+          <a:p>
+            <a:pPr lvl="0" indent="0" marL="0">
+              <a:buNone/>
+            </a:pPr>
+            <a:r>
+              <a:rPr b="1"/>
+              <a:t>BixBench (객관식)</a:t>
+            </a:r>
+          </a:p>
+          <a:p>
+            <a:pPr lvl="0" indent="0" marL="0">
+              <a:buNone/>
+            </a:pPr>
+            <a:r>
+              <a:rPr/>
+              <a:t>BixBench는 컴퓨터 생물학 분석 과제로 LLM 에이전트를 시험하는 벤치마크입니다. 객관식 문항에 “정보가 부족하다” 보기를 넣은 조건과 뺀 조건을 비교했습니다.</a:t>
+            </a:r>
+          </a:p>
+          <a:p>
+            <a:pPr lvl="0"/>
+            <a:r>
+              <a:rPr/>
+              <a:t>기권 보기가 있으면 성능이 무작위로 찍는 수준에 가까워졌습니다.</a:t>
+            </a:r>
+          </a:p>
+          <a:p>
+            <a:pPr lvl="0"/>
+            <a:r>
+              <a:rPr/>
+              <a:t>기권 보기가 없으면 무작위보다 높았습니다.</a:t>
+            </a:r>
+          </a:p>
+          <a:p>
+            <a:pPr lvl="0" indent="0" marL="0">
+              <a:buNone/>
+            </a:pPr>
+            <a:r>
+              <a:rPr/>
+              <a:t>출처: ToolUniverse arXiv:2509.23426 · Medea DOI 10.64898/2026.01.16.696667 · BixBench arXiv:2503.00096 · LAB-Bench arXiv:2407.10362</a:t>
+            </a:r>
+          </a:p>
+        </p:txBody>
+      </p:sp>
     </p:spTree>
   </p:cSld>
 </p:sld>
@@ -3842,7 +3766,7 @@
           <p:cNvPr id="2" name="Title 1">
             <a:extLst>
               <a:ext uri="{FF2B5EF4-FFF2-40B4-BE49-F238E27FC236}">
-                <a16:creationId xmlns:a16="http://schemas.microsoft.com/office/drawing/2014/main" id="{60DC0D0C-9A5E-1DC8-B48D-462EC113779B}"/>
+                <a16:creationId xmlns:a16="http://schemas.microsoft.com/office/drawing/2014/main" id="{C9CE818D-09AE-4CD2-3C65-237AD773CD9F}"/>
               </a:ext>
             </a:extLst>
           </p:cNvPr>
@@ -3853,12 +3777,7 @@
             <p:ph type="title"/>
           </p:nvPr>
         </p:nvSpPr>
-        <p:spPr>
-          <a:xfrm>
-            <a:off x="831850" y="1709738"/>
-            <a:ext cx="10515600" cy="2852737"/>
-          </a:xfrm>
-        </p:spPr>
+        <p:spPr/>
         <p:txBody>
           <a:bodyPr/>
           <a:lstStyle/>
@@ -3868,7 +3787,109 @@
             </a:pPr>
             <a:r>
               <a:rPr/>
-              <a:t>난이도 정의</a:t>
+              <a:t>최근 근거: DTI 불확실성</a:t>
+            </a:r>
+          </a:p>
+        </p:txBody>
+      </p:sp>
+      <p:sp>
+        <p:nvSpPr>
+          <p:cNvPr id="3" name="Content Placeholder 2">
+            <a:extLst>
+              <a:ext uri="{FF2B5EF4-FFF2-40B4-BE49-F238E27FC236}">
+                <a16:creationId xmlns:a16="http://schemas.microsoft.com/office/drawing/2014/main" id="{CF466120-0A55-3491-F9FC-FA77E459C46D}"/>
+              </a:ext>
+            </a:extLst>
+          </p:cNvPr>
+          <p:cNvSpPr>
+            <a:spLocks noGrp="1"/>
+          </p:cNvSpPr>
+          <p:nvPr>
+            <p:ph idx="1"/>
+          </p:nvPr>
+        </p:nvSpPr>
+        <p:spPr/>
+        <p:txBody>
+          <a:bodyPr/>
+          <a:lstStyle/>
+          <a:p>
+            <a:pPr lvl="0" indent="0" marL="0">
+              <a:buNone/>
+            </a:pPr>
+            <a:r>
+              <a:rPr b="1"/>
+              <a:t>Rakhshaninejad et al. (2025), DTI conformal prediction</a:t>
+            </a:r>
+          </a:p>
+          <a:p>
+            <a:pPr lvl="0" indent="0" marL="0">
+              <a:buNone/>
+            </a:pPr>
+            <a:r>
+              <a:rPr/>
+              <a:t>DTI 예측에 conformal prediction을 적용하고, KIBA 데이터를 네 방식(random, 처음 보는 약물, 처음 보는 단백질, 둘 다 처음)으로 나눠 시험했습니다.</a:t>
+            </a:r>
+          </a:p>
+          <a:p>
+            <a:pPr lvl="0"/>
+            <a:r>
+              <a:rPr/>
+              <a:t>처음 보는 약물과 단백질이 섞일수록 예측이 어려워졌습니다.</a:t>
+            </a:r>
+          </a:p>
+          <a:p>
+            <a:pPr lvl="0"/>
+            <a:r>
+              <a:rPr/>
+              <a:t>처음 보는 약물 split에서는 어떤 방법도 목표 coverage(95%)를 일관되게 맞추지 못했습니다.</a:t>
+            </a:r>
+          </a:p>
+          <a:p>
+            <a:pPr lvl="0"/>
+            <a:r>
+              <a:rPr/>
+              <a:t>난이도는 split 종류 하나뿐이고, LLM은 다루지 않았습니다.</a:t>
+            </a:r>
+          </a:p>
+          <a:p>
+            <a:pPr lvl="0" indent="0" marL="0">
+              <a:buNone/>
+            </a:pPr>
+            <a:r>
+              <a:rPr b="1"/>
+              <a:t>EviDTI (Nat Commun 2025)</a:t>
+            </a:r>
+          </a:p>
+          <a:p>
+            <a:pPr lvl="0" indent="0" marL="0">
+              <a:buNone/>
+            </a:pPr>
+            <a:r>
+              <a:rPr/>
+              <a:t>불확실성을 함께 출력하는 DTI 모델입니다. 학습에 없던 약물 10%로 테스트셋을 만들었습니다.</a:t>
+            </a:r>
+          </a:p>
+          <a:p>
+            <a:pPr lvl="0"/>
+            <a:r>
+              <a:rPr/>
+              <a:t>틀린 예측일수록 불확실성이 높았습니다.</a:t>
+            </a:r>
+          </a:p>
+          <a:p>
+            <a:pPr lvl="0"/>
+            <a:r>
+              <a:rPr/>
+              <a:t>약물이 얼마나 새로운지에 따라 불확실성이 변하는지는 보지 않았습니다.</a:t>
+            </a:r>
+          </a:p>
+          <a:p>
+            <a:pPr lvl="0" indent="0" marL="0">
+              <a:buNone/>
+            </a:pPr>
+            <a:r>
+              <a:rPr/>
+              <a:t>출처: Rakhshaninejad arXiv:2505.18890 · EviDTI DOI 10.1038/s41467-025-62235-6</a:t>
             </a:r>
           </a:p>
         </p:txBody>
@@ -3921,7 +3942,7 @@
             </a:pPr>
             <a:r>
               <a:rPr/>
-              <a:t>난이도는 무엇에 대한 난이도인가</a:t>
+              <a:t>최근 근거: co-folding과 화학 LLM</a:t>
             </a:r>
           </a:p>
         </p:txBody>
@@ -3947,39 +3968,83 @@
           <a:bodyPr/>
           <a:lstStyle/>
           <a:p>
+            <a:pPr lvl="0" indent="0" marL="0">
+              <a:buNone/>
+            </a:pPr>
+            <a:r>
+              <a:rPr b="1"/>
+              <a:t>Škrinjar et al. (2025), co-folding</a:t>
+            </a:r>
+          </a:p>
+          <a:p>
+            <a:pPr lvl="0" indent="0" marL="0">
+              <a:buNone/>
+            </a:pPr>
+            <a:r>
+              <a:rPr/>
+              <a:t>AlphaFold3, Chai-1, Protenix, Boltz-1을 학습 cutoff 이후 공개된 복합체 2,600개로 시험했습니다.</a:t>
+            </a:r>
+          </a:p>
+          <a:p>
             <a:pPr lvl="0"/>
             <a:r>
               <a:rPr/>
-              <a:t>난이도는 (서열, SMILES) 자체의 속성이 아닙니다. </a:t>
-            </a:r>
+              <a:t>학습 데이터와 비슷한 복합체일수록 결합 자세를 잘 맞혔습니다.</a:t>
+            </a:r>
+          </a:p>
+          <a:p>
+            <a:pPr lvl="0"/>
+            <a:r>
+              <a:rPr/>
+              <a:t>모델의 confidence 점수로 걸러도 이 문제는 남았습니다.</a:t>
+            </a:r>
+          </a:p>
+          <a:p>
+            <a:pPr lvl="0"/>
+            <a:r>
+              <a:rPr/>
+              <a:t>affinity가 아니라 결합 자세 예측입니다.</a:t>
+            </a:r>
+          </a:p>
+          <a:p>
+            <a:pPr lvl="0" indent="0" marL="0">
+              <a:buNone/>
+            </a:pPr>
             <a:r>
               <a:rPr b="1"/>
-              <a:t>기준 코퍼스</a:t>
-            </a:r>
-            <a:r>
-              <a:rPr/>
-              <a:t>에 대한 상대적 속성입니다.</a:t>
+              <a:t>ChemBench (Nat Chem 2025)</a:t>
+            </a:r>
+          </a:p>
+          <a:p>
+            <a:pPr lvl="0" indent="0" marL="0">
+              <a:buNone/>
+            </a:pPr>
+            <a:r>
+              <a:rPr/>
+              <a:t>화학 문제로 LLM을 시험하고, 문제마다 자신감을 1-5로 답하게 했습니다. 우리 조건 B, C, D와 같은 자기보고 방식입니다.</a:t>
             </a:r>
           </a:p>
           <a:p>
             <a:pPr lvl="0"/>
             <a:r>
               <a:rPr/>
-              <a:t>조건 A의 기준은 BindingDB 학습 split입니다. LLM 에이전트의 기준은 사전학습 데이터와 도구가 닿는 모든 DB입니다.</a:t>
+              <a:t>대부분의 모델이 보정되지 않았고, 자신감이 오해를 부르는 경우가 있었습니다.</a:t>
             </a:r>
           </a:p>
           <a:p>
             <a:pPr lvl="0"/>
             <a:r>
               <a:rPr/>
-              <a:t>예를 들어 A의 학습셋에 없는 타겟도, ChEMBL을 검색하는 에이전트에게는 단순 조회일 수 있습니다.</a:t>
-            </a:r>
-          </a:p>
-          <a:p>
-            <a:pPr lvl="0"/>
-            <a:r>
-              <a:rPr/>
-              <a:t>그래서 축마다 기준 코퍼스와 유효한 조건을 함께 적습니다.</a:t>
+              <a:t>저자들은 많은 모델이 자기 한계를 믿을 만하게 추정하지 못한다고 결론지었습니다.</a:t>
+            </a:r>
+          </a:p>
+          <a:p>
+            <a:pPr lvl="0" indent="0" marL="0">
+              <a:buNone/>
+            </a:pPr>
+            <a:r>
+              <a:rPr/>
+              <a:t>출처: Škrinjar bioRxiv 10.1101/2025.02.03.636309 (v1) · ChemBench DOI 10.1038/s41557-025-01815-x</a:t>
             </a:r>
           </a:p>
         </p:txBody>
@@ -4011,7 +4076,7 @@
           <p:cNvPr id="2" name="Title 1">
             <a:extLst>
               <a:ext uri="{FF2B5EF4-FFF2-40B4-BE49-F238E27FC236}">
-                <a16:creationId xmlns:a16="http://schemas.microsoft.com/office/drawing/2014/main" id="{C9CE818D-09AE-4CD2-3C65-237AD773CD9F}"/>
+                <a16:creationId xmlns:a16="http://schemas.microsoft.com/office/drawing/2014/main" id="{60DC0D0C-9A5E-1DC8-B48D-462EC113779B}"/>
               </a:ext>
             </a:extLst>
           </p:cNvPr>
@@ -4022,7 +4087,12 @@
             <p:ph type="title"/>
           </p:nvPr>
         </p:nvSpPr>
-        <p:spPr/>
+        <p:spPr>
+          <a:xfrm>
+            <a:off x="831850" y="1709738"/>
+            <a:ext cx="10515600" cy="2852737"/>
+          </a:xfrm>
+        </p:spPr>
         <p:txBody>
           <a:bodyPr/>
           <a:lstStyle/>
@@ -4032,325 +4102,11 @@
             </a:pPr>
             <a:r>
               <a:rPr/>
-              <a:t>난이도 좌표: 네 묶음</a:t>
-            </a:r>
-          </a:p>
-        </p:txBody>
-      </p:sp>
-      <p:graphicFrame>
-        <p:nvGraphicFramePr>
-          <p:cNvPr id="6" name="Content Placeholder 5"/>
-          <p:cNvGraphicFramePr>
-            <a:graphicFrameLocks noGrp="1"/>
-          </p:cNvGraphicFramePr>
-          <p:nvPr>
-            <p:ph idx="1"/>
-          </p:nvPr>
-        </p:nvGraphicFramePr>
-        <p:xfrm>
-          <a:off x="838200" y="1816100"/>
-          <a:ext cx="10515600" cy="4343400"/>
-        </p:xfrm>
-        <a:graphic>
-          <a:graphicData uri="http://schemas.openxmlformats.org/drawingml/2006/table">
-            <a:tbl>
-              <a:tblPr firstRow="1" bandRow="1">
-                <a:tableStyleId>{5C22544A-7EE6-4342-B048-85BDC9FD1C3A}</a:tableStyleId>
-              </a:tblPr>
-              <a:tblGrid>
-                <a:gridCol w="3505200"/>
-                <a:gridCol w="3505200"/>
-                <a:gridCol w="3505200"/>
-              </a:tblGrid>
-              <a:tr h="0">
-                <a:tc>
-                  <a:txBody>
-                    <a:bodyPr/>
-                    <a:lstStyle/>
-                    <a:p>
-                      <a:pPr lvl="0" indent="0" marL="0">
-                        <a:buNone/>
-                      </a:pPr>
-                      <a:r>
-                        <a:rPr/>
-                        <a:t>묶음</a:t>
-                      </a:r>
-                    </a:p>
-                  </a:txBody>
-                  <a:tcPr/>
-                </a:tc>
-                <a:tc>
-                  <a:txBody>
-                    <a:bodyPr/>
-                    <a:lstStyle/>
-                    <a:p>
-                      <a:pPr lvl="0" indent="0" marL="0">
-                        <a:buNone/>
-                      </a:pPr>
-                      <a:r>
-                        <a:rPr/>
-                        <a:t>축</a:t>
-                      </a:r>
-                    </a:p>
-                  </a:txBody>
-                  <a:tcPr/>
-                </a:tc>
-                <a:tc>
-                  <a:txBody>
-                    <a:bodyPr/>
-                    <a:lstStyle/>
-                    <a:p>
-                      <a:pPr lvl="0" indent="0" marL="0">
-                        <a:buNone/>
-                      </a:pPr>
-                      <a:r>
-                        <a:rPr/>
-                        <a:t>유효한 조건</a:t>
-                      </a:r>
-                    </a:p>
-                  </a:txBody>
-                  <a:tcPr/>
-                </a:tc>
-              </a:tr>
-              <a:tr h="0">
-                <a:tc>
-                  <a:txBody>
-                    <a:bodyPr/>
-                    <a:lstStyle/>
-                    <a:p>
-                      <a:pPr lvl="0" indent="0" marL="0">
-                        <a:buNone/>
-                      </a:pPr>
-                      <a:r>
-                        <a:rPr/>
-                        <a:t>보편 난이도</a:t>
-                      </a:r>
-                    </a:p>
-                  </a:txBody>
-                </a:tc>
-                <a:tc>
-                  <a:txBody>
-                    <a:bodyPr/>
-                    <a:lstStyle/>
-                    <a:p>
-                      <a:pPr lvl="0" indent="0" marL="0">
-                        <a:buNone/>
-                      </a:pPr>
-                      <a:r>
-                        <a:rPr/>
-                        <a:t>타겟 성숙도 (Pharos TDL), 문헌 가용성 (새로 추가)</a:t>
-                      </a:r>
-                    </a:p>
-                  </a:txBody>
-                </a:tc>
-                <a:tc>
-                  <a:txBody>
-                    <a:bodyPr/>
-                    <a:lstStyle/>
-                    <a:p>
-                      <a:pPr lvl="0" indent="0" marL="0">
-                        <a:buNone/>
-                      </a:pPr>
-                      <a:r>
-                        <a:rPr/>
-                        <a:t>전 조건</a:t>
-                      </a:r>
-                    </a:p>
-                  </a:txBody>
-                </a:tc>
-              </a:tr>
-              <a:tr h="0">
-                <a:tc>
-                  <a:txBody>
-                    <a:bodyPr/>
-                    <a:lstStyle/>
-                    <a:p>
-                      <a:pPr lvl="0" indent="0" marL="0">
-                        <a:buNone/>
-                      </a:pPr>
-                      <a:r>
-                        <a:rPr/>
-                        <a:t>학습 split 기준</a:t>
-                      </a:r>
-                    </a:p>
-                  </a:txBody>
-                </a:tc>
-                <a:tc>
-                  <a:txBody>
-                    <a:bodyPr/>
-                    <a:lstStyle/>
-                    <a:p>
-                      <a:pPr lvl="0" indent="0" marL="0">
-                        <a:buNone/>
-                      </a:pPr>
-                      <a:r>
-                        <a:rPr/>
-                        <a:t>리간드 신규성 (Tanimoto, Murcko scaffold), 타겟 신규성 (서열 identity)</a:t>
-                      </a:r>
-                    </a:p>
-                  </a:txBody>
-                </a:tc>
-                <a:tc>
-                  <a:txBody>
-                    <a:bodyPr/>
-                    <a:lstStyle/>
-                    <a:p>
-                      <a:pPr lvl="0" indent="0" marL="0">
-                        <a:buNone/>
-                      </a:pPr>
-                      <a:r>
-                        <a:rPr/>
-                        <a:t>A에 직접. 나머지 조건에 통하는지는 검증 전 가정</a:t>
-                      </a:r>
-                    </a:p>
-                  </a:txBody>
-                </a:tc>
-              </a:tr>
-              <a:tr h="0">
-                <a:tc>
-                  <a:txBody>
-                    <a:bodyPr/>
-                    <a:lstStyle/>
-                    <a:p>
-                      <a:pPr lvl="0" indent="0" marL="0">
-                        <a:buNone/>
-                      </a:pPr>
-                      <a:r>
-                        <a:rPr/>
-                        <a:t>구조 (조건부)</a:t>
-                      </a:r>
-                    </a:p>
-                  </a:txBody>
-                </a:tc>
-                <a:tc>
-                  <a:txBody>
-                    <a:bodyPr/>
-                    <a:lstStyle/>
-                    <a:p>
-                      <a:pPr lvl="0" indent="0" marL="0">
-                        <a:buNone/>
-                      </a:pPr>
-                      <a:r>
-                        <a:rPr/>
-                        <a:t>pocket pLDDT/PAE, 실험 구조 유무</a:t>
-                      </a:r>
-                    </a:p>
-                  </a:txBody>
-                </a:tc>
-                <a:tc>
-                  <a:txBody>
-                    <a:bodyPr/>
-                    <a:lstStyle/>
-                    <a:p>
-                      <a:pPr lvl="0" indent="0" marL="0">
-                        <a:buNone/>
-                      </a:pPr>
-                      <a:r>
-                        <a:rPr/>
-                        <a:t>구조를 쓰는 A, F. 티켓 04 실측 후 확정</a:t>
-                      </a:r>
-                    </a:p>
-                  </a:txBody>
-                </a:tc>
-              </a:tr>
-              <a:tr h="0">
-                <a:tc>
-                  <a:txBody>
-                    <a:bodyPr/>
-                    <a:lstStyle/>
-                    <a:p>
-                      <a:pPr lvl="0" indent="0" marL="0">
-                        <a:buNone/>
-                      </a:pPr>
-                      <a:r>
-                        <a:rPr/>
-                        <a:t>Boltz-2 (조건부)</a:t>
-                      </a:r>
-                    </a:p>
-                  </a:txBody>
-                </a:tc>
-                <a:tc>
-                  <a:txBody>
-                    <a:bodyPr/>
-                    <a:lstStyle/>
-                    <a:p>
-                      <a:pPr lvl="0" indent="0" marL="0">
-                        <a:buNone/>
-                      </a:pPr>
-                      <a:r>
-                        <a:rPr/>
-                        <a:t>리간드 크기 (heavy atom 56개 초과), cofactor가 필요한 타겟</a:t>
-                      </a:r>
-                    </a:p>
-                  </a:txBody>
-                </a:tc>
-                <a:tc>
-                  <a:txBody>
-                    <a:bodyPr/>
-                    <a:lstStyle/>
-                    <a:p>
-                      <a:pPr lvl="0" indent="0" marL="0">
-                        <a:buNone/>
-                      </a:pPr>
-                      <a:r>
-                        <a:rPr/>
-                        <a:t>F</a:t>
-                      </a:r>
-                    </a:p>
-                  </a:txBody>
-                </a:tc>
-              </a:tr>
-              <a:tr h="0">
-                <a:tc>
-                  <a:txBody>
-                    <a:bodyPr/>
-                    <a:lstStyle/>
-                    <a:p>
-                      <a:pPr lvl="0" indent="0" marL="0">
-                        <a:buNone/>
-                      </a:pPr>
-                      <a:r>
-                        <a:rPr/>
-                        <a:t>유효성 플래그</a:t>
-                      </a:r>
-                    </a:p>
-                  </a:txBody>
-                </a:tc>
-                <a:tc>
-                  <a:txBody>
-                    <a:bodyPr/>
-                    <a:lstStyle/>
-                    <a:p>
-                      <a:pPr lvl="0" indent="0" marL="0">
-                        <a:buNone/>
-                      </a:pPr>
-                      <a:r>
-                        <a:rPr/>
-                        <a:t>오염 축 (원측정 발행일), 실측값 직접 조회 여부</a:t>
-                      </a:r>
-                    </a:p>
-                  </a:txBody>
-                </a:tc>
-                <a:tc>
-                  <a:txBody>
-                    <a:bodyPr/>
-                    <a:lstStyle/>
-                    <a:p>
-                      <a:pPr lvl="0" indent="0" marL="0">
-                        <a:buNone/>
-                      </a:pPr>
-                      <a:r>
-                        <a:rPr/>
-                        <a:t>난이도가 아닙니다. 쿼리가 “예측”인지를 판정합니다</a:t>
-                      </a:r>
-                    </a:p>
-                  </a:txBody>
-                </a:tc>
-              </a:tr>
-            </a:tbl>
-          </a:graphicData>
-        </a:graphic>
-      </p:graphicFrame>
+              <a:t>난이도 정의</a:t>
+            </a:r>
+          </a:p>
+        </p:txBody>
+      </p:sp>
     </p:spTree>
   </p:cSld>
 </p:sld>
@@ -4375,6 +4131,37 @@
       </p:grpSpPr>
       <p:sp>
         <p:nvSpPr>
+          <p:cNvPr id="2" name="Title 1">
+            <a:extLst>
+              <a:ext uri="{FF2B5EF4-FFF2-40B4-BE49-F238E27FC236}">
+                <a16:creationId xmlns:a16="http://schemas.microsoft.com/office/drawing/2014/main" id="{C9CE818D-09AE-4CD2-3C65-237AD773CD9F}"/>
+              </a:ext>
+            </a:extLst>
+          </p:cNvPr>
+          <p:cNvSpPr>
+            <a:spLocks noGrp="1"/>
+          </p:cNvSpPr>
+          <p:nvPr>
+            <p:ph type="title"/>
+          </p:nvPr>
+        </p:nvSpPr>
+        <p:spPr/>
+        <p:txBody>
+          <a:bodyPr/>
+          <a:lstStyle/>
+          <a:p>
+            <a:pPr lvl="0" indent="0" marL="0">
+              <a:buNone/>
+            </a:pPr>
+            <a:r>
+              <a:rPr/>
+              <a:t>난이도는 무엇에 대한 난이도인가</a:t>
+            </a:r>
+          </a:p>
+        </p:txBody>
+      </p:sp>
+      <p:sp>
+        <p:nvSpPr>
           <p:cNvPr id="3" name="Content Placeholder 2">
             <a:extLst>
               <a:ext uri="{FF2B5EF4-FFF2-40B4-BE49-F238E27FC236}">
@@ -4394,12 +4181,39 @@
           <a:bodyPr/>
           <a:lstStyle/>
           <a:p>
-            <a:pPr lvl="0" indent="0" marL="0">
-              <a:buNone/>
-            </a:pPr>
-            <a:r>
-              <a:rPr/>
-              <a:t>난이도 좌표는 모델에 입력하지 않습니다. 결과를 층화해 분석할 때만 씁니다.</a:t>
+            <a:pPr lvl="0"/>
+            <a:r>
+              <a:rPr/>
+              <a:t>난이도는 (서열, SMILES) 자체의 속성이 아닙니다. </a:t>
+            </a:r>
+            <a:r>
+              <a:rPr b="1"/>
+              <a:t>기준 코퍼스</a:t>
+            </a:r>
+            <a:r>
+              <a:rPr/>
+              <a:t>에 대한 상대적 속성입니다.</a:t>
+            </a:r>
+          </a:p>
+          <a:p>
+            <a:pPr lvl="0"/>
+            <a:r>
+              <a:rPr/>
+              <a:t>조건 A의 기준은 BindingDB 학습 split입니다. LLM 에이전트의 기준은 사전학습 데이터와 도구가 닿는 모든 DB입니다.</a:t>
+            </a:r>
+          </a:p>
+          <a:p>
+            <a:pPr lvl="0"/>
+            <a:r>
+              <a:rPr/>
+              <a:t>예를 들어 A의 학습셋에 없는 타겟도, ChEMBL을 검색하는 에이전트에게는 단순 조회일 수 있습니다.</a:t>
+            </a:r>
+          </a:p>
+          <a:p>
+            <a:pPr lvl="0"/>
+            <a:r>
+              <a:rPr/>
+              <a:t>그래서 축마다 기준 코퍼스와 유효한 조건을 함께 적습니다.</a:t>
             </a:r>
           </a:p>
         </p:txBody>
@@ -4452,76 +4266,325 @@
             </a:pPr>
             <a:r>
               <a:rPr/>
-              <a:t>난이도가 아닌 것: 라벨 노이즈</a:t>
-            </a:r>
-          </a:p>
-        </p:txBody>
-      </p:sp>
-      <p:sp>
-        <p:nvSpPr>
-          <p:cNvPr id="3" name="Content Placeholder 2">
-            <a:extLst>
-              <a:ext uri="{FF2B5EF4-FFF2-40B4-BE49-F238E27FC236}">
-                <a16:creationId xmlns:a16="http://schemas.microsoft.com/office/drawing/2014/main" id="{CF466120-0A55-3491-F9FC-FA77E459C46D}"/>
-              </a:ext>
-            </a:extLst>
-          </p:cNvPr>
-          <p:cNvSpPr>
-            <a:spLocks noGrp="1"/>
-          </p:cNvSpPr>
+              <a:t>난이도 좌표: 네 묶음</a:t>
+            </a:r>
+          </a:p>
+        </p:txBody>
+      </p:sp>
+      <p:graphicFrame>
+        <p:nvGraphicFramePr>
+          <p:cNvPr id="6" name="Content Placeholder 5"/>
+          <p:cNvGraphicFramePr>
+            <a:graphicFrameLocks noGrp="1"/>
+          </p:cNvGraphicFramePr>
           <p:nvPr>
             <p:ph idx="1"/>
           </p:nvPr>
-        </p:nvSpPr>
-        <p:spPr/>
-        <p:txBody>
-          <a:bodyPr/>
-          <a:lstStyle/>
-          <a:p>
-            <a:pPr lvl="0"/>
-            <a:r>
-              <a:rPr/>
-              <a:t>“이 scaffold는 처음 본다”는 예측기가 알아차릴 수 있습니다.</a:t>
-            </a:r>
-          </a:p>
-          <a:p>
-            <a:pPr lvl="0"/>
-            <a:r>
-              <a:rPr/>
-              <a:t>“이 IC50은 특이한 조건에서 쟀다”, “5.9와 6.1의 경계다”는 알아차릴 수 없습니다. 입력이 아니라 정답의 속성입니다.</a:t>
-            </a:r>
-          </a:p>
-          <a:p>
-            <a:pPr lvl="0"/>
-            <a:r>
-              <a:rPr/>
-              <a:t>그래서 난이도 축에서 빼고, 평가셋 </a:t>
-            </a:r>
-            <a:r>
-              <a:rPr b="1"/>
-              <a:t>포함 기준</a:t>
-            </a:r>
-            <a:r>
-              <a:rPr/>
-              <a:t>으로 처리합니다.</a:t>
-            </a:r>
-          </a:p>
-          <a:p>
-            <a:pPr lvl="1"/>
-            <a:r>
-              <a:rPr/>
-              <a:t>1 µM 경계를 걸치는 검열값, 반복 측정, 회색 구간(5.5-6.5 제외 권고), degrader</a:t>
-            </a:r>
-          </a:p>
-          <a:p>
-            <a:pPr lvl="0"/>
-            <a:r>
-              <a:rPr/>
-              <a:t>각 축이 실제 난이도를 대변하는지는 W06 baseline 오차가 축을 따라 커지는지로 검증합니다(티켓 05).</a:t>
-            </a:r>
-          </a:p>
-        </p:txBody>
-      </p:sp>
+        </p:nvGraphicFramePr>
+        <p:xfrm>
+          <a:off x="838200" y="1816100"/>
+          <a:ext cx="10515600" cy="4343400"/>
+        </p:xfrm>
+        <a:graphic>
+          <a:graphicData uri="http://schemas.openxmlformats.org/drawingml/2006/table">
+            <a:tbl>
+              <a:tblPr firstRow="1" bandRow="1">
+                <a:tableStyleId>{5C22544A-7EE6-4342-B048-85BDC9FD1C3A}</a:tableStyleId>
+              </a:tblPr>
+              <a:tblGrid>
+                <a:gridCol w="3505200"/>
+                <a:gridCol w="3505200"/>
+                <a:gridCol w="3505200"/>
+              </a:tblGrid>
+              <a:tr h="0">
+                <a:tc>
+                  <a:txBody>
+                    <a:bodyPr/>
+                    <a:lstStyle/>
+                    <a:p>
+                      <a:pPr lvl="0" indent="0" marL="0">
+                        <a:buNone/>
+                      </a:pPr>
+                      <a:r>
+                        <a:rPr/>
+                        <a:t>묶음</a:t>
+                      </a:r>
+                    </a:p>
+                  </a:txBody>
+                  <a:tcPr/>
+                </a:tc>
+                <a:tc>
+                  <a:txBody>
+                    <a:bodyPr/>
+                    <a:lstStyle/>
+                    <a:p>
+                      <a:pPr lvl="0" indent="0" marL="0">
+                        <a:buNone/>
+                      </a:pPr>
+                      <a:r>
+                        <a:rPr/>
+                        <a:t>축</a:t>
+                      </a:r>
+                    </a:p>
+                  </a:txBody>
+                  <a:tcPr/>
+                </a:tc>
+                <a:tc>
+                  <a:txBody>
+                    <a:bodyPr/>
+                    <a:lstStyle/>
+                    <a:p>
+                      <a:pPr lvl="0" indent="0" marL="0">
+                        <a:buNone/>
+                      </a:pPr>
+                      <a:r>
+                        <a:rPr/>
+                        <a:t>유효한 조건</a:t>
+                      </a:r>
+                    </a:p>
+                  </a:txBody>
+                  <a:tcPr/>
+                </a:tc>
+              </a:tr>
+              <a:tr h="0">
+                <a:tc>
+                  <a:txBody>
+                    <a:bodyPr/>
+                    <a:lstStyle/>
+                    <a:p>
+                      <a:pPr lvl="0" indent="0" marL="0">
+                        <a:buNone/>
+                      </a:pPr>
+                      <a:r>
+                        <a:rPr/>
+                        <a:t>보편 난이도</a:t>
+                      </a:r>
+                    </a:p>
+                  </a:txBody>
+                </a:tc>
+                <a:tc>
+                  <a:txBody>
+                    <a:bodyPr/>
+                    <a:lstStyle/>
+                    <a:p>
+                      <a:pPr lvl="0" indent="0" marL="0">
+                        <a:buNone/>
+                      </a:pPr>
+                      <a:r>
+                        <a:rPr/>
+                        <a:t>타겟 성숙도 (Pharos TDL), 문헌 가용성 (새로 추가)</a:t>
+                      </a:r>
+                    </a:p>
+                  </a:txBody>
+                </a:tc>
+                <a:tc>
+                  <a:txBody>
+                    <a:bodyPr/>
+                    <a:lstStyle/>
+                    <a:p>
+                      <a:pPr lvl="0" indent="0" marL="0">
+                        <a:buNone/>
+                      </a:pPr>
+                      <a:r>
+                        <a:rPr/>
+                        <a:t>전 조건</a:t>
+                      </a:r>
+                    </a:p>
+                  </a:txBody>
+                </a:tc>
+              </a:tr>
+              <a:tr h="0">
+                <a:tc>
+                  <a:txBody>
+                    <a:bodyPr/>
+                    <a:lstStyle/>
+                    <a:p>
+                      <a:pPr lvl="0" indent="0" marL="0">
+                        <a:buNone/>
+                      </a:pPr>
+                      <a:r>
+                        <a:rPr/>
+                        <a:t>학습 split 기준</a:t>
+                      </a:r>
+                    </a:p>
+                  </a:txBody>
+                </a:tc>
+                <a:tc>
+                  <a:txBody>
+                    <a:bodyPr/>
+                    <a:lstStyle/>
+                    <a:p>
+                      <a:pPr lvl="0" indent="0" marL="0">
+                        <a:buNone/>
+                      </a:pPr>
+                      <a:r>
+                        <a:rPr/>
+                        <a:t>리간드 신규성 (Tanimoto, Murcko scaffold), 타겟 신규성 (서열 identity)</a:t>
+                      </a:r>
+                    </a:p>
+                  </a:txBody>
+                </a:tc>
+                <a:tc>
+                  <a:txBody>
+                    <a:bodyPr/>
+                    <a:lstStyle/>
+                    <a:p>
+                      <a:pPr lvl="0" indent="0" marL="0">
+                        <a:buNone/>
+                      </a:pPr>
+                      <a:r>
+                        <a:rPr/>
+                        <a:t>A에 직접. 나머지 조건에 통하는지는 검증 전 가정</a:t>
+                      </a:r>
+                    </a:p>
+                  </a:txBody>
+                </a:tc>
+              </a:tr>
+              <a:tr h="0">
+                <a:tc>
+                  <a:txBody>
+                    <a:bodyPr/>
+                    <a:lstStyle/>
+                    <a:p>
+                      <a:pPr lvl="0" indent="0" marL="0">
+                        <a:buNone/>
+                      </a:pPr>
+                      <a:r>
+                        <a:rPr/>
+                        <a:t>구조 (조건부)</a:t>
+                      </a:r>
+                    </a:p>
+                  </a:txBody>
+                </a:tc>
+                <a:tc>
+                  <a:txBody>
+                    <a:bodyPr/>
+                    <a:lstStyle/>
+                    <a:p>
+                      <a:pPr lvl="0" indent="0" marL="0">
+                        <a:buNone/>
+                      </a:pPr>
+                      <a:r>
+                        <a:rPr/>
+                        <a:t>pocket pLDDT/PAE, 실험 구조 유무</a:t>
+                      </a:r>
+                    </a:p>
+                  </a:txBody>
+                </a:tc>
+                <a:tc>
+                  <a:txBody>
+                    <a:bodyPr/>
+                    <a:lstStyle/>
+                    <a:p>
+                      <a:pPr lvl="0" indent="0" marL="0">
+                        <a:buNone/>
+                      </a:pPr>
+                      <a:r>
+                        <a:rPr/>
+                        <a:t>구조를 쓰는 A, F. 티켓 04 실측 후 확정</a:t>
+                      </a:r>
+                    </a:p>
+                  </a:txBody>
+                </a:tc>
+              </a:tr>
+              <a:tr h="0">
+                <a:tc>
+                  <a:txBody>
+                    <a:bodyPr/>
+                    <a:lstStyle/>
+                    <a:p>
+                      <a:pPr lvl="0" indent="0" marL="0">
+                        <a:buNone/>
+                      </a:pPr>
+                      <a:r>
+                        <a:rPr/>
+                        <a:t>Boltz-2 (조건부)</a:t>
+                      </a:r>
+                    </a:p>
+                  </a:txBody>
+                </a:tc>
+                <a:tc>
+                  <a:txBody>
+                    <a:bodyPr/>
+                    <a:lstStyle/>
+                    <a:p>
+                      <a:pPr lvl="0" indent="0" marL="0">
+                        <a:buNone/>
+                      </a:pPr>
+                      <a:r>
+                        <a:rPr/>
+                        <a:t>리간드 크기 (heavy atom 56개 초과), cofactor가 필요한 타겟</a:t>
+                      </a:r>
+                    </a:p>
+                  </a:txBody>
+                </a:tc>
+                <a:tc>
+                  <a:txBody>
+                    <a:bodyPr/>
+                    <a:lstStyle/>
+                    <a:p>
+                      <a:pPr lvl="0" indent="0" marL="0">
+                        <a:buNone/>
+                      </a:pPr>
+                      <a:r>
+                        <a:rPr/>
+                        <a:t>F</a:t>
+                      </a:r>
+                    </a:p>
+                  </a:txBody>
+                </a:tc>
+              </a:tr>
+              <a:tr h="0">
+                <a:tc>
+                  <a:txBody>
+                    <a:bodyPr/>
+                    <a:lstStyle/>
+                    <a:p>
+                      <a:pPr lvl="0" indent="0" marL="0">
+                        <a:buNone/>
+                      </a:pPr>
+                      <a:r>
+                        <a:rPr/>
+                        <a:t>유효성 플래그</a:t>
+                      </a:r>
+                    </a:p>
+                  </a:txBody>
+                </a:tc>
+                <a:tc>
+                  <a:txBody>
+                    <a:bodyPr/>
+                    <a:lstStyle/>
+                    <a:p>
+                      <a:pPr lvl="0" indent="0" marL="0">
+                        <a:buNone/>
+                      </a:pPr>
+                      <a:r>
+                        <a:rPr/>
+                        <a:t>오염 축 (원측정 발행일), 실측값 직접 조회 여부</a:t>
+                      </a:r>
+                    </a:p>
+                  </a:txBody>
+                </a:tc>
+                <a:tc>
+                  <a:txBody>
+                    <a:bodyPr/>
+                    <a:lstStyle/>
+                    <a:p>
+                      <a:pPr lvl="0" indent="0" marL="0">
+                        <a:buNone/>
+                      </a:pPr>
+                      <a:r>
+                        <a:rPr/>
+                        <a:t>난이도가 아닙니다. 쿼리가 “예측”인지를 판정합니다</a:t>
+                      </a:r>
+                    </a:p>
+                  </a:txBody>
+                </a:tc>
+              </a:tr>
+            </a:tbl>
+          </a:graphicData>
+        </a:graphic>
+      </p:graphicFrame>
     </p:spTree>
   </p:cSld>
 </p:sld>
@@ -4546,26 +4609,21 @@
       </p:grpSpPr>
       <p:sp>
         <p:nvSpPr>
-          <p:cNvPr id="2" name="Title 1">
-            <a:extLst>
-              <a:ext uri="{FF2B5EF4-FFF2-40B4-BE49-F238E27FC236}">
-                <a16:creationId xmlns:a16="http://schemas.microsoft.com/office/drawing/2014/main" id="{60DC0D0C-9A5E-1DC8-B48D-462EC113779B}"/>
-              </a:ext>
-            </a:extLst>
-          </p:cNvPr>
-          <p:cNvSpPr>
-            <a:spLocks noGrp="1"/>
-          </p:cNvSpPr>
-          <p:nvPr>
-            <p:ph type="title"/>
-          </p:nvPr>
-        </p:nvSpPr>
-        <p:spPr>
-          <a:xfrm>
-            <a:off x="831850" y="1709738"/>
-            <a:ext cx="10515600" cy="2852737"/>
-          </a:xfrm>
-        </p:spPr>
+          <p:cNvPr id="3" name="Content Placeholder 2">
+            <a:extLst>
+              <a:ext uri="{FF2B5EF4-FFF2-40B4-BE49-F238E27FC236}">
+                <a16:creationId xmlns:a16="http://schemas.microsoft.com/office/drawing/2014/main" id="{CF466120-0A55-3491-F9FC-FA77E459C46D}"/>
+              </a:ext>
+            </a:extLst>
+          </p:cNvPr>
+          <p:cNvSpPr>
+            <a:spLocks noGrp="1"/>
+          </p:cNvSpPr>
+          <p:nvPr>
+            <p:ph idx="1"/>
+          </p:nvPr>
+        </p:nvSpPr>
+        <p:spPr/>
         <p:txBody>
           <a:bodyPr/>
           <a:lstStyle/>
@@ -4575,7 +4633,7 @@
             </a:pPr>
             <a:r>
               <a:rPr/>
-              <a:t>INPUT &amp; OUTPUT</a:t>
+              <a:t>난이도 좌표는 모델에 입력하지 않습니다. 결과를 층화해 분석할 때만 씁니다.</a:t>
             </a:r>
           </a:p>
         </p:txBody>
@@ -4628,333 +4686,76 @@
             </a:pPr>
             <a:r>
               <a:rPr/>
-              <a:t>모든 조건 공통</a:t>
-            </a:r>
-          </a:p>
-        </p:txBody>
-      </p:sp>
-      <p:graphicFrame>
-        <p:nvGraphicFramePr>
-          <p:cNvPr id="6" name="Content Placeholder 5"/>
-          <p:cNvGraphicFramePr>
-            <a:graphicFrameLocks noGrp="1"/>
-          </p:cNvGraphicFramePr>
+              <a:t>난이도가 아닌 것: 라벨 노이즈</a:t>
+            </a:r>
+          </a:p>
+        </p:txBody>
+      </p:sp>
+      <p:sp>
+        <p:nvSpPr>
+          <p:cNvPr id="3" name="Content Placeholder 2">
+            <a:extLst>
+              <a:ext uri="{FF2B5EF4-FFF2-40B4-BE49-F238E27FC236}">
+                <a16:creationId xmlns:a16="http://schemas.microsoft.com/office/drawing/2014/main" id="{CF466120-0A55-3491-F9FC-FA77E459C46D}"/>
+              </a:ext>
+            </a:extLst>
+          </p:cNvPr>
+          <p:cNvSpPr>
+            <a:spLocks noGrp="1"/>
+          </p:cNvSpPr>
           <p:nvPr>
             <p:ph idx="1"/>
           </p:nvPr>
-        </p:nvGraphicFramePr>
-        <p:xfrm>
-          <a:off x="838200" y="1816100"/>
-          <a:ext cx="10515600" cy="4343400"/>
-        </p:xfrm>
-        <a:graphic>
-          <a:graphicData uri="http://schemas.openxmlformats.org/drawingml/2006/table">
-            <a:tbl>
-              <a:tblPr firstRow="1" bandRow="1">
-                <a:tableStyleId>{5C22544A-7EE6-4342-B048-85BDC9FD1C3A}</a:tableStyleId>
-              </a:tblPr>
-              <a:tblGrid>
-                <a:gridCol w="5257800"/>
-                <a:gridCol w="5257800"/>
-              </a:tblGrid>
-              <a:tr h="0">
-                <a:tc>
-                  <a:txBody>
-                    <a:bodyPr/>
-                    <a:lstStyle/>
-                    <a:p>
-                      <a:pPr lvl="0" indent="0" marL="0">
-                        <a:buNone/>
-                      </a:pPr>
-                      <a:r>
-                        <a:rPr/>
-                        <a:t>항목</a:t>
-                      </a:r>
-                    </a:p>
-                  </a:txBody>
-                  <a:tcPr/>
-                </a:tc>
-                <a:tc>
-                  <a:txBody>
-                    <a:bodyPr/>
-                    <a:lstStyle/>
-                    <a:p>
-                      <a:pPr lvl="0" indent="0" marL="0">
-                        <a:buNone/>
-                      </a:pPr>
-                      <a:r>
-                        <a:rPr/>
-                        <a:t>정의</a:t>
-                      </a:r>
-                    </a:p>
-                  </a:txBody>
-                  <a:tcPr/>
-                </a:tc>
-              </a:tr>
-              <a:tr h="0">
-                <a:tc>
-                  <a:txBody>
-                    <a:bodyPr/>
-                    <a:lstStyle/>
-                    <a:p>
-                      <a:pPr lvl="0" indent="0" marL="0">
-                        <a:buNone/>
-                      </a:pPr>
-                      <a:r>
-                        <a:rPr/>
-                        <a:t>입력</a:t>
-                      </a:r>
-                    </a:p>
-                  </a:txBody>
-                </a:tc>
-                <a:tc>
-                  <a:txBody>
-                    <a:bodyPr/>
-                    <a:lstStyle/>
-                    <a:p>
-                      <a:pPr lvl="0" indent="0" marL="0">
-                        <a:buNone/>
-                      </a:pPr>
-                      <a:r>
-                        <a:rPr/>
-                        <a:t>단백질 서열 + 화합물 SMILES만. 타겟 식별자(UniProt ID 등)는 주지 않습니다</a:t>
-                      </a:r>
-                    </a:p>
-                  </a:txBody>
-                </a:tc>
-              </a:tr>
-              <a:tr h="0">
-                <a:tc>
-                  <a:txBody>
-                    <a:bodyPr/>
-                    <a:lstStyle/>
-                    <a:p>
-                      <a:pPr lvl="0" indent="0" marL="0">
-                        <a:buNone/>
-                      </a:pPr>
-                      <a:r>
-                        <a:rPr/>
-                        <a:t>주 결정</a:t>
-                      </a:r>
-                    </a:p>
-                  </a:txBody>
-                </a:tc>
-                <a:tc>
-                  <a:txBody>
-                    <a:bodyPr/>
-                    <a:lstStyle/>
-                    <a:p>
-                      <a:pPr lvl="0" indent="0" marL="0">
-                        <a:buNone/>
-                      </a:pPr>
-                      <a:r>
-                        <a:rPr/>
-                        <a:t>결합 여부 </a:t>
-                      </a:r>
-                      <a:r>
-                        <a:rPr>
-                          <a:latin typeface="Courier"/>
-                        </a:rPr>
-                        <a:t>binds</a:t>
-                      </a:r>
-                      <a:r>
-                        <a:rPr/>
-                        <a:t>. pAffinity ≥ 6.0 (Kd / Ki / IC50 ≤ 1 µM)이면 true</a:t>
-                      </a:r>
-                    </a:p>
-                  </a:txBody>
-                </a:tc>
-              </a:tr>
-              <a:tr h="0">
-                <a:tc>
-                  <a:txBody>
-                    <a:bodyPr/>
-                    <a:lstStyle/>
-                    <a:p>
-                      <a:pPr lvl="0" indent="0" marL="0">
-                        <a:buNone/>
-                      </a:pPr>
-                      <a:r>
-                        <a:rPr/>
-                        <a:t>출력</a:t>
-                      </a:r>
-                    </a:p>
-                  </a:txBody>
-                </a:tc>
-                <a:tc>
-                  <a:txBody>
-                    <a:bodyPr/>
-                    <a:lstStyle/>
-                    <a:p>
-                      <a:pPr lvl="0" indent="0" marL="0">
-                        <a:buNone/>
-                      </a:pPr>
-                      <a:r>
-                        <a:rPr>
-                          <a:latin typeface="Courier"/>
-                        </a:rPr>
-                        <a:t>binds</a:t>
-                      </a:r>
-                      <a:r>
-                        <a:rPr/>
-                        <a:t>와 신뢰도, 또는 기권</a:t>
-                      </a:r>
-                    </a:p>
-                  </a:txBody>
-                </a:tc>
-              </a:tr>
-              <a:tr h="0">
-                <a:tc>
-                  <a:txBody>
-                    <a:bodyPr/>
-                    <a:lstStyle/>
-                    <a:p>
-                      <a:pPr lvl="0" indent="0" marL="0">
-                        <a:buNone/>
-                      </a:pPr>
-                      <a:r>
-                        <a:rPr/>
-                        <a:t>주 지표</a:t>
-                      </a:r>
-                    </a:p>
-                  </a:txBody>
-                </a:tc>
-                <a:tc>
-                  <a:txBody>
-                    <a:bodyPr/>
-                    <a:lstStyle/>
-                    <a:p>
-                      <a:pPr lvl="0" indent="0" marL="0">
-                        <a:buNone/>
-                      </a:pPr>
-                      <a:r>
-                        <a:rPr/>
-                        <a:t>AURC, coverage 80%에서의 selective accuracy</a:t>
-                      </a:r>
-                    </a:p>
-                  </a:txBody>
-                </a:tc>
-              </a:tr>
-              <a:tr h="0">
-                <a:tc>
-                  <a:txBody>
-                    <a:bodyPr/>
-                    <a:lstStyle/>
-                    <a:p>
-                      <a:pPr lvl="0" indent="0" marL="0">
-                        <a:buNone/>
-                      </a:pPr>
-                      <a:r>
-                        <a:rPr/>
-                        <a:t>보조</a:t>
-                      </a:r>
-                    </a:p>
-                  </a:txBody>
-                </a:tc>
-                <a:tc>
-                  <a:txBody>
-                    <a:bodyPr/>
-                    <a:lstStyle/>
-                    <a:p>
-                      <a:pPr lvl="0" indent="0" marL="0">
-                        <a:buNone/>
-                      </a:pPr>
-                      <a:r>
-                        <a:rPr/>
-                        <a:t>회귀(pAffinity). Ki와 Kd 정확값 부분집합에서만 보고</a:t>
-                      </a:r>
-                    </a:p>
-                  </a:txBody>
-                </a:tc>
-              </a:tr>
-              <a:tr h="0">
-                <a:tc>
-                  <a:txBody>
-                    <a:bodyPr/>
-                    <a:lstStyle/>
-                    <a:p>
-                      <a:pPr lvl="0" indent="0" marL="0">
-                        <a:buNone/>
-                      </a:pPr>
-                      <a:r>
-                        <a:rPr/>
-                        <a:t>데이터</a:t>
-                      </a:r>
-                    </a:p>
-                  </a:txBody>
-                </a:tc>
-                <a:tc>
-                  <a:txBody>
-                    <a:bodyPr/>
-                    <a:lstStyle/>
-                    <a:p>
-                      <a:pPr lvl="0" indent="0" marL="0">
-                        <a:buNone/>
-                      </a:pPr>
-                      <a:r>
-                        <a:rPr/>
-                        <a:t>BindingDB </a:t>
-                      </a:r>
-                      <a:r>
-                        <a:rPr>
-                          <a:latin typeface="Courier"/>
-                        </a:rPr>
-                        <a:t>202610</a:t>
-                      </a:r>
-                      <a:r>
-                        <a:rPr/>
-                        <a:t> 스냅샷의 CC BY 4.0 부분 (1,436,782행)</a:t>
-                      </a:r>
-                    </a:p>
-                  </a:txBody>
-                </a:tc>
-              </a:tr>
-              <a:tr h="0">
-                <a:tc>
-                  <a:txBody>
-                    <a:bodyPr/>
-                    <a:lstStyle/>
-                    <a:p>
-                      <a:pPr lvl="0" indent="0" marL="0">
-                        <a:buNone/>
-                      </a:pPr>
-                      <a:r>
-                        <a:rPr/>
-                        <a:t>음성</a:t>
-                      </a:r>
-                    </a:p>
-                  </a:txBody>
-                </a:tc>
-                <a:tc>
-                  <a:txBody>
-                    <a:bodyPr/>
-                    <a:lstStyle/>
-                    <a:p>
-                      <a:pPr lvl="0" indent="0" marL="0">
-                        <a:buNone/>
-                      </a:pPr>
-                      <a:r>
-                        <a:rPr/>
-                        <a:t>검열값 </a:t>
-                      </a:r>
-                      <a:r>
-                        <a:rPr>
-                          <a:latin typeface="Courier"/>
-                        </a:rPr>
-                        <a:t>&gt;10 µM</a:t>
-                      </a:r>
-                      <a:r>
-                        <a:rPr/>
-                        <a:t> + 측정된 약한 결합 (pAffinity &lt; 6). decoy 합성은 쓰지 않습니다</a:t>
-                      </a:r>
-                    </a:p>
-                  </a:txBody>
-                </a:tc>
-              </a:tr>
-            </a:tbl>
-          </a:graphicData>
-        </a:graphic>
-      </p:graphicFrame>
+        </p:nvSpPr>
+        <p:spPr/>
+        <p:txBody>
+          <a:bodyPr/>
+          <a:lstStyle/>
+          <a:p>
+            <a:pPr lvl="0"/>
+            <a:r>
+              <a:rPr/>
+              <a:t>“이 scaffold는 처음 본다”는 예측기가 알아차릴 수 있습니다.</a:t>
+            </a:r>
+          </a:p>
+          <a:p>
+            <a:pPr lvl="0"/>
+            <a:r>
+              <a:rPr/>
+              <a:t>“이 IC50은 특이한 조건에서 쟀다”, “5.9와 6.1의 경계다”는 알아차릴 수 없습니다. 입력이 아니라 정답의 속성입니다.</a:t>
+            </a:r>
+          </a:p>
+          <a:p>
+            <a:pPr lvl="0"/>
+            <a:r>
+              <a:rPr/>
+              <a:t>그래서 난이도 축에서 빼고, 평가셋 </a:t>
+            </a:r>
+            <a:r>
+              <a:rPr b="1"/>
+              <a:t>포함 기준</a:t>
+            </a:r>
+            <a:r>
+              <a:rPr/>
+              <a:t>으로 처리합니다.</a:t>
+            </a:r>
+          </a:p>
+          <a:p>
+            <a:pPr lvl="1"/>
+            <a:r>
+              <a:rPr/>
+              <a:t>1 µM 경계를 걸치는 검열값, 반복 측정, 회색 구간(5.5-6.5 제외 권고), degrader</a:t>
+            </a:r>
+          </a:p>
+          <a:p>
+            <a:pPr lvl="0"/>
+            <a:r>
+              <a:rPr/>
+              <a:t>각 축이 실제 난이도를 대변하는지는 W06 baseline 오차가 축을 따라 커지는지로 검증합니다(티켓 05).</a:t>
+            </a:r>
+          </a:p>
+        </p:txBody>
+      </p:sp>
     </p:spTree>
   </p:cSld>
 </p:sld>
@@ -4982,7 +4783,7 @@
           <p:cNvPr id="2" name="Title 1">
             <a:extLst>
               <a:ext uri="{FF2B5EF4-FFF2-40B4-BE49-F238E27FC236}">
-                <a16:creationId xmlns:a16="http://schemas.microsoft.com/office/drawing/2014/main" id="{C9CE818D-09AE-4CD2-3C65-237AD773CD9F}"/>
+                <a16:creationId xmlns:a16="http://schemas.microsoft.com/office/drawing/2014/main" id="{60DC0D0C-9A5E-1DC8-B48D-462EC113779B}"/>
               </a:ext>
             </a:extLst>
           </p:cNvPr>
@@ -4993,7 +4794,12 @@
             <p:ph type="title"/>
           </p:nvPr>
         </p:nvSpPr>
-        <p:spPr/>
+        <p:spPr>
+          <a:xfrm>
+            <a:off x="831850" y="1709738"/>
+            <a:ext cx="10515600" cy="2852737"/>
+          </a:xfrm>
+        </p:spPr>
         <p:txBody>
           <a:bodyPr/>
           <a:lstStyle/>
@@ -5003,96 +4809,7 @@
             </a:pPr>
             <a:r>
               <a:rPr/>
-              <a:t>트랙 간 흐름</a:t>
-            </a:r>
-          </a:p>
-        </p:txBody>
-      </p:sp>
-      <p:sp>
-        <p:nvSpPr>
-          <p:cNvPr id="3" name="Content Placeholder 2">
-            <a:extLst>
-              <a:ext uri="{FF2B5EF4-FFF2-40B4-BE49-F238E27FC236}">
-                <a16:creationId xmlns:a16="http://schemas.microsoft.com/office/drawing/2014/main" id="{CF466120-0A55-3491-F9FC-FA77E459C46D}"/>
-              </a:ext>
-            </a:extLst>
-          </p:cNvPr>
-          <p:cNvSpPr>
-            <a:spLocks noGrp="1"/>
-          </p:cNvSpPr>
-          <p:nvPr>
-            <p:ph idx="1"/>
-          </p:nvPr>
-        </p:nvSpPr>
-        <p:spPr/>
-        <p:txBody>
-          <a:bodyPr/>
-          <a:lstStyle/>
-          <a:p>
-            <a:pPr lvl="0" indent="-457200" marL="457200">
-              <a:buAutoNum type="arabicPeriod"/>
-            </a:pPr>
-            <a:r>
-              <a:rPr b="1"/>
-              <a:t>큐레이션 트랙</a:t>
-            </a:r>
-            <a:r>
-              <a:rPr/>
-              <a:t>이 평가 쿼리와 난이도 좌표를 만듭니다 (</a:t>
-            </a:r>
-            <a:r>
-              <a:rPr>
-                <a:latin typeface="Courier"/>
-              </a:rPr>
-              <a:t>results/benchmark/</a:t>
-            </a:r>
-            <a:r>
-              <a:rPr/>
-              <a:t>).</a:t>
-            </a:r>
-          </a:p>
-          <a:p>
-            <a:pPr lvl="0" indent="-457200" marL="457200">
-              <a:buAutoNum type="arabicPeriod"/>
-            </a:pPr>
-            <a:r>
-              <a:rPr b="1"/>
-              <a:t>ML과 보정 트랙</a:t>
-            </a:r>
-            <a:r>
-              <a:rPr/>
-              <a:t>이 같은 쿼리로 조건 A와 F를 돌리고, conformal 절차를 구현합니다.</a:t>
-            </a:r>
-          </a:p>
-          <a:p>
-            <a:pPr lvl="0" indent="-457200" marL="457200">
-              <a:buAutoNum type="arabicPeriod"/>
-            </a:pPr>
-            <a:r>
-              <a:rPr b="1"/>
-              <a:t>에이전트 트랙</a:t>
-            </a:r>
-            <a:r>
-              <a:rPr/>
-              <a:t>이 같은 쿼리로 조건 B, C, D를 돌리고 신뢰도 로그를 남깁니다.</a:t>
-            </a:r>
-          </a:p>
-          <a:p>
-            <a:pPr lvl="0" indent="-457200" marL="457200">
-              <a:buAutoNum type="arabicPeriod"/>
-            </a:pPr>
-            <a:r>
-              <a:rPr/>
-              <a:t>조건 E는 에이전트 신뢰도 로그에 ML 트랙의 conformal 절차를 씌운 것입니다.</a:t>
-            </a:r>
-          </a:p>
-          <a:p>
-            <a:pPr lvl="0" indent="-457200" marL="457200">
-              <a:buAutoNum type="arabicPeriod"/>
-            </a:pPr>
-            <a:r>
-              <a:rPr/>
-              <a:t>모든 조건의 출력을 난이도 좌표로 층화해 비교합니다.</a:t>
+              <a:t>INPUT &amp; OUTPUT</a:t>
             </a:r>
           </a:p>
         </p:txBody>
@@ -5220,9 +4937,7 @@
             </a:r>
           </a:p>
           <a:p>
-            <a:pPr lvl="0" indent="0" marL="0">
-              <a:buNone/>
-            </a:pPr>
+            <a:pPr lvl="0"/>
             <a:r>
               <a:rPr b="1"/>
               <a:t>오늘의 목표:</a:t>
@@ -5233,12 +4948,10 @@
             </a:r>
           </a:p>
           <a:p>
-            <a:pPr lvl="0" indent="0" marL="0">
-              <a:buNone/>
-            </a:pPr>
+            <a:pPr lvl="0"/>
             <a:r>
               <a:rPr b="1"/>
-              <a:t>다음 미팅 전 목표:</a:t>
+              <a:t>HW:</a:t>
             </a:r>
             <a:r>
               <a:rPr/>
@@ -5295,7 +5008,7 @@
             </a:pPr>
             <a:r>
               <a:rPr/>
-              <a:t>큐레이션 트랙</a:t>
+              <a:t>모든 조건 공통</a:t>
             </a:r>
           </a:p>
         </p:txBody>
@@ -5321,9 +5034,8 @@
                 <a:tableStyleId>{5C22544A-7EE6-4342-B048-85BDC9FD1C3A}</a:tableStyleId>
               </a:tblPr>
               <a:tblGrid>
-                <a:gridCol w="3505200"/>
-                <a:gridCol w="3505200"/>
-                <a:gridCol w="3505200"/>
+                <a:gridCol w="5257800"/>
+                <a:gridCol w="5257800"/>
               </a:tblGrid>
               <a:tr h="0">
                 <a:tc>
@@ -5336,7 +5048,7 @@
                       </a:pPr>
                       <a:r>
                         <a:rPr/>
-                        <a:t>단계</a:t>
+                        <a:t>항목</a:t>
                       </a:r>
                     </a:p>
                   </a:txBody>
@@ -5352,23 +5064,7 @@
                       </a:pPr>
                       <a:r>
                         <a:rPr/>
-                        <a:t>입력</a:t>
-                      </a:r>
-                    </a:p>
-                  </a:txBody>
-                  <a:tcPr/>
-                </a:tc>
-                <a:tc>
-                  <a:txBody>
-                    <a:bodyPr/>
-                    <a:lstStyle/>
-                    <a:p>
-                      <a:pPr lvl="0" indent="0" marL="0">
-                        <a:buNone/>
-                      </a:pPr>
-                      <a:r>
-                        <a:rPr/>
-                        <a:t>출력</a:t>
+                        <a:t>정의</a:t>
                       </a:r>
                     </a:p>
                   </a:txBody>
@@ -5386,7 +5082,183 @@
                       </a:pPr>
                       <a:r>
                         <a:rPr/>
-                        <a:t>쿼리 선정</a:t>
+                        <a:t>입력</a:t>
+                      </a:r>
+                    </a:p>
+                  </a:txBody>
+                </a:tc>
+                <a:tc>
+                  <a:txBody>
+                    <a:bodyPr/>
+                    <a:lstStyle/>
+                    <a:p>
+                      <a:pPr lvl="0" indent="0" marL="0">
+                        <a:buNone/>
+                      </a:pPr>
+                      <a:r>
+                        <a:rPr/>
+                        <a:t>단백질 서열 + 화합물 SMILES만. 타겟 식별자(UniProt ID 등)는 주지 않습니다</a:t>
+                      </a:r>
+                    </a:p>
+                  </a:txBody>
+                </a:tc>
+              </a:tr>
+              <a:tr h="0">
+                <a:tc>
+                  <a:txBody>
+                    <a:bodyPr/>
+                    <a:lstStyle/>
+                    <a:p>
+                      <a:pPr lvl="0" indent="0" marL="0">
+                        <a:buNone/>
+                      </a:pPr>
+                      <a:r>
+                        <a:rPr/>
+                        <a:t>주 결정</a:t>
+                      </a:r>
+                    </a:p>
+                  </a:txBody>
+                </a:tc>
+                <a:tc>
+                  <a:txBody>
+                    <a:bodyPr/>
+                    <a:lstStyle/>
+                    <a:p>
+                      <a:pPr lvl="0" indent="0" marL="0">
+                        <a:buNone/>
+                      </a:pPr>
+                      <a:r>
+                        <a:rPr/>
+                        <a:t>결합 여부 </a:t>
+                      </a:r>
+                      <a:r>
+                        <a:rPr>
+                          <a:latin typeface="Courier"/>
+                        </a:rPr>
+                        <a:t>binds</a:t>
+                      </a:r>
+                      <a:r>
+                        <a:rPr/>
+                        <a:t>. pAffinity ≥ 6.0 (Kd / Ki / IC50 ≤ 1 µM)이면 true</a:t>
+                      </a:r>
+                    </a:p>
+                  </a:txBody>
+                </a:tc>
+              </a:tr>
+              <a:tr h="0">
+                <a:tc>
+                  <a:txBody>
+                    <a:bodyPr/>
+                    <a:lstStyle/>
+                    <a:p>
+                      <a:pPr lvl="0" indent="0" marL="0">
+                        <a:buNone/>
+                      </a:pPr>
+                      <a:r>
+                        <a:rPr/>
+                        <a:t>출력</a:t>
+                      </a:r>
+                    </a:p>
+                  </a:txBody>
+                </a:tc>
+                <a:tc>
+                  <a:txBody>
+                    <a:bodyPr/>
+                    <a:lstStyle/>
+                    <a:p>
+                      <a:pPr lvl="0" indent="0" marL="0">
+                        <a:buNone/>
+                      </a:pPr>
+                      <a:r>
+                        <a:rPr>
+                          <a:latin typeface="Courier"/>
+                        </a:rPr>
+                        <a:t>binds</a:t>
+                      </a:r>
+                      <a:r>
+                        <a:rPr/>
+                        <a:t>와 신뢰도, 또는 기권</a:t>
+                      </a:r>
+                    </a:p>
+                  </a:txBody>
+                </a:tc>
+              </a:tr>
+              <a:tr h="0">
+                <a:tc>
+                  <a:txBody>
+                    <a:bodyPr/>
+                    <a:lstStyle/>
+                    <a:p>
+                      <a:pPr lvl="0" indent="0" marL="0">
+                        <a:buNone/>
+                      </a:pPr>
+                      <a:r>
+                        <a:rPr/>
+                        <a:t>주 지표</a:t>
+                      </a:r>
+                    </a:p>
+                  </a:txBody>
+                </a:tc>
+                <a:tc>
+                  <a:txBody>
+                    <a:bodyPr/>
+                    <a:lstStyle/>
+                    <a:p>
+                      <a:pPr lvl="0" indent="0" marL="0">
+                        <a:buNone/>
+                      </a:pPr>
+                      <a:r>
+                        <a:rPr/>
+                        <a:t>AURC, coverage 80%에서의 selective accuracy</a:t>
+                      </a:r>
+                    </a:p>
+                  </a:txBody>
+                </a:tc>
+              </a:tr>
+              <a:tr h="0">
+                <a:tc>
+                  <a:txBody>
+                    <a:bodyPr/>
+                    <a:lstStyle/>
+                    <a:p>
+                      <a:pPr lvl="0" indent="0" marL="0">
+                        <a:buNone/>
+                      </a:pPr>
+                      <a:r>
+                        <a:rPr/>
+                        <a:t>보조</a:t>
+                      </a:r>
+                    </a:p>
+                  </a:txBody>
+                </a:tc>
+                <a:tc>
+                  <a:txBody>
+                    <a:bodyPr/>
+                    <a:lstStyle/>
+                    <a:p>
+                      <a:pPr lvl="0" indent="0" marL="0">
+                        <a:buNone/>
+                      </a:pPr>
+                      <a:r>
+                        <a:rPr/>
+                        <a:t>회귀(pAffinity). Ki와 Kd 정확값 부분집합에서만 보고</a:t>
+                      </a:r>
+                    </a:p>
+                  </a:txBody>
+                </a:tc>
+              </a:tr>
+              <a:tr h="0">
+                <a:tc>
+                  <a:txBody>
+                    <a:bodyPr/>
+                    <a:lstStyle/>
+                    <a:p>
+                      <a:pPr lvl="0" indent="0" marL="0">
+                        <a:buNone/>
+                      </a:pPr>
+                      <a:r>
+                        <a:rPr/>
+                        <a:t>데이터</a:t>
                       </a:r>
                     </a:p>
                   </a:txBody>
@@ -5411,183 +5283,49 @@
                       </a:r>
                       <a:r>
                         <a:rPr/>
-                        <a:t> CC BY 부분 (Articles + Patents)</a:t>
-                      </a:r>
-                    </a:p>
-                  </a:txBody>
-                </a:tc>
-                <a:tc>
-                  <a:txBody>
-                    <a:bodyPr/>
-                    <a:lstStyle/>
-                    <a:p>
-                      <a:pPr lvl="0" indent="0" marL="0">
-                        <a:buNone/>
-                      </a:pPr>
-                      <a:r>
-                        <a:rPr/>
-                        <a:t>평가 쿼리 60-100개 (서열, SMILES, 정답 </a:t>
+                        <a:t> 스냅샷의 CC BY 4.0 부분 (1,436,782행)</a:t>
+                      </a:r>
+                    </a:p>
+                  </a:txBody>
+                </a:tc>
+              </a:tr>
+              <a:tr h="0">
+                <a:tc>
+                  <a:txBody>
+                    <a:bodyPr/>
+                    <a:lstStyle/>
+                    <a:p>
+                      <a:pPr lvl="0" indent="0" marL="0">
+                        <a:buNone/>
+                      </a:pPr>
+                      <a:r>
+                        <a:rPr/>
+                        <a:t>음성</a:t>
+                      </a:r>
+                    </a:p>
+                  </a:txBody>
+                </a:tc>
+                <a:tc>
+                  <a:txBody>
+                    <a:bodyPr/>
+                    <a:lstStyle/>
+                    <a:p>
+                      <a:pPr lvl="0" indent="0" marL="0">
+                        <a:buNone/>
+                      </a:pPr>
+                      <a:r>
+                        <a:rPr/>
+                        <a:t>검열값 </a:t>
                       </a:r>
                       <a:r>
                         <a:rPr>
                           <a:latin typeface="Courier"/>
                         </a:rPr>
-                        <a:t>binds</a:t>
-                      </a:r>
-                      <a:r>
-                        <a:rPr/>
-                        <a:t>, 측정 종류, 출처)</a:t>
-                      </a:r>
-                    </a:p>
-                  </a:txBody>
-                </a:tc>
-              </a:tr>
-              <a:tr h="0">
-                <a:tc>
-                  <a:txBody>
-                    <a:bodyPr/>
-                    <a:lstStyle/>
-                    <a:p>
-                      <a:pPr lvl="0" indent="0" marL="0">
-                        <a:buNone/>
-                      </a:pPr>
-                      <a:r>
-                        <a:rPr/>
-                        <a:t>포함 기준</a:t>
-                      </a:r>
-                    </a:p>
-                  </a:txBody>
-                </a:tc>
-                <a:tc>
-                  <a:txBody>
-                    <a:bodyPr/>
-                    <a:lstStyle/>
-                    <a:p>
-                      <a:pPr lvl="0" indent="0" marL="0">
-                        <a:buNone/>
-                      </a:pPr>
-                      <a:r>
-                        <a:rPr/>
-                        <a:t>측정 메타데이터 (부등호, 반복 측정, 리간드 크기 등)</a:t>
-                      </a:r>
-                    </a:p>
-                  </a:txBody>
-                </a:tc>
-                <a:tc>
-                  <a:txBody>
-                    <a:bodyPr/>
-                    <a:lstStyle/>
-                    <a:p>
-                      <a:pPr lvl="0" indent="0" marL="0">
-                        <a:buNone/>
-                      </a:pPr>
-                      <a:r>
-                        <a:rPr/>
-                        <a:t>제외 및 플래그 기록</a:t>
-                      </a:r>
-                    </a:p>
-                  </a:txBody>
-                </a:tc>
-              </a:tr>
-              <a:tr h="0">
-                <a:tc>
-                  <a:txBody>
-                    <a:bodyPr/>
-                    <a:lstStyle/>
-                    <a:p>
-                      <a:pPr lvl="0" indent="0" marL="0">
-                        <a:buNone/>
-                      </a:pPr>
-                      <a:r>
-                        <a:rPr/>
-                        <a:t>좌표 계산</a:t>
-                      </a:r>
-                    </a:p>
-                  </a:txBody>
-                </a:tc>
-                <a:tc>
-                  <a:txBody>
-                    <a:bodyPr/>
-                    <a:lstStyle/>
-                    <a:p>
-                      <a:pPr lvl="0" indent="0" marL="0">
-                        <a:buNone/>
-                      </a:pPr>
-                      <a:r>
-                        <a:rPr/>
-                        <a:t>쿼리, A의 학습 split, Pharos, AlphaFold DB, PDB/SIFTS, 발행일</a:t>
-                      </a:r>
-                    </a:p>
-                  </a:txBody>
-                </a:tc>
-                <a:tc>
-                  <a:txBody>
-                    <a:bodyPr/>
-                    <a:lstStyle/>
-                    <a:p>
-                      <a:pPr lvl="0" indent="0" marL="0">
-                        <a:buNone/>
-                      </a:pPr>
-                      <a:r>
-                        <a:rPr/>
-                        <a:t>쿼리별 난이도 좌표와 유효성 플래그</a:t>
-                      </a:r>
-                    </a:p>
-                  </a:txBody>
-                </a:tc>
-              </a:tr>
-              <a:tr h="0">
-                <a:tc>
-                  <a:txBody>
-                    <a:bodyPr/>
-                    <a:lstStyle/>
-                    <a:p>
-                      <a:pPr lvl="0" indent="0" marL="0">
-                        <a:buNone/>
-                      </a:pPr>
-                      <a:r>
-                        <a:rPr/>
-                        <a:t>교차 검증</a:t>
-                      </a:r>
-                    </a:p>
-                  </a:txBody>
-                </a:tc>
-                <a:tc>
-                  <a:txBody>
-                    <a:bodyPr/>
-                    <a:lstStyle/>
-                    <a:p>
-                      <a:pPr lvl="0" indent="0" marL="0">
-                        <a:buNone/>
-                      </a:pPr>
-                      <a:r>
-                        <a:rPr/>
-                        <a:t>쿼리 초안</a:t>
-                      </a:r>
-                    </a:p>
-                  </a:txBody>
-                </a:tc>
-                <a:tc>
-                  <a:txBody>
-                    <a:bodyPr/>
-                    <a:lstStyle/>
-                    <a:p>
-                      <a:pPr lvl="0" indent="0" marL="0">
-                        <a:buNone/>
-                      </a:pPr>
-                      <a:r>
-                        <a:rPr/>
-                        <a:t>2인 검증 기록, </a:t>
-                      </a:r>
-                      <a:r>
-                        <a:rPr>
-                          <a:latin typeface="Courier"/>
-                        </a:rPr>
-                        <a:t>results/benchmark/</a:t>
-                      </a:r>
-                      <a:r>
-                        <a:rPr/>
-                        <a:t> 확정본</a:t>
+                        <a:t>&gt;10 µM</a:t>
+                      </a:r>
+                      <a:r>
+                        <a:rPr/>
+                        <a:t> + 측정된 약한 결합 (pAffinity &lt; 6). decoy 합성은 쓰지 않습니다</a:t>
                       </a:r>
                     </a:p>
                   </a:txBody>
@@ -5645,263 +5383,100 @@
             </a:pPr>
             <a:r>
               <a:rPr/>
+              <a:t>트랙 간 흐름</a:t>
+            </a:r>
+          </a:p>
+        </p:txBody>
+      </p:sp>
+      <p:sp>
+        <p:nvSpPr>
+          <p:cNvPr id="3" name="Content Placeholder 2">
+            <a:extLst>
+              <a:ext uri="{FF2B5EF4-FFF2-40B4-BE49-F238E27FC236}">
+                <a16:creationId xmlns:a16="http://schemas.microsoft.com/office/drawing/2014/main" id="{CF466120-0A55-3491-F9FC-FA77E459C46D}"/>
+              </a:ext>
+            </a:extLst>
+          </p:cNvPr>
+          <p:cNvSpPr>
+            <a:spLocks noGrp="1"/>
+          </p:cNvSpPr>
+          <p:nvPr>
+            <p:ph idx="1"/>
+          </p:nvPr>
+        </p:nvSpPr>
+        <p:spPr/>
+        <p:txBody>
+          <a:bodyPr/>
+          <a:lstStyle/>
+          <a:p>
+            <a:pPr lvl="0" indent="-457200" marL="457200">
+              <a:buAutoNum type="arabicPeriod"/>
+            </a:pPr>
+            <a:r>
+              <a:rPr b="1"/>
+              <a:t>큐레이션 트랙</a:t>
+            </a:r>
+            <a:r>
+              <a:rPr/>
+              <a:t>이 평가 쿼리와 난이도 좌표를 만듭니다 (</a:t>
+            </a:r>
+            <a:r>
+              <a:rPr>
+                <a:latin typeface="Courier"/>
+              </a:rPr>
+              <a:t>results/benchmark/</a:t>
+            </a:r>
+            <a:r>
+              <a:rPr/>
+              <a:t>).</a:t>
+            </a:r>
+          </a:p>
+          <a:p>
+            <a:pPr lvl="0" indent="-457200" marL="457200">
+              <a:buAutoNum type="arabicPeriod"/>
+            </a:pPr>
+            <a:r>
+              <a:rPr b="1"/>
               <a:t>ML과 보정 트랙</a:t>
             </a:r>
-          </a:p>
-        </p:txBody>
-      </p:sp>
-      <p:graphicFrame>
-        <p:nvGraphicFramePr>
-          <p:cNvPr id="6" name="Content Placeholder 5"/>
-          <p:cNvGraphicFramePr>
-            <a:graphicFrameLocks noGrp="1"/>
-          </p:cNvGraphicFramePr>
-          <p:nvPr>
-            <p:ph idx="1"/>
-          </p:nvPr>
-        </p:nvGraphicFramePr>
-        <p:xfrm>
-          <a:off x="838200" y="1816100"/>
-          <a:ext cx="10515600" cy="4343400"/>
-        </p:xfrm>
-        <a:graphic>
-          <a:graphicData uri="http://schemas.openxmlformats.org/drawingml/2006/table">
-            <a:tbl>
-              <a:tblPr firstRow="1" bandRow="1">
-                <a:tableStyleId>{5C22544A-7EE6-4342-B048-85BDC9FD1C3A}</a:tableStyleId>
-              </a:tblPr>
-              <a:tblGrid>
-                <a:gridCol w="3505200"/>
-                <a:gridCol w="3505200"/>
-                <a:gridCol w="3505200"/>
-              </a:tblGrid>
-              <a:tr h="0">
-                <a:tc>
-                  <a:txBody>
-                    <a:bodyPr/>
-                    <a:lstStyle/>
-                    <a:p>
-                      <a:pPr lvl="0" indent="0" marL="0">
-                        <a:buNone/>
-                      </a:pPr>
-                      <a:r>
-                        <a:rPr/>
-                        <a:t>조건</a:t>
-                      </a:r>
-                    </a:p>
-                  </a:txBody>
-                  <a:tcPr/>
-                </a:tc>
-                <a:tc>
-                  <a:txBody>
-                    <a:bodyPr/>
-                    <a:lstStyle/>
-                    <a:p>
-                      <a:pPr lvl="0" indent="0" marL="0">
-                        <a:buNone/>
-                      </a:pPr>
-                      <a:r>
-                        <a:rPr/>
-                        <a:t>입력</a:t>
-                      </a:r>
-                    </a:p>
-                  </a:txBody>
-                  <a:tcPr/>
-                </a:tc>
-                <a:tc>
-                  <a:txBody>
-                    <a:bodyPr/>
-                    <a:lstStyle/>
-                    <a:p>
-                      <a:pPr lvl="0" indent="0" marL="0">
-                        <a:buNone/>
-                      </a:pPr>
-                      <a:r>
-                        <a:rPr/>
-                        <a:t>출력</a:t>
-                      </a:r>
-                    </a:p>
-                  </a:txBody>
-                  <a:tcPr/>
-                </a:tc>
-              </a:tr>
-              <a:tr h="0">
-                <a:tc>
-                  <a:txBody>
-                    <a:bodyPr/>
-                    <a:lstStyle/>
-                    <a:p>
-                      <a:pPr lvl="0" indent="0" marL="0">
-                        <a:buNone/>
-                      </a:pPr>
-                      <a:r>
-                        <a:rPr/>
-                        <a:t>A. 보정된 baseline</a:t>
-                      </a:r>
-                    </a:p>
-                  </a:txBody>
-                </a:tc>
-                <a:tc>
-                  <a:txBody>
-                    <a:bodyPr/>
-                    <a:lstStyle/>
-                    <a:p>
-                      <a:pPr lvl="0" indent="0" marL="0">
-                        <a:buNone/>
-                      </a:pPr>
-                      <a:r>
-                        <a:rPr/>
-                        <a:t>ESM-2 단백질 임베딩, Morgan fingerprint, AlphaFold DB pocket feature, 학습 split</a:t>
-                      </a:r>
-                    </a:p>
-                  </a:txBody>
-                </a:tc>
-                <a:tc>
-                  <a:txBody>
-                    <a:bodyPr/>
-                    <a:lstStyle/>
-                    <a:p>
-                      <a:pPr lvl="0" indent="0" marL="0">
-                        <a:buNone/>
-                      </a:pPr>
-                      <a:r>
-                        <a:rPr>
-                          <a:latin typeface="Courier"/>
-                        </a:rPr>
-                        <a:t>binds</a:t>
-                      </a:r>
-                      <a:r>
-                        <a:rPr/>
-                        <a:t> 확률, conformal 예측 집합 (</a:t>
-                      </a:r>
-                      <a:r>
-                        <a:rPr>
-                          <a:latin typeface="Courier"/>
-                        </a:rPr>
-                        <a:t>{binds, not binds}</a:t>
-                      </a:r>
-                      <a:r>
-                        <a:rPr/>
-                        <a:t>이면 기권)</a:t>
-                      </a:r>
-                    </a:p>
-                  </a:txBody>
-                </a:tc>
-              </a:tr>
-              <a:tr h="0">
-                <a:tc>
-                  <a:txBody>
-                    <a:bodyPr/>
-                    <a:lstStyle/>
-                    <a:p>
-                      <a:pPr lvl="0" indent="0" marL="0">
-                        <a:buNone/>
-                      </a:pPr>
-                      <a:r>
-                        <a:rPr/>
-                        <a:t>F. Boltz-2 (GPU 조건부)</a:t>
-                      </a:r>
-                    </a:p>
-                  </a:txBody>
-                </a:tc>
-                <a:tc>
-                  <a:txBody>
-                    <a:bodyPr/>
-                    <a:lstStyle/>
-                    <a:p>
-                      <a:pPr lvl="0" indent="0" marL="0">
-                        <a:buNone/>
-                      </a:pPr>
-                      <a:r>
-                        <a:rPr/>
-                        <a:t>서열 + SMILES, 난이도 층화 200쌍</a:t>
-                      </a:r>
-                    </a:p>
-                  </a:txBody>
-                </a:tc>
-                <a:tc>
-                  <a:txBody>
-                    <a:bodyPr/>
-                    <a:lstStyle/>
-                    <a:p>
-                      <a:pPr lvl="0" indent="0" marL="0">
-                        <a:buNone/>
-                      </a:pPr>
-                      <a:r>
-                        <a:rPr>
-                          <a:latin typeface="Courier"/>
-                        </a:rPr>
-                        <a:t>affinity_probability_binary</a:t>
-                      </a:r>
-                      <a:r>
-                        <a:rPr/>
-                        <a:t>, </a:t>
-                      </a:r>
-                      <a:r>
-                        <a:rPr>
-                          <a:latin typeface="Courier"/>
-                        </a:rPr>
-                        <a:t>ligand_iptm</a:t>
-                      </a:r>
-                      <a:r>
-                        <a:rPr/>
-                        <a:t>, conformal 예측 집합</a:t>
-                      </a:r>
-                    </a:p>
-                  </a:txBody>
-                </a:tc>
-              </a:tr>
-              <a:tr h="0">
-                <a:tc>
-                  <a:txBody>
-                    <a:bodyPr/>
-                    <a:lstStyle/>
-                    <a:p>
-                      <a:pPr lvl="0" indent="0" marL="0">
-                        <a:buNone/>
-                      </a:pPr>
-                      <a:r>
-                        <a:rPr/>
-                        <a:t>E 절차</a:t>
-                      </a:r>
-                    </a:p>
-                  </a:txBody>
-                </a:tc>
-                <a:tc>
-                  <a:txBody>
-                    <a:bodyPr/>
-                    <a:lstStyle/>
-                    <a:p>
-                      <a:pPr lvl="0" indent="0" marL="0">
-                        <a:buNone/>
-                      </a:pPr>
-                      <a:r>
-                        <a:rPr/>
-                        <a:t>에이전트 트랙의 신뢰도 로그</a:t>
-                      </a:r>
-                    </a:p>
-                  </a:txBody>
-                </a:tc>
-                <a:tc>
-                  <a:txBody>
-                    <a:bodyPr/>
-                    <a:lstStyle/>
-                    <a:p>
-                      <a:pPr lvl="0" indent="0" marL="0">
-                        <a:buNone/>
-                      </a:pPr>
-                      <a:r>
-                        <a:rPr/>
-                        <a:t>A와 같은 conformal 절차를 적용한 예측 집합</a:t>
-                      </a:r>
-                    </a:p>
-                  </a:txBody>
-                </a:tc>
-              </a:tr>
-            </a:tbl>
-          </a:graphicData>
-        </a:graphic>
-      </p:graphicFrame>
+            <a:r>
+              <a:rPr/>
+              <a:t>이 같은 쿼리로 조건 A와 F를 돌리고, conformal 절차를 구현합니다.</a:t>
+            </a:r>
+          </a:p>
+          <a:p>
+            <a:pPr lvl="0" indent="-457200" marL="457200">
+              <a:buAutoNum type="arabicPeriod"/>
+            </a:pPr>
+            <a:r>
+              <a:rPr b="1"/>
+              <a:t>에이전트 트랙</a:t>
+            </a:r>
+            <a:r>
+              <a:rPr/>
+              <a:t>이 같은 쿼리로 조건 B, C, D를 돌리고 신뢰도 로그를 남깁니다.</a:t>
+            </a:r>
+          </a:p>
+          <a:p>
+            <a:pPr lvl="0" indent="-457200" marL="457200">
+              <a:buAutoNum type="arabicPeriod"/>
+            </a:pPr>
+            <a:r>
+              <a:rPr/>
+              <a:t>조건 E는 에이전트 신뢰도 로그에 ML 트랙의 conformal 절차를 씌운 것입니다.</a:t>
+            </a:r>
+          </a:p>
+          <a:p>
+            <a:pPr lvl="0" indent="-457200" marL="457200">
+              <a:buAutoNum type="arabicPeriod"/>
+            </a:pPr>
+            <a:r>
+              <a:rPr/>
+              <a:t>모든 조건의 출력을 난이도 좌표로 층화해 비교합니다.</a:t>
+            </a:r>
+          </a:p>
+        </p:txBody>
+      </p:sp>
     </p:spTree>
   </p:cSld>
 </p:sld>
@@ -5926,35 +5501,332 @@
       </p:grpSpPr>
       <p:sp>
         <p:nvSpPr>
-          <p:cNvPr id="3" name="Content Placeholder 2">
-            <a:extLst>
-              <a:ext uri="{FF2B5EF4-FFF2-40B4-BE49-F238E27FC236}">
-                <a16:creationId xmlns:a16="http://schemas.microsoft.com/office/drawing/2014/main" id="{CF466120-0A55-3491-F9FC-FA77E459C46D}"/>
-              </a:ext>
-            </a:extLst>
-          </p:cNvPr>
-          <p:cNvSpPr>
-            <a:spLocks noGrp="1"/>
-          </p:cNvSpPr>
+          <p:cNvPr id="2" name="Title 1">
+            <a:extLst>
+              <a:ext uri="{FF2B5EF4-FFF2-40B4-BE49-F238E27FC236}">
+                <a16:creationId xmlns:a16="http://schemas.microsoft.com/office/drawing/2014/main" id="{C9CE818D-09AE-4CD2-3C65-237AD773CD9F}"/>
+              </a:ext>
+            </a:extLst>
+          </p:cNvPr>
+          <p:cNvSpPr>
+            <a:spLocks noGrp="1"/>
+          </p:cNvSpPr>
+          <p:nvPr>
+            <p:ph type="title"/>
+          </p:nvPr>
+        </p:nvSpPr>
+        <p:spPr/>
+        <p:txBody>
+          <a:bodyPr/>
+          <a:lstStyle/>
+          <a:p>
+            <a:pPr lvl="0" indent="0" marL="0">
+              <a:buNone/>
+            </a:pPr>
+            <a:r>
+              <a:rPr/>
+              <a:t>큐레이션 트랙</a:t>
+            </a:r>
+          </a:p>
+        </p:txBody>
+      </p:sp>
+      <p:graphicFrame>
+        <p:nvGraphicFramePr>
+          <p:cNvPr id="6" name="Content Placeholder 5"/>
+          <p:cNvGraphicFramePr>
+            <a:graphicFrameLocks noGrp="1"/>
+          </p:cNvGraphicFramePr>
           <p:nvPr>
             <p:ph idx="1"/>
           </p:nvPr>
-        </p:nvSpPr>
-        <p:spPr/>
-        <p:txBody>
-          <a:bodyPr/>
-          <a:lstStyle/>
-          <a:p>
-            <a:pPr lvl="0" indent="0" marL="0">
-              <a:buNone/>
-            </a:pPr>
-            <a:r>
-              <a:rPr/>
-              <a:t>OpenFold3는 F에서 빠지고 구조 품질 레퍼런스로 씁니다. 조사한 co-folding 모델 7개 중 affinity를 출력하는 것은 Boltz-2뿐입니다.</a:t>
-            </a:r>
-          </a:p>
-        </p:txBody>
-      </p:sp>
+        </p:nvGraphicFramePr>
+        <p:xfrm>
+          <a:off x="838200" y="1816100"/>
+          <a:ext cx="10515600" cy="4343400"/>
+        </p:xfrm>
+        <a:graphic>
+          <a:graphicData uri="http://schemas.openxmlformats.org/drawingml/2006/table">
+            <a:tbl>
+              <a:tblPr firstRow="1" bandRow="1">
+                <a:tableStyleId>{5C22544A-7EE6-4342-B048-85BDC9FD1C3A}</a:tableStyleId>
+              </a:tblPr>
+              <a:tblGrid>
+                <a:gridCol w="3505200"/>
+                <a:gridCol w="3505200"/>
+                <a:gridCol w="3505200"/>
+              </a:tblGrid>
+              <a:tr h="0">
+                <a:tc>
+                  <a:txBody>
+                    <a:bodyPr/>
+                    <a:lstStyle/>
+                    <a:p>
+                      <a:pPr lvl="0" indent="0" marL="0">
+                        <a:buNone/>
+                      </a:pPr>
+                      <a:r>
+                        <a:rPr/>
+                        <a:t>단계</a:t>
+                      </a:r>
+                    </a:p>
+                  </a:txBody>
+                  <a:tcPr/>
+                </a:tc>
+                <a:tc>
+                  <a:txBody>
+                    <a:bodyPr/>
+                    <a:lstStyle/>
+                    <a:p>
+                      <a:pPr lvl="0" indent="0" marL="0">
+                        <a:buNone/>
+                      </a:pPr>
+                      <a:r>
+                        <a:rPr/>
+                        <a:t>입력</a:t>
+                      </a:r>
+                    </a:p>
+                  </a:txBody>
+                  <a:tcPr/>
+                </a:tc>
+                <a:tc>
+                  <a:txBody>
+                    <a:bodyPr/>
+                    <a:lstStyle/>
+                    <a:p>
+                      <a:pPr lvl="0" indent="0" marL="0">
+                        <a:buNone/>
+                      </a:pPr>
+                      <a:r>
+                        <a:rPr/>
+                        <a:t>출력</a:t>
+                      </a:r>
+                    </a:p>
+                  </a:txBody>
+                  <a:tcPr/>
+                </a:tc>
+              </a:tr>
+              <a:tr h="0">
+                <a:tc>
+                  <a:txBody>
+                    <a:bodyPr/>
+                    <a:lstStyle/>
+                    <a:p>
+                      <a:pPr lvl="0" indent="0" marL="0">
+                        <a:buNone/>
+                      </a:pPr>
+                      <a:r>
+                        <a:rPr/>
+                        <a:t>쿼리 선정</a:t>
+                      </a:r>
+                    </a:p>
+                  </a:txBody>
+                </a:tc>
+                <a:tc>
+                  <a:txBody>
+                    <a:bodyPr/>
+                    <a:lstStyle/>
+                    <a:p>
+                      <a:pPr lvl="0" indent="0" marL="0">
+                        <a:buNone/>
+                      </a:pPr>
+                      <a:r>
+                        <a:rPr/>
+                        <a:t>BindingDB </a:t>
+                      </a:r>
+                      <a:r>
+                        <a:rPr>
+                          <a:latin typeface="Courier"/>
+                        </a:rPr>
+                        <a:t>202610</a:t>
+                      </a:r>
+                      <a:r>
+                        <a:rPr/>
+                        <a:t> CC BY 부분 (Articles + Patents)</a:t>
+                      </a:r>
+                    </a:p>
+                  </a:txBody>
+                </a:tc>
+                <a:tc>
+                  <a:txBody>
+                    <a:bodyPr/>
+                    <a:lstStyle/>
+                    <a:p>
+                      <a:pPr lvl="0" indent="0" marL="0">
+                        <a:buNone/>
+                      </a:pPr>
+                      <a:r>
+                        <a:rPr/>
+                        <a:t>평가 쿼리 60-100개 (서열, SMILES, 정답 </a:t>
+                      </a:r>
+                      <a:r>
+                        <a:rPr>
+                          <a:latin typeface="Courier"/>
+                        </a:rPr>
+                        <a:t>binds</a:t>
+                      </a:r>
+                      <a:r>
+                        <a:rPr/>
+                        <a:t>, 측정 종류, 출처)</a:t>
+                      </a:r>
+                    </a:p>
+                  </a:txBody>
+                </a:tc>
+              </a:tr>
+              <a:tr h="0">
+                <a:tc>
+                  <a:txBody>
+                    <a:bodyPr/>
+                    <a:lstStyle/>
+                    <a:p>
+                      <a:pPr lvl="0" indent="0" marL="0">
+                        <a:buNone/>
+                      </a:pPr>
+                      <a:r>
+                        <a:rPr/>
+                        <a:t>포함 기준</a:t>
+                      </a:r>
+                    </a:p>
+                  </a:txBody>
+                </a:tc>
+                <a:tc>
+                  <a:txBody>
+                    <a:bodyPr/>
+                    <a:lstStyle/>
+                    <a:p>
+                      <a:pPr lvl="0" indent="0" marL="0">
+                        <a:buNone/>
+                      </a:pPr>
+                      <a:r>
+                        <a:rPr/>
+                        <a:t>측정 메타데이터 (부등호, 반복 측정, 리간드 크기 등)</a:t>
+                      </a:r>
+                    </a:p>
+                  </a:txBody>
+                </a:tc>
+                <a:tc>
+                  <a:txBody>
+                    <a:bodyPr/>
+                    <a:lstStyle/>
+                    <a:p>
+                      <a:pPr lvl="0" indent="0" marL="0">
+                        <a:buNone/>
+                      </a:pPr>
+                      <a:r>
+                        <a:rPr/>
+                        <a:t>제외 및 플래그 기록</a:t>
+                      </a:r>
+                    </a:p>
+                  </a:txBody>
+                </a:tc>
+              </a:tr>
+              <a:tr h="0">
+                <a:tc>
+                  <a:txBody>
+                    <a:bodyPr/>
+                    <a:lstStyle/>
+                    <a:p>
+                      <a:pPr lvl="0" indent="0" marL="0">
+                        <a:buNone/>
+                      </a:pPr>
+                      <a:r>
+                        <a:rPr/>
+                        <a:t>좌표 계산</a:t>
+                      </a:r>
+                    </a:p>
+                  </a:txBody>
+                </a:tc>
+                <a:tc>
+                  <a:txBody>
+                    <a:bodyPr/>
+                    <a:lstStyle/>
+                    <a:p>
+                      <a:pPr lvl="0" indent="0" marL="0">
+                        <a:buNone/>
+                      </a:pPr>
+                      <a:r>
+                        <a:rPr/>
+                        <a:t>쿼리, A의 학습 split, Pharos, AlphaFold DB, PDB/SIFTS, 발행일</a:t>
+                      </a:r>
+                    </a:p>
+                  </a:txBody>
+                </a:tc>
+                <a:tc>
+                  <a:txBody>
+                    <a:bodyPr/>
+                    <a:lstStyle/>
+                    <a:p>
+                      <a:pPr lvl="0" indent="0" marL="0">
+                        <a:buNone/>
+                      </a:pPr>
+                      <a:r>
+                        <a:rPr/>
+                        <a:t>쿼리별 난이도 좌표와 유효성 플래그</a:t>
+                      </a:r>
+                    </a:p>
+                  </a:txBody>
+                </a:tc>
+              </a:tr>
+              <a:tr h="0">
+                <a:tc>
+                  <a:txBody>
+                    <a:bodyPr/>
+                    <a:lstStyle/>
+                    <a:p>
+                      <a:pPr lvl="0" indent="0" marL="0">
+                        <a:buNone/>
+                      </a:pPr>
+                      <a:r>
+                        <a:rPr/>
+                        <a:t>교차 검증</a:t>
+                      </a:r>
+                    </a:p>
+                  </a:txBody>
+                </a:tc>
+                <a:tc>
+                  <a:txBody>
+                    <a:bodyPr/>
+                    <a:lstStyle/>
+                    <a:p>
+                      <a:pPr lvl="0" indent="0" marL="0">
+                        <a:buNone/>
+                      </a:pPr>
+                      <a:r>
+                        <a:rPr/>
+                        <a:t>쿼리 초안</a:t>
+                      </a:r>
+                    </a:p>
+                  </a:txBody>
+                </a:tc>
+                <a:tc>
+                  <a:txBody>
+                    <a:bodyPr/>
+                    <a:lstStyle/>
+                    <a:p>
+                      <a:pPr lvl="0" indent="0" marL="0">
+                        <a:buNone/>
+                      </a:pPr>
+                      <a:r>
+                        <a:rPr/>
+                        <a:t>2인 검증 기록, </a:t>
+                      </a:r>
+                      <a:r>
+                        <a:rPr>
+                          <a:latin typeface="Courier"/>
+                        </a:rPr>
+                        <a:t>results/benchmark/</a:t>
+                      </a:r>
+                      <a:r>
+                        <a:rPr/>
+                        <a:t> 확정본</a:t>
+                      </a:r>
+                    </a:p>
+                  </a:txBody>
+                </a:tc>
+              </a:tr>
+            </a:tbl>
+          </a:graphicData>
+        </a:graphic>
+      </p:graphicFrame>
     </p:spTree>
   </p:cSld>
 </p:sld>
@@ -6003,7 +5875,7 @@
             </a:pPr>
             <a:r>
               <a:rPr/>
-              <a:t>에이전트 트랙</a:t>
+              <a:t>ML과 보정 트랙</a:t>
             </a:r>
           </a:p>
         </p:txBody>
@@ -6076,7 +5948,7 @@
                       </a:pPr>
                       <a:r>
                         <a:rPr/>
-                        <a:t>출력 (JSON)</a:t>
+                        <a:t>출력</a:t>
                       </a:r>
                     </a:p>
                   </a:txBody>
@@ -6094,22 +5966,22 @@
                       </a:pPr>
                       <a:r>
                         <a:rPr/>
-                        <a:t>B. Zero-shot LLM</a:t>
-                      </a:r>
-                    </a:p>
-                  </a:txBody>
-                </a:tc>
-                <a:tc>
-                  <a:txBody>
-                    <a:bodyPr/>
-                    <a:lstStyle/>
-                    <a:p>
-                      <a:pPr lvl="0" indent="0" marL="0">
-                        <a:buNone/>
-                      </a:pPr>
-                      <a:r>
-                        <a:rPr/>
-                        <a:t>서열 + SMILES, 도구 없음</a:t>
+                        <a:t>A. 보정된 baseline</a:t>
+                      </a:r>
+                    </a:p>
+                  </a:txBody>
+                </a:tc>
+                <a:tc>
+                  <a:txBody>
+                    <a:bodyPr/>
+                    <a:lstStyle/>
+                    <a:p>
+                      <a:pPr lvl="0" indent="0" marL="0">
+                        <a:buNone/>
+                      </a:pPr>
+                      <a:r>
+                        <a:rPr/>
+                        <a:t>ESM-2 단백질 임베딩, Morgan fingerprint, AlphaFold DB pocket feature, 학습 split</a:t>
                       </a:r>
                     </a:p>
                   </a:txBody>
@@ -6130,23 +6002,66 @@
                       </a:r>
                       <a:r>
                         <a:rPr/>
-                        <a:t>, </a:t>
+                        <a:t> 확률, conformal 예측 집합 (</a:t>
                       </a:r>
                       <a:r>
                         <a:rPr>
                           <a:latin typeface="Courier"/>
                         </a:rPr>
-                        <a:t>confidence</a:t>
-                      </a:r>
-                      <a:r>
-                        <a:rPr/>
-                        <a:t>, </a:t>
-                      </a:r>
+                        <a:t>{binds, not binds}</a:t>
+                      </a:r>
+                      <a:r>
+                        <a:rPr/>
+                        <a:t>이면 기권)</a:t>
+                      </a:r>
+                    </a:p>
+                  </a:txBody>
+                </a:tc>
+              </a:tr>
+              <a:tr h="0">
+                <a:tc>
+                  <a:txBody>
+                    <a:bodyPr/>
+                    <a:lstStyle/>
+                    <a:p>
+                      <a:pPr lvl="0" indent="0" marL="0">
+                        <a:buNone/>
+                      </a:pPr>
+                      <a:r>
+                        <a:rPr/>
+                        <a:t>F. Boltz-2 (GPU 조건부)</a:t>
+                      </a:r>
+                    </a:p>
+                  </a:txBody>
+                </a:tc>
+                <a:tc>
+                  <a:txBody>
+                    <a:bodyPr/>
+                    <a:lstStyle/>
+                    <a:p>
+                      <a:pPr lvl="0" indent="0" marL="0">
+                        <a:buNone/>
+                      </a:pPr>
+                      <a:r>
+                        <a:rPr/>
+                        <a:t>서열 + SMILES, 난이도 층화 200쌍</a:t>
+                      </a:r>
+                    </a:p>
+                  </a:txBody>
+                </a:tc>
+                <a:tc>
+                  <a:txBody>
+                    <a:bodyPr/>
+                    <a:lstStyle/>
+                    <a:p>
+                      <a:pPr lvl="0" indent="0" marL="0">
+                        <a:buNone/>
+                      </a:pPr>
                       <a:r>
                         <a:rPr>
                           <a:latin typeface="Courier"/>
                         </a:rPr>
-                        <a:t>pAffinity</a:t>
+                        <a:t>affinity_probability_binary</a:t>
                       </a:r>
                       <a:r>
                         <a:rPr/>
@@ -6156,7 +6071,11 @@
                         <a:rPr>
                           <a:latin typeface="Courier"/>
                         </a:rPr>
-                        <a:t>reasoning</a:t>
+                        <a:t>ligand_iptm</a:t>
+                      </a:r>
+                      <a:r>
+                        <a:rPr/>
+                        <a:t>, conformal 예측 집합</a:t>
                       </a:r>
                     </a:p>
                   </a:txBody>
@@ -6173,210 +6092,37 @@
                       </a:pPr>
                       <a:r>
                         <a:rPr/>
-                        <a:t>C. Agent</a:t>
-                      </a:r>
-                    </a:p>
-                  </a:txBody>
-                </a:tc>
-                <a:tc>
-                  <a:txBody>
-                    <a:bodyPr/>
-                    <a:lstStyle/>
-                    <a:p>
-                      <a:pPr lvl="0" indent="0" marL="0">
-                        <a:buNone/>
-                      </a:pPr>
-                      <a:r>
-                        <a:rPr/>
-                        <a:t>서열 + SMILES, ToolUniverse MCP 도구</a:t>
-                      </a:r>
-                    </a:p>
-                  </a:txBody>
-                </a:tc>
-                <a:tc>
-                  <a:txBody>
-                    <a:bodyPr/>
-                    <a:lstStyle/>
-                    <a:p>
-                      <a:pPr lvl="0" indent="0" marL="0">
-                        <a:buNone/>
-                      </a:pPr>
-                      <a:r>
-                        <a:rPr/>
-                        <a:t>B 필드 + </a:t>
-                      </a:r>
-                      <a:r>
-                        <a:rPr>
-                          <a:latin typeface="Courier"/>
-                        </a:rPr>
-                        <a:t>identified_target</a:t>
-                      </a:r>
-                      <a:r>
-                        <a:rPr/>
-                        <a:t>, </a:t>
-                      </a:r>
-                      <a:r>
-                        <a:rPr>
-                          <a:latin typeface="Courier"/>
-                        </a:rPr>
-                        <a:t>direct_measurement_found</a:t>
-                      </a:r>
-                      <a:r>
-                        <a:rPr/>
-                        <a:t>, </a:t>
-                      </a:r>
-                      <a:r>
-                        <a:rPr>
-                          <a:latin typeface="Courier"/>
-                        </a:rPr>
-                        <a:t>evidence</a:t>
-                      </a:r>
-                    </a:p>
-                  </a:txBody>
-                </a:tc>
-              </a:tr>
-              <a:tr h="0">
-                <a:tc>
-                  <a:txBody>
-                    <a:bodyPr/>
-                    <a:lstStyle/>
-                    <a:p>
-                      <a:pPr lvl="0" indent="0" marL="0">
-                        <a:buNone/>
-                      </a:pPr>
-                      <a:r>
-                        <a:rPr/>
-                        <a:t>D. Agent + 기권</a:t>
-                      </a:r>
-                    </a:p>
-                  </a:txBody>
-                </a:tc>
-                <a:tc>
-                  <a:txBody>
-                    <a:bodyPr/>
-                    <a:lstStyle/>
-                    <a:p>
-                      <a:pPr lvl="0" indent="0" marL="0">
-                        <a:buNone/>
-                      </a:pPr>
-                      <a:r>
-                        <a:rPr/>
-                        <a:t>C와 같음, 기권 허용</a:t>
-                      </a:r>
-                    </a:p>
-                  </a:txBody>
-                </a:tc>
-                <a:tc>
-                  <a:txBody>
-                    <a:bodyPr/>
-                    <a:lstStyle/>
-                    <a:p>
-                      <a:pPr lvl="0" indent="0" marL="0">
-                        <a:buNone/>
-                      </a:pPr>
-                      <a:r>
-                        <a:rPr/>
-                        <a:t>C 필드 + </a:t>
-                      </a:r>
-                      <a:r>
-                        <a:rPr>
-                          <a:latin typeface="Courier"/>
-                        </a:rPr>
-                        <a:t>abstain</a:t>
-                      </a:r>
-                    </a:p>
-                  </a:txBody>
-                </a:tc>
-              </a:tr>
-              <a:tr h="0">
-                <a:tc>
-                  <a:txBody>
-                    <a:bodyPr/>
-                    <a:lstStyle/>
-                    <a:p>
-                      <a:pPr lvl="0" indent="0" marL="0">
-                        <a:buNone/>
-                      </a:pPr>
-                      <a:r>
-                        <a:rPr/>
-                        <a:t>반복 실행</a:t>
-                      </a:r>
-                    </a:p>
-                  </a:txBody>
-                </a:tc>
-                <a:tc>
-                  <a:txBody>
-                    <a:bodyPr/>
-                    <a:lstStyle/>
-                    <a:p>
-                      <a:pPr lvl="0" indent="0" marL="0">
-                        <a:buNone/>
-                      </a:pPr>
-                      <a:r>
-                        <a:rPr/>
-                        <a:t>같은 쿼리 3회, temperature 0.7</a:t>
-                      </a:r>
-                    </a:p>
-                  </a:txBody>
-                </a:tc>
-                <a:tc>
-                  <a:txBody>
-                    <a:bodyPr/>
-                    <a:lstStyle/>
-                    <a:p>
-                      <a:pPr lvl="0" indent="0" marL="0">
-                        <a:buNone/>
-                      </a:pPr>
-                      <a:r>
-                        <a:rPr/>
-                        <a:t>flip rate, 조건 E용 신뢰도 로그, 토큰·지연·비용</a:t>
-                      </a:r>
-                    </a:p>
-                  </a:txBody>
-                </a:tc>
-              </a:tr>
-              <a:tr h="0">
-                <a:tc>
-                  <a:txBody>
-                    <a:bodyPr/>
-                    <a:lstStyle/>
-                    <a:p>
-                      <a:pPr lvl="0" indent="0" marL="0">
-                        <a:buNone/>
-                      </a:pPr>
-                      <a:r>
-                        <a:rPr/>
-                        <a:t>교란 감사</a:t>
-                      </a:r>
-                    </a:p>
-                  </a:txBody>
-                </a:tc>
-                <a:tc>
-                  <a:txBody>
-                    <a:bodyPr/>
-                    <a:lstStyle/>
-                    <a:p>
-                      <a:pPr lvl="0" indent="0" marL="0">
-                        <a:buNone/>
-                      </a:pPr>
-                      <a:r>
-                        <a:rPr/>
-                        <a:t>도구 출력에 오류 4종 주입 (단위, 엔트리, 동일성, 식별자)</a:t>
-                      </a:r>
-                    </a:p>
-                  </a:txBody>
-                </a:tc>
-                <a:tc>
-                  <a:txBody>
-                    <a:bodyPr/>
-                    <a:lstStyle/>
-                    <a:p>
-                      <a:pPr lvl="0" indent="0" marL="0">
-                        <a:buNone/>
-                      </a:pPr>
-                      <a:r>
-                        <a:rPr/>
-                        <a:t>교란 탐지율</a:t>
+                        <a:t>E 절차</a:t>
+                      </a:r>
+                    </a:p>
+                  </a:txBody>
+                </a:tc>
+                <a:tc>
+                  <a:txBody>
+                    <a:bodyPr/>
+                    <a:lstStyle/>
+                    <a:p>
+                      <a:pPr lvl="0" indent="0" marL="0">
+                        <a:buNone/>
+                      </a:pPr>
+                      <a:r>
+                        <a:rPr/>
+                        <a:t>에이전트 트랙의 신뢰도 로그</a:t>
+                      </a:r>
+                    </a:p>
+                  </a:txBody>
+                </a:tc>
+                <a:tc>
+                  <a:txBody>
+                    <a:bodyPr/>
+                    <a:lstStyle/>
+                    <a:p>
+                      <a:pPr lvl="0" indent="0" marL="0">
+                        <a:buNone/>
+                      </a:pPr>
+                      <a:r>
+                        <a:rPr/>
+                        <a:t>A와 같은 conformal 절차를 적용한 예측 집합</a:t>
                       </a:r>
                     </a:p>
                   </a:txBody>
@@ -6392,6 +6138,490 @@
 </file>
 
 <file path=ppt/slides/slide24.xml><?xml version="1.0" encoding="utf-8"?>
+<p:sld xmlns:a="http://schemas.openxmlformats.org/drawingml/2006/main" xmlns:r="http://schemas.openxmlformats.org/officeDocument/2006/relationships" xmlns:p="http://schemas.openxmlformats.org/presentationml/2006/main">
+  <p:cSld>
+    <p:spTree>
+      <p:nvGrpSpPr>
+        <p:cNvPr id="1" name=""/>
+        <p:cNvGrpSpPr/>
+        <p:nvPr/>
+      </p:nvGrpSpPr>
+      <p:grpSpPr>
+        <a:xfrm>
+          <a:off x="0" y="0"/>
+          <a:ext cx="0" cy="0"/>
+          <a:chOff x="0" y="0"/>
+          <a:chExt cx="0" cy="0"/>
+        </a:xfrm>
+      </p:grpSpPr>
+      <p:sp>
+        <p:nvSpPr>
+          <p:cNvPr id="3" name="Content Placeholder 2">
+            <a:extLst>
+              <a:ext uri="{FF2B5EF4-FFF2-40B4-BE49-F238E27FC236}">
+                <a16:creationId xmlns:a16="http://schemas.microsoft.com/office/drawing/2014/main" id="{CF466120-0A55-3491-F9FC-FA77E459C46D}"/>
+              </a:ext>
+            </a:extLst>
+          </p:cNvPr>
+          <p:cNvSpPr>
+            <a:spLocks noGrp="1"/>
+          </p:cNvSpPr>
+          <p:nvPr>
+            <p:ph idx="1"/>
+          </p:nvPr>
+        </p:nvSpPr>
+        <p:spPr/>
+        <p:txBody>
+          <a:bodyPr/>
+          <a:lstStyle/>
+          <a:p>
+            <a:pPr lvl="0" indent="0" marL="0">
+              <a:buNone/>
+            </a:pPr>
+            <a:r>
+              <a:rPr/>
+              <a:t>OpenFold3는 F에서 빠지고 구조 품질 레퍼런스로 씁니다. 조사한 co-folding 모델 7개 중 affinity를 출력하는 것은 Boltz-2뿐입니다.</a:t>
+            </a:r>
+          </a:p>
+        </p:txBody>
+      </p:sp>
+    </p:spTree>
+  </p:cSld>
+</p:sld>
+</file>
+
+<file path=ppt/slides/slide25.xml><?xml version="1.0" encoding="utf-8"?>
+<p:sld xmlns:a="http://schemas.openxmlformats.org/drawingml/2006/main" xmlns:r="http://schemas.openxmlformats.org/officeDocument/2006/relationships" xmlns:p="http://schemas.openxmlformats.org/presentationml/2006/main">
+  <p:cSld>
+    <p:spTree>
+      <p:nvGrpSpPr>
+        <p:cNvPr id="1" name=""/>
+        <p:cNvGrpSpPr/>
+        <p:nvPr/>
+      </p:nvGrpSpPr>
+      <p:grpSpPr>
+        <a:xfrm>
+          <a:off x="0" y="0"/>
+          <a:ext cx="0" cy="0"/>
+          <a:chOff x="0" y="0"/>
+          <a:chExt cx="0" cy="0"/>
+        </a:xfrm>
+      </p:grpSpPr>
+      <p:sp>
+        <p:nvSpPr>
+          <p:cNvPr id="2" name="Title 1">
+            <a:extLst>
+              <a:ext uri="{FF2B5EF4-FFF2-40B4-BE49-F238E27FC236}">
+                <a16:creationId xmlns:a16="http://schemas.microsoft.com/office/drawing/2014/main" id="{C9CE818D-09AE-4CD2-3C65-237AD773CD9F}"/>
+              </a:ext>
+            </a:extLst>
+          </p:cNvPr>
+          <p:cNvSpPr>
+            <a:spLocks noGrp="1"/>
+          </p:cNvSpPr>
+          <p:nvPr>
+            <p:ph type="title"/>
+          </p:nvPr>
+        </p:nvSpPr>
+        <p:spPr/>
+        <p:txBody>
+          <a:bodyPr/>
+          <a:lstStyle/>
+          <a:p>
+            <a:pPr lvl="0" indent="0" marL="0">
+              <a:buNone/>
+            </a:pPr>
+            <a:r>
+              <a:rPr/>
+              <a:t>에이전트 트랙</a:t>
+            </a:r>
+          </a:p>
+        </p:txBody>
+      </p:sp>
+      <p:graphicFrame>
+        <p:nvGraphicFramePr>
+          <p:cNvPr id="6" name="Content Placeholder 5"/>
+          <p:cNvGraphicFramePr>
+            <a:graphicFrameLocks noGrp="1"/>
+          </p:cNvGraphicFramePr>
+          <p:nvPr>
+            <p:ph idx="1"/>
+          </p:nvPr>
+        </p:nvGraphicFramePr>
+        <p:xfrm>
+          <a:off x="838200" y="1816100"/>
+          <a:ext cx="10515600" cy="4343400"/>
+        </p:xfrm>
+        <a:graphic>
+          <a:graphicData uri="http://schemas.openxmlformats.org/drawingml/2006/table">
+            <a:tbl>
+              <a:tblPr firstRow="1" bandRow="1">
+                <a:tableStyleId>{5C22544A-7EE6-4342-B048-85BDC9FD1C3A}</a:tableStyleId>
+              </a:tblPr>
+              <a:tblGrid>
+                <a:gridCol w="3505200"/>
+                <a:gridCol w="3505200"/>
+                <a:gridCol w="3505200"/>
+              </a:tblGrid>
+              <a:tr h="0">
+                <a:tc>
+                  <a:txBody>
+                    <a:bodyPr/>
+                    <a:lstStyle/>
+                    <a:p>
+                      <a:pPr lvl="0" indent="0" marL="0">
+                        <a:buNone/>
+                      </a:pPr>
+                      <a:r>
+                        <a:rPr/>
+                        <a:t>조건</a:t>
+                      </a:r>
+                    </a:p>
+                  </a:txBody>
+                  <a:tcPr/>
+                </a:tc>
+                <a:tc>
+                  <a:txBody>
+                    <a:bodyPr/>
+                    <a:lstStyle/>
+                    <a:p>
+                      <a:pPr lvl="0" indent="0" marL="0">
+                        <a:buNone/>
+                      </a:pPr>
+                      <a:r>
+                        <a:rPr/>
+                        <a:t>입력</a:t>
+                      </a:r>
+                    </a:p>
+                  </a:txBody>
+                  <a:tcPr/>
+                </a:tc>
+                <a:tc>
+                  <a:txBody>
+                    <a:bodyPr/>
+                    <a:lstStyle/>
+                    <a:p>
+                      <a:pPr lvl="0" indent="0" marL="0">
+                        <a:buNone/>
+                      </a:pPr>
+                      <a:r>
+                        <a:rPr/>
+                        <a:t>출력 (JSON)</a:t>
+                      </a:r>
+                    </a:p>
+                  </a:txBody>
+                  <a:tcPr/>
+                </a:tc>
+              </a:tr>
+              <a:tr h="0">
+                <a:tc>
+                  <a:txBody>
+                    <a:bodyPr/>
+                    <a:lstStyle/>
+                    <a:p>
+                      <a:pPr lvl="0" indent="0" marL="0">
+                        <a:buNone/>
+                      </a:pPr>
+                      <a:r>
+                        <a:rPr/>
+                        <a:t>B. Zero-shot LLM</a:t>
+                      </a:r>
+                    </a:p>
+                  </a:txBody>
+                </a:tc>
+                <a:tc>
+                  <a:txBody>
+                    <a:bodyPr/>
+                    <a:lstStyle/>
+                    <a:p>
+                      <a:pPr lvl="0" indent="0" marL="0">
+                        <a:buNone/>
+                      </a:pPr>
+                      <a:r>
+                        <a:rPr/>
+                        <a:t>서열 + SMILES, 도구 없음</a:t>
+                      </a:r>
+                    </a:p>
+                  </a:txBody>
+                </a:tc>
+                <a:tc>
+                  <a:txBody>
+                    <a:bodyPr/>
+                    <a:lstStyle/>
+                    <a:p>
+                      <a:pPr lvl="0" indent="0" marL="0">
+                        <a:buNone/>
+                      </a:pPr>
+                      <a:r>
+                        <a:rPr>
+                          <a:latin typeface="Courier"/>
+                        </a:rPr>
+                        <a:t>binds</a:t>
+                      </a:r>
+                      <a:r>
+                        <a:rPr/>
+                        <a:t>, </a:t>
+                      </a:r>
+                      <a:r>
+                        <a:rPr>
+                          <a:latin typeface="Courier"/>
+                        </a:rPr>
+                        <a:t>confidence</a:t>
+                      </a:r>
+                      <a:r>
+                        <a:rPr/>
+                        <a:t>, </a:t>
+                      </a:r>
+                      <a:r>
+                        <a:rPr>
+                          <a:latin typeface="Courier"/>
+                        </a:rPr>
+                        <a:t>pAffinity</a:t>
+                      </a:r>
+                      <a:r>
+                        <a:rPr/>
+                        <a:t>, </a:t>
+                      </a:r>
+                      <a:r>
+                        <a:rPr>
+                          <a:latin typeface="Courier"/>
+                        </a:rPr>
+                        <a:t>reasoning</a:t>
+                      </a:r>
+                    </a:p>
+                  </a:txBody>
+                </a:tc>
+              </a:tr>
+              <a:tr h="0">
+                <a:tc>
+                  <a:txBody>
+                    <a:bodyPr/>
+                    <a:lstStyle/>
+                    <a:p>
+                      <a:pPr lvl="0" indent="0" marL="0">
+                        <a:buNone/>
+                      </a:pPr>
+                      <a:r>
+                        <a:rPr/>
+                        <a:t>C. Agent</a:t>
+                      </a:r>
+                    </a:p>
+                  </a:txBody>
+                </a:tc>
+                <a:tc>
+                  <a:txBody>
+                    <a:bodyPr/>
+                    <a:lstStyle/>
+                    <a:p>
+                      <a:pPr lvl="0" indent="0" marL="0">
+                        <a:buNone/>
+                      </a:pPr>
+                      <a:r>
+                        <a:rPr/>
+                        <a:t>서열 + SMILES, ToolUniverse MCP 도구</a:t>
+                      </a:r>
+                    </a:p>
+                  </a:txBody>
+                </a:tc>
+                <a:tc>
+                  <a:txBody>
+                    <a:bodyPr/>
+                    <a:lstStyle/>
+                    <a:p>
+                      <a:pPr lvl="0" indent="0" marL="0">
+                        <a:buNone/>
+                      </a:pPr>
+                      <a:r>
+                        <a:rPr/>
+                        <a:t>B 필드 + </a:t>
+                      </a:r>
+                      <a:r>
+                        <a:rPr>
+                          <a:latin typeface="Courier"/>
+                        </a:rPr>
+                        <a:t>identified_target</a:t>
+                      </a:r>
+                      <a:r>
+                        <a:rPr/>
+                        <a:t>, </a:t>
+                      </a:r>
+                      <a:r>
+                        <a:rPr>
+                          <a:latin typeface="Courier"/>
+                        </a:rPr>
+                        <a:t>direct_measurement_found</a:t>
+                      </a:r>
+                      <a:r>
+                        <a:rPr/>
+                        <a:t>, </a:t>
+                      </a:r>
+                      <a:r>
+                        <a:rPr>
+                          <a:latin typeface="Courier"/>
+                        </a:rPr>
+                        <a:t>evidence</a:t>
+                      </a:r>
+                    </a:p>
+                  </a:txBody>
+                </a:tc>
+              </a:tr>
+              <a:tr h="0">
+                <a:tc>
+                  <a:txBody>
+                    <a:bodyPr/>
+                    <a:lstStyle/>
+                    <a:p>
+                      <a:pPr lvl="0" indent="0" marL="0">
+                        <a:buNone/>
+                      </a:pPr>
+                      <a:r>
+                        <a:rPr/>
+                        <a:t>D. Agent + 기권</a:t>
+                      </a:r>
+                    </a:p>
+                  </a:txBody>
+                </a:tc>
+                <a:tc>
+                  <a:txBody>
+                    <a:bodyPr/>
+                    <a:lstStyle/>
+                    <a:p>
+                      <a:pPr lvl="0" indent="0" marL="0">
+                        <a:buNone/>
+                      </a:pPr>
+                      <a:r>
+                        <a:rPr/>
+                        <a:t>C와 같음, 기권 허용</a:t>
+                      </a:r>
+                    </a:p>
+                  </a:txBody>
+                </a:tc>
+                <a:tc>
+                  <a:txBody>
+                    <a:bodyPr/>
+                    <a:lstStyle/>
+                    <a:p>
+                      <a:pPr lvl="0" indent="0" marL="0">
+                        <a:buNone/>
+                      </a:pPr>
+                      <a:r>
+                        <a:rPr/>
+                        <a:t>C 필드 + </a:t>
+                      </a:r>
+                      <a:r>
+                        <a:rPr>
+                          <a:latin typeface="Courier"/>
+                        </a:rPr>
+                        <a:t>abstain</a:t>
+                      </a:r>
+                    </a:p>
+                  </a:txBody>
+                </a:tc>
+              </a:tr>
+              <a:tr h="0">
+                <a:tc>
+                  <a:txBody>
+                    <a:bodyPr/>
+                    <a:lstStyle/>
+                    <a:p>
+                      <a:pPr lvl="0" indent="0" marL="0">
+                        <a:buNone/>
+                      </a:pPr>
+                      <a:r>
+                        <a:rPr/>
+                        <a:t>반복 실행</a:t>
+                      </a:r>
+                    </a:p>
+                  </a:txBody>
+                </a:tc>
+                <a:tc>
+                  <a:txBody>
+                    <a:bodyPr/>
+                    <a:lstStyle/>
+                    <a:p>
+                      <a:pPr lvl="0" indent="0" marL="0">
+                        <a:buNone/>
+                      </a:pPr>
+                      <a:r>
+                        <a:rPr/>
+                        <a:t>같은 쿼리 3회, temperature 0.7</a:t>
+                      </a:r>
+                    </a:p>
+                  </a:txBody>
+                </a:tc>
+                <a:tc>
+                  <a:txBody>
+                    <a:bodyPr/>
+                    <a:lstStyle/>
+                    <a:p>
+                      <a:pPr lvl="0" indent="0" marL="0">
+                        <a:buNone/>
+                      </a:pPr>
+                      <a:r>
+                        <a:rPr/>
+                        <a:t>flip rate, 조건 E용 신뢰도 로그, 토큰·지연·비용</a:t>
+                      </a:r>
+                    </a:p>
+                  </a:txBody>
+                </a:tc>
+              </a:tr>
+              <a:tr h="0">
+                <a:tc>
+                  <a:txBody>
+                    <a:bodyPr/>
+                    <a:lstStyle/>
+                    <a:p>
+                      <a:pPr lvl="0" indent="0" marL="0">
+                        <a:buNone/>
+                      </a:pPr>
+                      <a:r>
+                        <a:rPr/>
+                        <a:t>교란 감사</a:t>
+                      </a:r>
+                    </a:p>
+                  </a:txBody>
+                </a:tc>
+                <a:tc>
+                  <a:txBody>
+                    <a:bodyPr/>
+                    <a:lstStyle/>
+                    <a:p>
+                      <a:pPr lvl="0" indent="0" marL="0">
+                        <a:buNone/>
+                      </a:pPr>
+                      <a:r>
+                        <a:rPr/>
+                        <a:t>도구 출력에 오류 4종 주입 (단위, 엔트리, 동일성, 식별자)</a:t>
+                      </a:r>
+                    </a:p>
+                  </a:txBody>
+                </a:tc>
+                <a:tc>
+                  <a:txBody>
+                    <a:bodyPr/>
+                    <a:lstStyle/>
+                    <a:p>
+                      <a:pPr lvl="0" indent="0" marL="0">
+                        <a:buNone/>
+                      </a:pPr>
+                      <a:r>
+                        <a:rPr/>
+                        <a:t>교란 탐지율</a:t>
+                      </a:r>
+                    </a:p>
+                  </a:txBody>
+                </a:tc>
+              </a:tr>
+            </a:tbl>
+          </a:graphicData>
+        </a:graphic>
+      </p:graphicFrame>
+    </p:spTree>
+  </p:cSld>
+</p:sld>
+</file>
+
+<file path=ppt/slides/slide26.xml><?xml version="1.0" encoding="utf-8"?>
 <p:sld xmlns:a="http://schemas.openxmlformats.org/drawingml/2006/main" xmlns:r="http://schemas.openxmlformats.org/officeDocument/2006/relationships" xmlns:p="http://schemas.openxmlformats.org/presentationml/2006/main">
   <p:cSld>
     <p:spTree>
@@ -6526,7 +6756,7 @@
 </p:sld>
 </file>
 
-<file path=ppt/slides/slide25.xml><?xml version="1.0" encoding="utf-8"?>
+<file path=ppt/slides/slide27.xml><?xml version="1.0" encoding="utf-8"?>
 <p:sld xmlns:a="http://schemas.openxmlformats.org/drawingml/2006/main" xmlns:r="http://schemas.openxmlformats.org/officeDocument/2006/relationships" xmlns:p="http://schemas.openxmlformats.org/presentationml/2006/main">
   <p:cSld>
     <p:spTree>
@@ -6630,11 +6860,11 @@
             <a:pPr lvl="0"/>
             <a:r>
               <a:rPr/>
-              <a:t>다음 주 발표할 논문 올리기</a:t>
-            </a:r>
-          </a:p>
-          <a:p>
-            <a:pPr lvl="0"/>
+              <a:t>HW: 다음 주 발표할 논문 정리해서 자료 올리기</a:t>
+            </a:r>
+          </a:p>
+          <a:p>
+            <a:pPr lvl="1"/>
             <a:r>
               <a:rPr/>
               <a:t>논문 → 실행: </a:t>
@@ -6653,7 +6883,7 @@
 </p:sld>
 </file>
 
-<file path=ppt/slides/slide26.xml><?xml version="1.0" encoding="utf-8"?>
+<file path=ppt/slides/slide28.xml><?xml version="1.0" encoding="utf-8"?>
 <p:sld xmlns:a="http://schemas.openxmlformats.org/drawingml/2006/main" xmlns:r="http://schemas.openxmlformats.org/officeDocument/2006/relationships" xmlns:p="http://schemas.openxmlformats.org/presentationml/2006/main">
   <p:cSld>
     <p:spTree>
@@ -6776,7 +7006,7 @@
 </p:sld>
 </file>
 
-<file path=ppt/slides/slide27.xml><?xml version="1.0" encoding="utf-8"?>
+<file path=ppt/slides/slide29.xml><?xml version="1.0" encoding="utf-8"?>
 <p:sld xmlns:a="http://schemas.openxmlformats.org/drawingml/2006/main" xmlns:r="http://schemas.openxmlformats.org/officeDocument/2006/relationships" xmlns:p="http://schemas.openxmlformats.org/presentationml/2006/main">
   <p:cSld>
     <p:spTree>
@@ -6908,7 +7138,7 @@
             <a:pPr lvl="0"/>
             <a:r>
               <a:rPr/>
-              <a:t>카메라 on 필수 (얼굴이 보이지 않아도 돼)</a:t>
+              <a:t>카메라 on 필수</a:t>
             </a:r>
           </a:p>
         </p:txBody>
@@ -6940,7 +7170,7 @@
           <p:cNvPr id="2" name="Title 1">
             <a:extLst>
               <a:ext uri="{FF2B5EF4-FFF2-40B4-BE49-F238E27FC236}">
-                <a16:creationId xmlns:a16="http://schemas.microsoft.com/office/drawing/2014/main" id="{60DC0D0C-9A5E-1DC8-B48D-462EC113779B}"/>
+                <a16:creationId xmlns:a16="http://schemas.microsoft.com/office/drawing/2014/main" id="{C9CE818D-09AE-4CD2-3C65-237AD773CD9F}"/>
               </a:ext>
             </a:extLst>
           </p:cNvPr>
@@ -6951,12 +7181,7 @@
             <p:ph type="title"/>
           </p:nvPr>
         </p:nvSpPr>
-        <p:spPr>
-          <a:xfrm>
-            <a:off x="831850" y="1709738"/>
-            <a:ext cx="10515600" cy="2852737"/>
-          </a:xfrm>
-        </p:spPr>
+        <p:spPr/>
         <p:txBody>
           <a:bodyPr/>
           <a:lstStyle/>
@@ -6966,7 +7191,68 @@
             </a:pPr>
             <a:r>
               <a:rPr/>
-              <a:t>Ice breaking</a:t>
+              <a:t>자기소개</a:t>
+            </a:r>
+          </a:p>
+        </p:txBody>
+      </p:sp>
+      <p:sp>
+        <p:nvSpPr>
+          <p:cNvPr id="3" name="Content Placeholder 2">
+            <a:extLst>
+              <a:ext uri="{FF2B5EF4-FFF2-40B4-BE49-F238E27FC236}">
+                <a16:creationId xmlns:a16="http://schemas.microsoft.com/office/drawing/2014/main" id="{CF466120-0A55-3491-F9FC-FA77E459C46D}"/>
+              </a:ext>
+            </a:extLst>
+          </p:cNvPr>
+          <p:cNvSpPr>
+            <a:spLocks noGrp="1"/>
+          </p:cNvSpPr>
+          <p:nvPr>
+            <p:ph idx="1"/>
+          </p:nvPr>
+        </p:nvSpPr>
+        <p:spPr/>
+        <p:txBody>
+          <a:bodyPr/>
+          <a:lstStyle/>
+          <a:p>
+            <a:pPr lvl="0" indent="0" marL="0">
+              <a:buNone/>
+            </a:pPr>
+            <a:r>
+              <a:rPr b="1"/>
+              <a:t>Yeji Bae</a:t>
+            </a:r>
+          </a:p>
+          <a:p>
+            <a:pPr lvl="0" indent="0" marL="0">
+              <a:buNone/>
+            </a:pPr>
+            <a:r>
+              <a:rPr/>
+              <a:t>Data Scientist / Computational Biologist at Seattle Children’s Hospital &amp; Research Institute</a:t>
+            </a:r>
+          </a:p>
+          <a:p>
+            <a:pPr lvl="0"/>
+            <a:r>
+              <a:rPr/>
+              <a:t>Multi-omics Analysis</a:t>
+            </a:r>
+          </a:p>
+          <a:p>
+            <a:pPr lvl="0"/>
+            <a:r>
+              <a:rPr/>
+              <a:t>DL model development (fine-tuning)</a:t>
+            </a:r>
+          </a:p>
+          <a:p>
+            <a:pPr lvl="0"/>
+            <a:r>
+              <a:rPr/>
+              <a:t>Agent Engineering</a:t>
             </a:r>
           </a:p>
         </p:txBody>
@@ -7019,7 +7305,7 @@
             </a:pPr>
             <a:r>
               <a:rPr/>
-              <a:t>자기소개</a:t>
+              <a:t>Abstain-DTI를 위한 온보딩</a:t>
             </a:r>
           </a:p>
         </p:txBody>
@@ -7045,42 +7331,24 @@
           <a:bodyPr/>
           <a:lstStyle/>
           <a:p>
-            <a:pPr lvl="0" indent="0" marL="0">
-              <a:buNone/>
-            </a:pPr>
-            <a:r>
-              <a:rPr b="1"/>
-              <a:t>Yeji Bae</a:t>
-            </a:r>
-          </a:p>
-          <a:p>
-            <a:pPr lvl="0" indent="0" marL="0">
-              <a:buNone/>
-            </a:pPr>
-            <a:r>
-              <a:rPr/>
-              <a:t>Data Scientist / Computational Biologist at Seattle Children’s Hospital &amp; Research Institute</a:t>
-            </a:r>
-          </a:p>
-          <a:p>
             <a:pPr lvl="0"/>
             <a:r>
               <a:rPr/>
-              <a:t>Multi-omics Analysis</a:t>
+              <a:t>문제 정의 :</a:t>
             </a:r>
           </a:p>
           <a:p>
             <a:pPr lvl="0"/>
             <a:r>
               <a:rPr/>
-              <a:t>DL model development (fine tuning)</a:t>
+              <a:t>난이도 정의 :</a:t>
             </a:r>
           </a:p>
           <a:p>
             <a:pPr lvl="0"/>
             <a:r>
               <a:rPr/>
-              <a:t>Agent Engineering</a:t>
+              <a:t>INPUT &amp; OUTPUT :</a:t>
             </a:r>
           </a:p>
         </p:txBody>
@@ -7112,7 +7380,7 @@
           <p:cNvPr id="2" name="Title 1">
             <a:extLst>
               <a:ext uri="{FF2B5EF4-FFF2-40B4-BE49-F238E27FC236}">
-                <a16:creationId xmlns:a16="http://schemas.microsoft.com/office/drawing/2014/main" id="{C9CE818D-09AE-4CD2-3C65-237AD773CD9F}"/>
+                <a16:creationId xmlns:a16="http://schemas.microsoft.com/office/drawing/2014/main" id="{60DC0D0C-9A5E-1DC8-B48D-462EC113779B}"/>
               </a:ext>
             </a:extLst>
           </p:cNvPr>
@@ -7123,7 +7391,12 @@
             <p:ph type="title"/>
           </p:nvPr>
         </p:nvSpPr>
-        <p:spPr/>
+        <p:spPr>
+          <a:xfrm>
+            <a:off x="831850" y="1709738"/>
+            <a:ext cx="10515600" cy="2852737"/>
+          </a:xfrm>
+        </p:spPr>
         <p:txBody>
           <a:bodyPr/>
           <a:lstStyle/>
@@ -7133,50 +7406,7 @@
             </a:pPr>
             <a:r>
               <a:rPr/>
-              <a:t>Abstain-DTI를 위한 온보딩</a:t>
-            </a:r>
-          </a:p>
-        </p:txBody>
-      </p:sp>
-      <p:sp>
-        <p:nvSpPr>
-          <p:cNvPr id="3" name="Content Placeholder 2">
-            <a:extLst>
-              <a:ext uri="{FF2B5EF4-FFF2-40B4-BE49-F238E27FC236}">
-                <a16:creationId xmlns:a16="http://schemas.microsoft.com/office/drawing/2014/main" id="{CF466120-0A55-3491-F9FC-FA77E459C46D}"/>
-              </a:ext>
-            </a:extLst>
-          </p:cNvPr>
-          <p:cNvSpPr>
-            <a:spLocks noGrp="1"/>
-          </p:cNvSpPr>
-          <p:nvPr>
-            <p:ph idx="1"/>
-          </p:nvPr>
-        </p:nvSpPr>
-        <p:spPr/>
-        <p:txBody>
-          <a:bodyPr/>
-          <a:lstStyle/>
-          <a:p>
-            <a:pPr lvl="0"/>
-            <a:r>
-              <a:rPr/>
               <a:t>문제 정의</a:t>
-            </a:r>
-          </a:p>
-          <a:p>
-            <a:pPr lvl="0"/>
-            <a:r>
-              <a:rPr/>
-              <a:t>난이도 정의</a:t>
-            </a:r>
-          </a:p>
-          <a:p>
-            <a:pPr lvl="0"/>
-            <a:r>
-              <a:rPr/>
-              <a:t>INPUT &amp; OUTPUT</a:t>
             </a:r>
           </a:p>
         </p:txBody>
@@ -7208,7 +7438,7 @@
           <p:cNvPr id="2" name="Title 1">
             <a:extLst>
               <a:ext uri="{FF2B5EF4-FFF2-40B4-BE49-F238E27FC236}">
-                <a16:creationId xmlns:a16="http://schemas.microsoft.com/office/drawing/2014/main" id="{60DC0D0C-9A5E-1DC8-B48D-462EC113779B}"/>
+                <a16:creationId xmlns:a16="http://schemas.microsoft.com/office/drawing/2014/main" id="{1A5592C5-AEA2-D627-F76B-35C7AD5ED253}"/>
               </a:ext>
             </a:extLst>
           </p:cNvPr>
@@ -7221,8 +7451,8 @@
         </p:nvSpPr>
         <p:spPr>
           <a:xfrm>
-            <a:off x="831850" y="1709738"/>
-            <a:ext cx="10515600" cy="2852737"/>
+            <a:off x="839788" y="457200"/>
+            <a:ext cx="3932237" cy="1600200"/>
           </a:xfrm>
         </p:spPr>
         <p:txBody>
@@ -7234,11 +7464,178 @@
             </a:pPr>
             <a:r>
               <a:rPr/>
-              <a:t>문제 정의</a:t>
-            </a:r>
-          </a:p>
-        </p:txBody>
-      </p:sp>
+              <a:t>무엇이 문제인가</a:t>
+            </a:r>
+          </a:p>
+        </p:txBody>
+      </p:sp>
+      <p:sp>
+        <p:nvSpPr>
+          <p:cNvPr id="4" name="Text Placeholder 3">
+            <a:extLst>
+              <a:ext uri="{FF2B5EF4-FFF2-40B4-BE49-F238E27FC236}">
+                <a16:creationId xmlns:a16="http://schemas.microsoft.com/office/drawing/2014/main" id="{67344C6D-89EA-24AC-1FF8-F95BD1763393}"/>
+              </a:ext>
+            </a:extLst>
+          </p:cNvPr>
+          <p:cNvSpPr>
+            <a:spLocks noGrp="1"/>
+          </p:cNvSpPr>
+          <p:nvPr>
+            <p:ph idx="2" sz="half" type="body"/>
+          </p:nvPr>
+        </p:nvSpPr>
+        <p:spPr/>
+        <p:txBody>
+          <a:bodyPr/>
+          <a:lstStyle/>
+          <a:p>
+            <a:pPr lvl="0" indent="0" marL="0">
+              <a:buNone/>
+            </a:pPr>
+            <a:r>
+              <a:rPr/>
+              <a:t>“LLM이 DTI 예측을 못 하는데도 그냥 답한다”에는 두 상황이 섞여 있습니다.</a:t>
+            </a:r>
+          </a:p>
+        </p:txBody>
+      </p:sp>
+      <p:graphicFrame>
+        <p:nvGraphicFramePr>
+          <p:cNvPr id="6" name="Content Placeholder 5"/>
+          <p:cNvGraphicFramePr>
+            <a:graphicFrameLocks noGrp="1"/>
+          </p:cNvGraphicFramePr>
+          <p:nvPr>
+            <p:ph idx="1"/>
+          </p:nvPr>
+        </p:nvGraphicFramePr>
+        <p:xfrm>
+          <a:off x="5181600" y="977900"/>
+          <a:ext cx="6172200" cy="4864100"/>
+        </p:xfrm>
+        <a:graphic>
+          <a:graphicData uri="http://schemas.openxmlformats.org/drawingml/2006/table">
+            <a:tbl>
+              <a:tblPr firstRow="1" bandRow="1">
+                <a:tableStyleId>{5C22544A-7EE6-4342-B048-85BDC9FD1C3A}</a:tableStyleId>
+              </a:tblPr>
+              <a:tblGrid>
+                <a:gridCol w="3086100"/>
+                <a:gridCol w="3086100"/>
+              </a:tblGrid>
+              <a:tr h="0">
+                <a:tc>
+                  <a:txBody>
+                    <a:bodyPr/>
+                    <a:lstStyle/>
+                    <a:p>
+                      <a:pPr lvl="0" indent="0" marL="0">
+                        <a:buNone/>
+                      </a:pPr>
+                      <a:r>
+                        <a:rPr/>
+                        <a:t>상황</a:t>
+                      </a:r>
+                    </a:p>
+                  </a:txBody>
+                  <a:tcPr/>
+                </a:tc>
+                <a:tc>
+                  <a:txBody>
+                    <a:bodyPr/>
+                    <a:lstStyle/>
+                    <a:p>
+                      <a:pPr lvl="0" indent="0" marL="0">
+                        <a:buNone/>
+                      </a:pPr>
+                      <a:r>
+                        <a:rPr/>
+                        <a:t>문제인가</a:t>
+                      </a:r>
+                    </a:p>
+                  </a:txBody>
+                  <a:tcPr/>
+                </a:tc>
+              </a:tr>
+              <a:tr h="0">
+                <a:tc>
+                  <a:txBody>
+                    <a:bodyPr/>
+                    <a:lstStyle/>
+                    <a:p>
+                      <a:pPr lvl="0" indent="0" marL="0">
+                        <a:buNone/>
+                      </a:pPr>
+                      <a:r>
+                        <a:rPr/>
+                        <a:t>약이 타겟에 붙지 않는다</a:t>
+                      </a:r>
+                    </a:p>
+                  </a:txBody>
+                </a:tc>
+                <a:tc>
+                  <a:txBody>
+                    <a:bodyPr/>
+                    <a:lstStyle/>
+                    <a:p>
+                      <a:pPr lvl="0" indent="0" marL="0">
+                        <a:buNone/>
+                      </a:pPr>
+                      <a:r>
+                        <a:rPr/>
+                        <a:t>아닙니다. 정답이 </a:t>
+                      </a:r>
+                      <a:r>
+                        <a:rPr>
+                          <a:latin typeface="Courier"/>
+                        </a:rPr>
+                        <a:t>binds = false</a:t>
+                      </a:r>
+                      <a:r>
+                        <a:rPr/>
+                        <a:t>일 뿐입니다</a:t>
+                      </a:r>
+                    </a:p>
+                  </a:txBody>
+                </a:tc>
+              </a:tr>
+              <a:tr h="0">
+                <a:tc>
+                  <a:txBody>
+                    <a:bodyPr/>
+                    <a:lstStyle/>
+                    <a:p>
+                      <a:pPr lvl="0" indent="0" marL="0">
+                        <a:buNone/>
+                      </a:pPr>
+                      <a:r>
+                        <a:rPr/>
+                        <a:t>답할 근거가 없는 입력에 쉬운 입력과 같은 신뢰도로 답한다</a:t>
+                      </a:r>
+                    </a:p>
+                  </a:txBody>
+                </a:tc>
+                <a:tc>
+                  <a:txBody>
+                    <a:bodyPr/>
+                    <a:lstStyle/>
+                    <a:p>
+                      <a:pPr lvl="0" indent="0" marL="0">
+                        <a:buNone/>
+                      </a:pPr>
+                      <a:r>
+                        <a:rPr/>
+                        <a:t>문제입니다</a:t>
+                      </a:r>
+                    </a:p>
+                  </a:txBody>
+                </a:tc>
+              </a:tr>
+            </a:tbl>
+          </a:graphicData>
+        </a:graphic>
+      </p:graphicFrame>
     </p:spTree>
   </p:cSld>
 </p:sld>
@@ -7263,54 +7660,18 @@
       </p:grpSpPr>
       <p:sp>
         <p:nvSpPr>
-          <p:cNvPr id="2" name="Title 1">
-            <a:extLst>
-              <a:ext uri="{FF2B5EF4-FFF2-40B4-BE49-F238E27FC236}">
-                <a16:creationId xmlns:a16="http://schemas.microsoft.com/office/drawing/2014/main" id="{1A5592C5-AEA2-D627-F76B-35C7AD5ED253}"/>
-              </a:ext>
-            </a:extLst>
-          </p:cNvPr>
-          <p:cNvSpPr>
-            <a:spLocks noGrp="1"/>
-          </p:cNvSpPr>
-          <p:nvPr>
-            <p:ph type="title"/>
-          </p:nvPr>
-        </p:nvSpPr>
-        <p:spPr>
-          <a:xfrm>
-            <a:off x="839788" y="457200"/>
-            <a:ext cx="3932237" cy="1600200"/>
-          </a:xfrm>
-        </p:spPr>
-        <p:txBody>
-          <a:bodyPr/>
-          <a:lstStyle/>
-          <a:p>
-            <a:pPr lvl="0" indent="0" marL="0">
-              <a:buNone/>
-            </a:pPr>
-            <a:r>
-              <a:rPr/>
-              <a:t>무엇이 문제인가</a:t>
-            </a:r>
-          </a:p>
-        </p:txBody>
-      </p:sp>
-      <p:sp>
-        <p:nvSpPr>
-          <p:cNvPr id="4" name="Text Placeholder 3">
-            <a:extLst>
-              <a:ext uri="{FF2B5EF4-FFF2-40B4-BE49-F238E27FC236}">
-                <a16:creationId xmlns:a16="http://schemas.microsoft.com/office/drawing/2014/main" id="{67344C6D-89EA-24AC-1FF8-F95BD1763393}"/>
-              </a:ext>
-            </a:extLst>
-          </p:cNvPr>
-          <p:cNvSpPr>
-            <a:spLocks noGrp="1"/>
-          </p:cNvSpPr>
-          <p:nvPr>
-            <p:ph idx="2" sz="half" type="body"/>
+          <p:cNvPr id="3" name="Content Placeholder 2">
+            <a:extLst>
+              <a:ext uri="{FF2B5EF4-FFF2-40B4-BE49-F238E27FC236}">
+                <a16:creationId xmlns:a16="http://schemas.microsoft.com/office/drawing/2014/main" id="{CF466120-0A55-3491-F9FC-FA77E459C46D}"/>
+              </a:ext>
+            </a:extLst>
+          </p:cNvPr>
+          <p:cNvSpPr>
+            <a:spLocks noGrp="1"/>
+          </p:cNvSpPr>
+          <p:nvPr>
+            <p:ph idx="1"/>
           </p:nvPr>
         </p:nvSpPr>
         <p:spPr/>
@@ -7318,152 +7679,21 @@
           <a:bodyPr/>
           <a:lstStyle/>
           <a:p>
-            <a:pPr lvl="0" indent="0" marL="0">
-              <a:buNone/>
-            </a:pPr>
-            <a:r>
-              <a:rPr/>
-              <a:t>“LLM이 DTI 예측을 못 하는데도 그냥 답한다”에는 두 상황이 섞여 있습니다.</a:t>
-            </a:r>
-          </a:p>
-        </p:txBody>
-      </p:sp>
-      <p:graphicFrame>
-        <p:nvGraphicFramePr>
-          <p:cNvPr id="6" name="Content Placeholder 5"/>
-          <p:cNvGraphicFramePr>
-            <a:graphicFrameLocks noGrp="1"/>
-          </p:cNvGraphicFramePr>
-          <p:nvPr>
-            <p:ph idx="1"/>
-          </p:nvPr>
-        </p:nvGraphicFramePr>
-        <p:xfrm>
-          <a:off x="5181600" y="977900"/>
-          <a:ext cx="6172200" cy="4864100"/>
-        </p:xfrm>
-        <a:graphic>
-          <a:graphicData uri="http://schemas.openxmlformats.org/drawingml/2006/table">
-            <a:tbl>
-              <a:tblPr firstRow="1" bandRow="1">
-                <a:tableStyleId>{5C22544A-7EE6-4342-B048-85BDC9FD1C3A}</a:tableStyleId>
-              </a:tblPr>
-              <a:tblGrid>
-                <a:gridCol w="3086100"/>
-                <a:gridCol w="3086100"/>
-              </a:tblGrid>
-              <a:tr h="0">
-                <a:tc>
-                  <a:txBody>
-                    <a:bodyPr/>
-                    <a:lstStyle/>
-                    <a:p>
-                      <a:pPr lvl="0" indent="0" marL="0">
-                        <a:buNone/>
-                      </a:pPr>
-                      <a:r>
-                        <a:rPr/>
-                        <a:t>상황</a:t>
-                      </a:r>
-                    </a:p>
-                  </a:txBody>
-                  <a:tcPr/>
-                </a:tc>
-                <a:tc>
-                  <a:txBody>
-                    <a:bodyPr/>
-                    <a:lstStyle/>
-                    <a:p>
-                      <a:pPr lvl="0" indent="0" marL="0">
-                        <a:buNone/>
-                      </a:pPr>
-                      <a:r>
-                        <a:rPr/>
-                        <a:t>문제인가</a:t>
-                      </a:r>
-                    </a:p>
-                  </a:txBody>
-                  <a:tcPr/>
-                </a:tc>
-              </a:tr>
-              <a:tr h="0">
-                <a:tc>
-                  <a:txBody>
-                    <a:bodyPr/>
-                    <a:lstStyle/>
-                    <a:p>
-                      <a:pPr lvl="0" indent="0" marL="0">
-                        <a:buNone/>
-                      </a:pPr>
-                      <a:r>
-                        <a:rPr/>
-                        <a:t>약이 타겟에 붙지 않는다</a:t>
-                      </a:r>
-                    </a:p>
-                  </a:txBody>
-                </a:tc>
-                <a:tc>
-                  <a:txBody>
-                    <a:bodyPr/>
-                    <a:lstStyle/>
-                    <a:p>
-                      <a:pPr lvl="0" indent="0" marL="0">
-                        <a:buNone/>
-                      </a:pPr>
-                      <a:r>
-                        <a:rPr/>
-                        <a:t>아닙니다. 정답이 </a:t>
-                      </a:r>
-                      <a:r>
-                        <a:rPr>
-                          <a:latin typeface="Courier"/>
-                        </a:rPr>
-                        <a:t>binds = false</a:t>
-                      </a:r>
-                      <a:r>
-                        <a:rPr/>
-                        <a:t>일 뿐입니다</a:t>
-                      </a:r>
-                    </a:p>
-                  </a:txBody>
-                </a:tc>
-              </a:tr>
-              <a:tr h="0">
-                <a:tc>
-                  <a:txBody>
-                    <a:bodyPr/>
-                    <a:lstStyle/>
-                    <a:p>
-                      <a:pPr lvl="0" indent="0" marL="0">
-                        <a:buNone/>
-                      </a:pPr>
-                      <a:r>
-                        <a:rPr/>
-                        <a:t>답할 근거가 없는 입력에 쉬운 입력과 같은 신뢰도로 답한다</a:t>
-                      </a:r>
-                    </a:p>
-                  </a:txBody>
-                </a:tc>
-                <a:tc>
-                  <a:txBody>
-                    <a:bodyPr/>
-                    <a:lstStyle/>
-                    <a:p>
-                      <a:pPr lvl="0" indent="0" marL="0">
-                        <a:buNone/>
-                      </a:pPr>
-                      <a:r>
-                        <a:rPr/>
-                        <a:t>문제입니다</a:t>
-                      </a:r>
-                    </a:p>
-                  </a:txBody>
-                </a:tc>
-              </a:tr>
-            </a:tbl>
-          </a:graphicData>
-        </a:graphic>
-      </p:graphicFrame>
+            <a:pPr lvl="0"/>
+            <a:r>
+              <a:rPr/>
+              <a:t>LLM만의 문제가 아닙니다. 지도학습 모델(A)과 Boltz-2(F)에도 같은 질문을 합니다.</a:t>
+            </a:r>
+          </a:p>
+          <a:p>
+            <a:pPr lvl="0"/>
+            <a:r>
+              <a:rPr/>
+              <a:t>기권 기능이 없어서 생기는 문제도 아닙니다. 신뢰도 점수가 난이도를 담고 있지 않으면, 기권 기능이 있어도 엉뚱한 문항에서 기권합니다.</a:t>
+            </a:r>
+          </a:p>
+        </p:txBody>
+      </p:sp>
     </p:spTree>
   </p:cSld>
 </p:sld>
@@ -7488,6 +7718,37 @@
       </p:grpSpPr>
       <p:sp>
         <p:nvSpPr>
+          <p:cNvPr id="2" name="Title 1">
+            <a:extLst>
+              <a:ext uri="{FF2B5EF4-FFF2-40B4-BE49-F238E27FC236}">
+                <a16:creationId xmlns:a16="http://schemas.microsoft.com/office/drawing/2014/main" id="{C9CE818D-09AE-4CD2-3C65-237AD773CD9F}"/>
+              </a:ext>
+            </a:extLst>
+          </p:cNvPr>
+          <p:cNvSpPr>
+            <a:spLocks noGrp="1"/>
+          </p:cNvSpPr>
+          <p:nvPr>
+            <p:ph type="title"/>
+          </p:nvPr>
+        </p:nvSpPr>
+        <p:spPr/>
+        <p:txBody>
+          <a:bodyPr/>
+          <a:lstStyle/>
+          <a:p>
+            <a:pPr lvl="0" indent="0" marL="0">
+              <a:buNone/>
+            </a:pPr>
+            <a:r>
+              <a:rPr/>
+              <a:t>Problem statement</a:t>
+            </a:r>
+          </a:p>
+        </p:txBody>
+      </p:sp>
+      <p:sp>
+        <p:nvSpPr>
           <p:cNvPr id="3" name="Content Placeholder 2">
             <a:extLst>
               <a:ext uri="{FF2B5EF4-FFF2-40B4-BE49-F238E27FC236}">
@@ -7507,17 +7768,39 @@
           <a:bodyPr/>
           <a:lstStyle/>
           <a:p>
+            <a:pPr lvl="0" indent="0" marL="1270000">
+              <a:buNone/>
+            </a:pPr>
+            <a:r>
+              <a:rPr sz="2000"/>
+              <a:t>DTI 예측기(지도학습 모델이든 LLM 에이전트든)는 입력이 자기가 아는 범위를 벗어나도 신뢰도를 낮추지 않을 수 있다. DTI 불확실성 연구는 random split과 cold split을 비교했을 뿐, 타겟·리간드 신규성이나 근거 가용성 같은 연속적인 난이도로 신뢰도와 기권을 층화하지 않았다. LLM 에이전트의 DTI 신뢰도를 잰 연구는 찾지 못했다.</a:t>
+            </a:r>
+          </a:p>
+          <a:p>
+            <a:pPr lvl="0" indent="0" marL="0">
+              <a:buNone/>
+            </a:pPr>
+            <a:r>
+              <a:rPr b="1"/>
+              <a:t>벤치마크의 질문은 하나입니다.</a:t>
+            </a:r>
+            <a:r>
+              <a:rPr/>
+              <a:t> 신뢰도, 또는 기권 결정이 사전에 정한 난이도 d(x)를 따라가는가?</a:t>
+            </a:r>
+          </a:p>
+          <a:p>
             <a:pPr lvl="0"/>
             <a:r>
               <a:rPr/>
-              <a:t>LLM만의 문제가 아닙니다. 지도학습 모델(A)과 Boltz-2(F)에도 같은 질문을 합니다.</a:t>
+              <a:t>“결함이 있다”가 아니라 “연속적인 난이도로 잰 곳이 없다”고 씁니다. DTI에서 결함의 직접 근거는 아직 없고, 인접 분야의 근거는 뒤에 정리했습니다.</a:t>
             </a:r>
           </a:p>
           <a:p>
             <a:pPr lvl="0"/>
             <a:r>
               <a:rPr/>
-              <a:t>기권 기능이 없어서 생기는 문제도 아닙니다. 신뢰도 점수가 난이도를 담고 있지 않으면, 기권 기능이 있어도 엉뚱한 문항에서 기권합니다.</a:t>
+              <a:t>정답을 보기 전에 정할 수 있는 난이도 좌표가 필요합니다. 다음 절에서 정의합니다.</a:t>
             </a:r>
           </a:p>
         </p:txBody>

</xml_diff>